<commit_message>
Edited Research section. Completed first draft of Feasibility section for Zeis and Ibidi solutions.
</commit_message>
<xml_diff>
--- a/Onboarding_Presentation.pptx
+++ b/Onboarding_Presentation.pptx
@@ -161,7 +161,7 @@
   <pc:docChgLst>
     <pc:chgData name="Joab Kloppers" userId="bcab5db0-8267-4c54-83c3-7ddba1e5c6be" providerId="ADAL" clId="{90E0EE0E-984C-4547-AADC-7DD4534EA015}"/>
     <pc:docChg chg="undo custSel addSld delSld modSld sldOrd">
-      <pc:chgData name="Joab Kloppers" userId="bcab5db0-8267-4c54-83c3-7ddba1e5c6be" providerId="ADAL" clId="{90E0EE0E-984C-4547-AADC-7DD4534EA015}" dt="2026-02-02T07:26:53.099" v="7703" actId="729"/>
+      <pc:chgData name="Joab Kloppers" userId="bcab5db0-8267-4c54-83c3-7ddba1e5c6be" providerId="ADAL" clId="{90E0EE0E-984C-4547-AADC-7DD4534EA015}" dt="2026-02-04T11:15:20.449" v="7731" actId="20577"/>
       <pc:docMkLst>
         <pc:docMk/>
       </pc:docMkLst>
@@ -259,6 +259,21 @@
           <pc:sldMk cId="4259977132" sldId="268"/>
         </pc:sldMkLst>
       </pc:sldChg>
+      <pc:sldChg chg="modSp mod">
+        <pc:chgData name="Joab Kloppers" userId="bcab5db0-8267-4c54-83c3-7ddba1e5c6be" providerId="ADAL" clId="{90E0EE0E-984C-4547-AADC-7DD4534EA015}" dt="2026-02-04T11:15:20.449" v="7731" actId="20577"/>
+        <pc:sldMkLst>
+          <pc:docMk/>
+          <pc:sldMk cId="855215445" sldId="325"/>
+        </pc:sldMkLst>
+        <pc:spChg chg="mod">
+          <ac:chgData name="Joab Kloppers" userId="bcab5db0-8267-4c54-83c3-7ddba1e5c6be" providerId="ADAL" clId="{90E0EE0E-984C-4547-AADC-7DD4534EA015}" dt="2026-02-04T11:15:20.449" v="7731" actId="20577"/>
+          <ac:spMkLst>
+            <pc:docMk/>
+            <pc:sldMk cId="855215445" sldId="325"/>
+            <ac:spMk id="4" creationId="{305E10E9-9AB7-0642-D4C4-DDFDAB7B5B2C}"/>
+          </ac:spMkLst>
+        </pc:spChg>
+      </pc:sldChg>
       <pc:sldChg chg="addSp delSp modSp mod modNotesTx">
         <pc:chgData name="Joab Kloppers" userId="bcab5db0-8267-4c54-83c3-7ddba1e5c6be" providerId="ADAL" clId="{90E0EE0E-984C-4547-AADC-7DD4534EA015}" dt="2026-02-02T07:25:18.742" v="7698" actId="14100"/>
         <pc:sldMkLst>
@@ -287,13 +302,6 @@
         <pc:sldMkLst>
           <pc:docMk/>
           <pc:sldMk cId="487522735" sldId="340"/>
-        </pc:sldMkLst>
-      </pc:sldChg>
-      <pc:sldChg chg="new del">
-        <pc:chgData name="Joab Kloppers" userId="bcab5db0-8267-4c54-83c3-7ddba1e5c6be" providerId="ADAL" clId="{90E0EE0E-984C-4547-AADC-7DD4534EA015}" dt="2026-02-02T07:25:44.227" v="7700" actId="2696"/>
-        <pc:sldMkLst>
-          <pc:docMk/>
-          <pc:sldMk cId="2084258004" sldId="341"/>
         </pc:sldMkLst>
       </pc:sldChg>
     </pc:docChg>
@@ -3336,7 +3344,7 @@
           <a:p>
             <a:fld id="{7FF95820-84BB-3447-8286-60A51307E7F2}" type="datetimeFigureOut">
               <a:rPr lang="en-US" smtClean="0"/>
-              <a:t>2/2/2026</a:t>
+              <a:t>2/4/2026</a:t>
             </a:fld>
             <a:endParaRPr lang="en-US" dirty="0"/>
           </a:p>
@@ -3514,7 +3522,7 @@
           <a:p>
             <a:fld id="{FC08FC54-6AE4-6A4A-9756-823A0F1BE5A6}" type="datetimeFigureOut">
               <a:rPr lang="en-US" smtClean="0"/>
-              <a:t>2/2/2026</a:t>
+              <a:t>2/4/2026</a:t>
             </a:fld>
             <a:endParaRPr lang="en-US" dirty="0"/>
           </a:p>
@@ -8847,7 +8855,15 @@
           <a:p>
             <a:r>
               <a:rPr lang="en-US" dirty="0"/>
-              <a:t>Stage Top Incubator with consideration for a BSL-3 Lab</a:t>
+              <a:t>Stage </a:t>
+            </a:r>
+            <a:r>
+              <a:rPr lang="en-US"/>
+              <a:t>Top bio-containment </a:t>
+            </a:r>
+            <a:r>
+              <a:rPr lang="en-US" dirty="0"/>
+              <a:t>with consideration for a BSL-3 Lab</a:t>
             </a:r>
           </a:p>
         </p:txBody>
@@ -12224,6 +12240,15 @@
 </file>
 
 <file path=customXml/item2.xml><?xml version="1.0" encoding="utf-8"?>
+<?mso-contentType ?>
+<FormTemplates xmlns="http://schemas.microsoft.com/sharepoint/v3/contenttype/forms">
+  <Display>DocumentLibraryForm</Display>
+  <Edit>DocumentLibraryForm</Edit>
+  <New>DocumentLibraryForm</New>
+</FormTemplates>
+</file>
+
+<file path=customXml/item3.xml><?xml version="1.0" encoding="utf-8"?>
 <p:properties xmlns:p="http://schemas.microsoft.com/office/2006/metadata/properties" xmlns:xsi="http://www.w3.org/2001/XMLSchema-instance" xmlns:pc="http://schemas.microsoft.com/office/infopath/2007/PartnerControls">
   <documentManagement>
     <_ip_UnifiedCompliancePolicyUIAction xmlns="http://schemas.microsoft.com/sharepoint/v3" xsi:nil="true"/>
@@ -12241,15 +12266,6 @@
     <MediaServiceKeyPoints xmlns="71af3243-3dd4-4a8d-8c0d-dd76da1f02a5" xsi:nil="true"/>
   </documentManagement>
 </p:properties>
-</file>
-
-<file path=customXml/item3.xml><?xml version="1.0" encoding="utf-8"?>
-<?mso-contentType ?>
-<FormTemplates xmlns="http://schemas.microsoft.com/sharepoint/v3/contenttype/forms">
-  <Display>DocumentLibraryForm</Display>
-  <Edit>DocumentLibraryForm</Edit>
-  <New>DocumentLibraryForm</New>
-</FormTemplates>
 </file>
 
 <file path=customXml/itemProps1.xml><?xml version="1.0" encoding="utf-8"?>
@@ -12274,6 +12290,14 @@
 </file>
 
 <file path=customXml/itemProps2.xml><?xml version="1.0" encoding="utf-8"?>
+<ds:datastoreItem xmlns:ds="http://schemas.openxmlformats.org/officeDocument/2006/customXml" ds:itemID="{DF8397A0-8C35-4EEE-8E61-47C914415B57}">
+  <ds:schemaRefs>
+    <ds:schemaRef ds:uri="http://schemas.microsoft.com/sharepoint/v3/contenttype/forms"/>
+  </ds:schemaRefs>
+</ds:datastoreItem>
+</file>
+
+<file path=customXml/itemProps3.xml><?xml version="1.0" encoding="utf-8"?>
 <ds:datastoreItem xmlns:ds="http://schemas.openxmlformats.org/officeDocument/2006/customXml" ds:itemID="{B881D8D6-8849-400B-8BC9-21D401C7DD06}">
   <ds:schemaRefs>
     <ds:schemaRef ds:uri="http://schemas.microsoft.com/office/2006/metadata/properties"/>
@@ -12285,14 +12309,6 @@
 </ds:datastoreItem>
 </file>
 
-<file path=customXml/itemProps3.xml><?xml version="1.0" encoding="utf-8"?>
-<ds:datastoreItem xmlns:ds="http://schemas.openxmlformats.org/officeDocument/2006/customXml" ds:itemID="{DF8397A0-8C35-4EEE-8E61-47C914415B57}">
-  <ds:schemaRefs>
-    <ds:schemaRef ds:uri="http://schemas.microsoft.com/sharepoint/v3/contenttype/forms"/>
-  </ds:schemaRefs>
-</ds:datastoreItem>
-</file>
-
 <file path=docMetadata/LabelInfo.xml><?xml version="1.0" encoding="utf-8"?>
 <clbl:labelList xmlns:clbl="http://schemas.microsoft.com/office/2020/mipLabelMetadata"/>
 </file>
</xml_diff>

<commit_message>
Completed first draft of specs section, design v1. worked on presentation
</commit_message>
<xml_diff>
--- a/Onboarding_Presentation.pptx
+++ b/Onboarding_Presentation.pptx
@@ -5,25 +5,26 @@
     <p:sldMasterId id="2147483648" r:id="rId4"/>
   </p:sldMasterIdLst>
   <p:notesMasterIdLst>
-    <p:notesMasterId r:id="rId18"/>
+    <p:notesMasterId r:id="rId19"/>
   </p:notesMasterIdLst>
   <p:handoutMasterIdLst>
-    <p:handoutMasterId r:id="rId19"/>
+    <p:handoutMasterId r:id="rId20"/>
   </p:handoutMasterIdLst>
   <p:sldIdLst>
     <p:sldId id="325" r:id="rId5"/>
     <p:sldId id="326" r:id="rId6"/>
     <p:sldId id="264" r:id="rId7"/>
     <p:sldId id="259" r:id="rId8"/>
-    <p:sldId id="257" r:id="rId9"/>
-    <p:sldId id="261" r:id="rId10"/>
-    <p:sldId id="258" r:id="rId11"/>
-    <p:sldId id="263" r:id="rId12"/>
-    <p:sldId id="265" r:id="rId13"/>
-    <p:sldId id="268" r:id="rId14"/>
-    <p:sldId id="267" r:id="rId15"/>
-    <p:sldId id="266" r:id="rId16"/>
-    <p:sldId id="340" r:id="rId17"/>
+    <p:sldId id="341" r:id="rId9"/>
+    <p:sldId id="257" r:id="rId10"/>
+    <p:sldId id="261" r:id="rId11"/>
+    <p:sldId id="258" r:id="rId12"/>
+    <p:sldId id="263" r:id="rId13"/>
+    <p:sldId id="265" r:id="rId14"/>
+    <p:sldId id="268" r:id="rId15"/>
+    <p:sldId id="267" r:id="rId16"/>
+    <p:sldId id="266" r:id="rId17"/>
+    <p:sldId id="340" r:id="rId18"/>
   </p:sldIdLst>
   <p:sldSz cx="12192000" cy="6858000"/>
   <p:notesSz cx="6858000" cy="9144000"/>
@@ -156,12 +157,20 @@
 </p:cmAuthorLst>
 </file>
 
+<file path=ppt/revisionInfo.xml><?xml version="1.0" encoding="utf-8"?>
+<p1510:revInfo xmlns:a="http://schemas.openxmlformats.org/drawingml/2006/main" xmlns:r="http://schemas.openxmlformats.org/officeDocument/2006/relationships" xmlns:p1510="http://schemas.microsoft.com/office/powerpoint/2015/10/main">
+  <p1510:revLst>
+    <p1510:client id="{984C69CA-C70A-4355-93EF-976B02AB29CC}" v="10" dt="2026-02-10T20:26:52.889"/>
+  </p1510:revLst>
+</p1510:revInfo>
+</file>
+
 <file path=ppt/changesInfos/changesInfo1.xml><?xml version="1.0" encoding="utf-8"?>
 <pc:chgInfo xmlns:a="http://schemas.openxmlformats.org/drawingml/2006/main" xmlns:r="http://schemas.openxmlformats.org/officeDocument/2006/relationships" xmlns:ac="http://schemas.microsoft.com/office/drawing/2013/main/command" xmlns:pc="http://schemas.microsoft.com/office/powerpoint/2013/main/command">
   <pc:docChgLst>
     <pc:chgData name="Joab Kloppers" userId="bcab5db0-8267-4c54-83c3-7ddba1e5c6be" providerId="ADAL" clId="{90E0EE0E-984C-4547-AADC-7DD4534EA015}"/>
     <pc:docChg chg="undo custSel addSld delSld modSld sldOrd">
-      <pc:chgData name="Joab Kloppers" userId="bcab5db0-8267-4c54-83c3-7ddba1e5c6be" providerId="ADAL" clId="{90E0EE0E-984C-4547-AADC-7DD4534EA015}" dt="2026-02-04T11:15:20.449" v="7731" actId="20577"/>
+      <pc:chgData name="Joab Kloppers" userId="bcab5db0-8267-4c54-83c3-7ddba1e5c6be" providerId="ADAL" clId="{90E0EE0E-984C-4547-AADC-7DD4534EA015}" dt="2026-02-10T20:38:11.141" v="10355" actId="20577"/>
       <pc:docMkLst>
         <pc:docMk/>
       </pc:docMkLst>
@@ -179,12 +188,188 @@
           <pc:sldMk cId="3058085568" sldId="258"/>
         </pc:sldMkLst>
       </pc:sldChg>
-      <pc:sldChg chg="mod modShow">
-        <pc:chgData name="Joab Kloppers" userId="bcab5db0-8267-4c54-83c3-7ddba1e5c6be" providerId="ADAL" clId="{90E0EE0E-984C-4547-AADC-7DD4534EA015}" dt="2026-02-02T07:26:31.974" v="7701" actId="729"/>
+      <pc:sldChg chg="addSp delSp modSp mod modShow modNotesTx">
+        <pc:chgData name="Joab Kloppers" userId="bcab5db0-8267-4c54-83c3-7ddba1e5c6be" providerId="ADAL" clId="{90E0EE0E-984C-4547-AADC-7DD4534EA015}" dt="2026-02-10T20:16:13.327" v="9403" actId="729"/>
         <pc:sldMkLst>
           <pc:docMk/>
           <pc:sldMk cId="1008037533" sldId="259"/>
         </pc:sldMkLst>
+        <pc:spChg chg="mod">
+          <ac:chgData name="Joab Kloppers" userId="bcab5db0-8267-4c54-83c3-7ddba1e5c6be" providerId="ADAL" clId="{90E0EE0E-984C-4547-AADC-7DD4534EA015}" dt="2026-02-10T20:11:53.006" v="8777" actId="20577"/>
+          <ac:spMkLst>
+            <pc:docMk/>
+            <pc:sldMk cId="1008037533" sldId="259"/>
+            <ac:spMk id="2" creationId="{954ABE40-AA00-F366-A36A-B3F1AADBF025}"/>
+          </ac:spMkLst>
+        </pc:spChg>
+        <pc:spChg chg="del">
+          <ac:chgData name="Joab Kloppers" userId="bcab5db0-8267-4c54-83c3-7ddba1e5c6be" providerId="ADAL" clId="{90E0EE0E-984C-4547-AADC-7DD4534EA015}" dt="2026-02-10T19:01:23.594" v="8602" actId="478"/>
+          <ac:spMkLst>
+            <pc:docMk/>
+            <pc:sldMk cId="1008037533" sldId="259"/>
+            <ac:spMk id="3" creationId="{72446868-83F0-CEEF-5E60-6D55C93B523F}"/>
+          </ac:spMkLst>
+        </pc:spChg>
+        <pc:spChg chg="add del mod">
+          <ac:chgData name="Joab Kloppers" userId="bcab5db0-8267-4c54-83c3-7ddba1e5c6be" providerId="ADAL" clId="{90E0EE0E-984C-4547-AADC-7DD4534EA015}" dt="2026-02-10T18:57:05.363" v="8575" actId="478"/>
+          <ac:spMkLst>
+            <pc:docMk/>
+            <pc:sldMk cId="1008037533" sldId="259"/>
+            <ac:spMk id="5" creationId="{5003907A-4466-BCC9-5192-9F5EB08A6344}"/>
+          </ac:spMkLst>
+        </pc:spChg>
+        <pc:spChg chg="add del mod">
+          <ac:chgData name="Joab Kloppers" userId="bcab5db0-8267-4c54-83c3-7ddba1e5c6be" providerId="ADAL" clId="{90E0EE0E-984C-4547-AADC-7DD4534EA015}" dt="2026-02-10T19:01:26.798" v="8603" actId="478"/>
+          <ac:spMkLst>
+            <pc:docMk/>
+            <pc:sldMk cId="1008037533" sldId="259"/>
+            <ac:spMk id="12" creationId="{88309AD4-D043-FB6A-1DE5-5F9029EFEDA2}"/>
+          </ac:spMkLst>
+        </pc:spChg>
+        <pc:spChg chg="add mod">
+          <ac:chgData name="Joab Kloppers" userId="bcab5db0-8267-4c54-83c3-7ddba1e5c6be" providerId="ADAL" clId="{90E0EE0E-984C-4547-AADC-7DD4534EA015}" dt="2026-02-10T20:07:55.308" v="8657" actId="1076"/>
+          <ac:spMkLst>
+            <pc:docMk/>
+            <pc:sldMk cId="1008037533" sldId="259"/>
+            <ac:spMk id="25" creationId="{BC2618DD-1892-E29D-47BA-8589984A0E8A}"/>
+          </ac:spMkLst>
+        </pc:spChg>
+        <pc:spChg chg="add mod">
+          <ac:chgData name="Joab Kloppers" userId="bcab5db0-8267-4c54-83c3-7ddba1e5c6be" providerId="ADAL" clId="{90E0EE0E-984C-4547-AADC-7DD4534EA015}" dt="2026-02-10T20:10:10.061" v="8730" actId="1076"/>
+          <ac:spMkLst>
+            <pc:docMk/>
+            <pc:sldMk cId="1008037533" sldId="259"/>
+            <ac:spMk id="32" creationId="{DDA9F899-BE29-24FA-C41D-36583F125CF6}"/>
+          </ac:spMkLst>
+        </pc:spChg>
+        <pc:spChg chg="add mod">
+          <ac:chgData name="Joab Kloppers" userId="bcab5db0-8267-4c54-83c3-7ddba1e5c6be" providerId="ADAL" clId="{90E0EE0E-984C-4547-AADC-7DD4534EA015}" dt="2026-02-10T20:11:37.166" v="8774" actId="1076"/>
+          <ac:spMkLst>
+            <pc:docMk/>
+            <pc:sldMk cId="1008037533" sldId="259"/>
+            <ac:spMk id="35" creationId="{3F4DCCD6-9DDA-667A-813F-B248A9C132FF}"/>
+          </ac:spMkLst>
+        </pc:spChg>
+        <pc:spChg chg="add mod">
+          <ac:chgData name="Joab Kloppers" userId="bcab5db0-8267-4c54-83c3-7ddba1e5c6be" providerId="ADAL" clId="{90E0EE0E-984C-4547-AADC-7DD4534EA015}" dt="2026-02-10T20:11:25.298" v="8773" actId="1076"/>
+          <ac:spMkLst>
+            <pc:docMk/>
+            <pc:sldMk cId="1008037533" sldId="259"/>
+            <ac:spMk id="38" creationId="{2A6FCFB0-523B-627F-E71C-34AE61F532CB}"/>
+          </ac:spMkLst>
+        </pc:spChg>
+        <pc:picChg chg="add del mod">
+          <ac:chgData name="Joab Kloppers" userId="bcab5db0-8267-4c54-83c3-7ddba1e5c6be" providerId="ADAL" clId="{90E0EE0E-984C-4547-AADC-7DD4534EA015}" dt="2026-02-10T19:07:58.920" v="8623" actId="478"/>
+          <ac:picMkLst>
+            <pc:docMk/>
+            <pc:sldMk cId="1008037533" sldId="259"/>
+            <ac:picMk id="7" creationId="{4B29A6B2-C61F-686A-8009-D6BB83DC559E}"/>
+          </ac:picMkLst>
+        </pc:picChg>
+        <pc:picChg chg="add del mod">
+          <ac:chgData name="Joab Kloppers" userId="bcab5db0-8267-4c54-83c3-7ddba1e5c6be" providerId="ADAL" clId="{90E0EE0E-984C-4547-AADC-7DD4534EA015}" dt="2026-02-10T19:07:03.540" v="8616" actId="478"/>
+          <ac:picMkLst>
+            <pc:docMk/>
+            <pc:sldMk cId="1008037533" sldId="259"/>
+            <ac:picMk id="9" creationId="{31185738-B179-B8F6-5900-343D12BD5C1A}"/>
+          </ac:picMkLst>
+        </pc:picChg>
+        <pc:picChg chg="del mod">
+          <ac:chgData name="Joab Kloppers" userId="bcab5db0-8267-4c54-83c3-7ddba1e5c6be" providerId="ADAL" clId="{90E0EE0E-984C-4547-AADC-7DD4534EA015}" dt="2026-02-10T18:57:00.458" v="8573" actId="478"/>
+          <ac:picMkLst>
+            <pc:docMk/>
+            <pc:sldMk cId="1008037533" sldId="259"/>
+            <ac:picMk id="10" creationId="{99058E17-80B3-F3F9-AF6A-0518C39D940F}"/>
+          </ac:picMkLst>
+        </pc:picChg>
+        <pc:picChg chg="add mod">
+          <ac:chgData name="Joab Kloppers" userId="bcab5db0-8267-4c54-83c3-7ddba1e5c6be" providerId="ADAL" clId="{90E0EE0E-984C-4547-AADC-7DD4534EA015}" dt="2026-02-10T19:08:16.243" v="8630" actId="1076"/>
+          <ac:picMkLst>
+            <pc:docMk/>
+            <pc:sldMk cId="1008037533" sldId="259"/>
+            <ac:picMk id="16" creationId="{EC0B6619-4249-56D3-AA68-E9D9F6A518EF}"/>
+          </ac:picMkLst>
+        </pc:picChg>
+        <pc:picChg chg="add del mod">
+          <ac:chgData name="Joab Kloppers" userId="bcab5db0-8267-4c54-83c3-7ddba1e5c6be" providerId="ADAL" clId="{90E0EE0E-984C-4547-AADC-7DD4534EA015}" dt="2026-02-10T19:09:17.308" v="8635" actId="478"/>
+          <ac:picMkLst>
+            <pc:docMk/>
+            <pc:sldMk cId="1008037533" sldId="259"/>
+            <ac:picMk id="18" creationId="{E1277B87-0C77-8423-8457-35A3F9AC18EB}"/>
+          </ac:picMkLst>
+        </pc:picChg>
+        <pc:picChg chg="add mod">
+          <ac:chgData name="Joab Kloppers" userId="bcab5db0-8267-4c54-83c3-7ddba1e5c6be" providerId="ADAL" clId="{90E0EE0E-984C-4547-AADC-7DD4534EA015}" dt="2026-02-10T19:09:24.612" v="8638" actId="14100"/>
+          <ac:picMkLst>
+            <pc:docMk/>
+            <pc:sldMk cId="1008037533" sldId="259"/>
+            <ac:picMk id="22" creationId="{84FC55AD-FE16-0299-BFFE-CC8A810E6B37}"/>
+          </ac:picMkLst>
+        </pc:picChg>
+        <pc:cxnChg chg="add del mod">
+          <ac:chgData name="Joab Kloppers" userId="bcab5db0-8267-4c54-83c3-7ddba1e5c6be" providerId="ADAL" clId="{90E0EE0E-984C-4547-AADC-7DD4534EA015}" dt="2026-02-10T19:08:22.701" v="8632" actId="478"/>
+          <ac:cxnSpMkLst>
+            <pc:docMk/>
+            <pc:sldMk cId="1008037533" sldId="259"/>
+            <ac:cxnSpMk id="14" creationId="{F6B44CDF-CD4E-3112-29BD-A00FBADE2FAD}"/>
+          </ac:cxnSpMkLst>
+        </pc:cxnChg>
+        <pc:cxnChg chg="add del">
+          <ac:chgData name="Joab Kloppers" userId="bcab5db0-8267-4c54-83c3-7ddba1e5c6be" providerId="ADAL" clId="{90E0EE0E-984C-4547-AADC-7DD4534EA015}" dt="2026-02-10T19:08:33.558" v="8634" actId="11529"/>
+          <ac:cxnSpMkLst>
+            <pc:docMk/>
+            <pc:sldMk cId="1008037533" sldId="259"/>
+            <ac:cxnSpMk id="20" creationId="{8DC3B800-FF99-A6E3-E192-855E3C7CE328}"/>
+          </ac:cxnSpMkLst>
+        </pc:cxnChg>
+        <pc:cxnChg chg="add mod">
+          <ac:chgData name="Joab Kloppers" userId="bcab5db0-8267-4c54-83c3-7ddba1e5c6be" providerId="ADAL" clId="{90E0EE0E-984C-4547-AADC-7DD4534EA015}" dt="2026-02-10T19:09:43.222" v="8640" actId="208"/>
+          <ac:cxnSpMkLst>
+            <pc:docMk/>
+            <pc:sldMk cId="1008037533" sldId="259"/>
+            <ac:cxnSpMk id="24" creationId="{F1EA5270-97B0-DA22-7F2F-8ED6CAF1B1B7}"/>
+          </ac:cxnSpMkLst>
+        </pc:cxnChg>
+        <pc:cxnChg chg="add del">
+          <ac:chgData name="Joab Kloppers" userId="bcab5db0-8267-4c54-83c3-7ddba1e5c6be" providerId="ADAL" clId="{90E0EE0E-984C-4547-AADC-7DD4534EA015}" dt="2026-02-10T20:08:18.256" v="8659" actId="11529"/>
+          <ac:cxnSpMkLst>
+            <pc:docMk/>
+            <pc:sldMk cId="1008037533" sldId="259"/>
+            <ac:cxnSpMk id="27" creationId="{107D5145-AB29-5E1D-32DA-2D9337901861}"/>
+          </ac:cxnSpMkLst>
+        </pc:cxnChg>
+        <pc:cxnChg chg="add mod">
+          <ac:chgData name="Joab Kloppers" userId="bcab5db0-8267-4c54-83c3-7ddba1e5c6be" providerId="ADAL" clId="{90E0EE0E-984C-4547-AADC-7DD4534EA015}" dt="2026-02-10T20:08:31.657" v="8661" actId="13822"/>
+          <ac:cxnSpMkLst>
+            <pc:docMk/>
+            <pc:sldMk cId="1008037533" sldId="259"/>
+            <ac:cxnSpMk id="29" creationId="{7024E816-5B85-11F8-35EC-225C0329971D}"/>
+          </ac:cxnSpMkLst>
+        </pc:cxnChg>
+        <pc:cxnChg chg="add mod">
+          <ac:chgData name="Joab Kloppers" userId="bcab5db0-8267-4c54-83c3-7ddba1e5c6be" providerId="ADAL" clId="{90E0EE0E-984C-4547-AADC-7DD4534EA015}" dt="2026-02-10T20:08:43.870" v="8663" actId="13822"/>
+          <ac:cxnSpMkLst>
+            <pc:docMk/>
+            <pc:sldMk cId="1008037533" sldId="259"/>
+            <ac:cxnSpMk id="31" creationId="{E4EC052F-811E-C09D-98A9-9728117AA578}"/>
+          </ac:cxnSpMkLst>
+        </pc:cxnChg>
+        <pc:cxnChg chg="add mod">
+          <ac:chgData name="Joab Kloppers" userId="bcab5db0-8267-4c54-83c3-7ddba1e5c6be" providerId="ADAL" clId="{90E0EE0E-984C-4547-AADC-7DD4534EA015}" dt="2026-02-10T20:10:20.793" v="8732" actId="13822"/>
+          <ac:cxnSpMkLst>
+            <pc:docMk/>
+            <pc:sldMk cId="1008037533" sldId="259"/>
+            <ac:cxnSpMk id="34" creationId="{517535E0-6D4E-5EC7-FFBC-F5A505FDDD92}"/>
+          </ac:cxnSpMkLst>
+        </pc:cxnChg>
+        <pc:cxnChg chg="add mod">
+          <ac:chgData name="Joab Kloppers" userId="bcab5db0-8267-4c54-83c3-7ddba1e5c6be" providerId="ADAL" clId="{90E0EE0E-984C-4547-AADC-7DD4534EA015}" dt="2026-02-10T20:11:10.072" v="8750" actId="13822"/>
+          <ac:cxnSpMkLst>
+            <pc:docMk/>
+            <pc:sldMk cId="1008037533" sldId="259"/>
+            <ac:cxnSpMk id="37" creationId="{BD8243A6-ECCD-3ACC-9686-B609C752C91B}"/>
+          </ac:cxnSpMkLst>
+        </pc:cxnChg>
       </pc:sldChg>
       <pc:sldChg chg="mod modShow">
         <pc:chgData name="Joab Kloppers" userId="bcab5db0-8267-4c54-83c3-7ddba1e5c6be" providerId="ADAL" clId="{90E0EE0E-984C-4547-AADC-7DD4534EA015}" dt="2026-02-02T07:26:53.099" v="7703" actId="729"/>
@@ -201,7 +386,7 @@
         </pc:sldMkLst>
       </pc:sldChg>
       <pc:sldChg chg="modSp mod ord modNotesTx">
-        <pc:chgData name="Joab Kloppers" userId="bcab5db0-8267-4c54-83c3-7ddba1e5c6be" providerId="ADAL" clId="{90E0EE0E-984C-4547-AADC-7DD4534EA015}" dt="2026-01-27T14:57:51.378" v="7696" actId="5793"/>
+        <pc:chgData name="Joab Kloppers" userId="bcab5db0-8267-4c54-83c3-7ddba1e5c6be" providerId="ADAL" clId="{90E0EE0E-984C-4547-AADC-7DD4534EA015}" dt="2026-02-10T18:56:02.236" v="8571" actId="20577"/>
         <pc:sldMkLst>
           <pc:docMk/>
           <pc:sldMk cId="837402205" sldId="264"/>
@@ -215,7 +400,7 @@
           </ac:spMkLst>
         </pc:spChg>
         <pc:spChg chg="mod">
-          <ac:chgData name="Joab Kloppers" userId="bcab5db0-8267-4c54-83c3-7ddba1e5c6be" providerId="ADAL" clId="{90E0EE0E-984C-4547-AADC-7DD4534EA015}" dt="2026-01-27T14:06:40.985" v="4495" actId="20577"/>
+          <ac:chgData name="Joab Kloppers" userId="bcab5db0-8267-4c54-83c3-7ddba1e5c6be" providerId="ADAL" clId="{90E0EE0E-984C-4547-AADC-7DD4534EA015}" dt="2026-02-10T18:23:17.407" v="7782" actId="20577"/>
           <ac:spMkLst>
             <pc:docMk/>
             <pc:sldMk cId="837402205" sldId="264"/>
@@ -303,6 +488,253 @@
           <pc:docMk/>
           <pc:sldMk cId="487522735" sldId="340"/>
         </pc:sldMkLst>
+      </pc:sldChg>
+      <pc:sldChg chg="addSp delSp modSp add mod modNotesTx">
+        <pc:chgData name="Joab Kloppers" userId="bcab5db0-8267-4c54-83c3-7ddba1e5c6be" providerId="ADAL" clId="{90E0EE0E-984C-4547-AADC-7DD4534EA015}" dt="2026-02-10T20:38:11.141" v="10355" actId="20577"/>
+        <pc:sldMkLst>
+          <pc:docMk/>
+          <pc:sldMk cId="3134398988" sldId="341"/>
+        </pc:sldMkLst>
+        <pc:spChg chg="mod">
+          <ac:chgData name="Joab Kloppers" userId="bcab5db0-8267-4c54-83c3-7ddba1e5c6be" providerId="ADAL" clId="{90E0EE0E-984C-4547-AADC-7DD4534EA015}" dt="2026-02-10T20:16:21.670" v="9408" actId="20577"/>
+          <ac:spMkLst>
+            <pc:docMk/>
+            <pc:sldMk cId="3134398988" sldId="341"/>
+            <ac:spMk id="2" creationId="{1C5EDC56-2648-71A0-B020-497F2AC0BCD2}"/>
+          </ac:spMkLst>
+        </pc:spChg>
+        <pc:spChg chg="add mod">
+          <ac:chgData name="Joab Kloppers" userId="bcab5db0-8267-4c54-83c3-7ddba1e5c6be" providerId="ADAL" clId="{90E0EE0E-984C-4547-AADC-7DD4534EA015}" dt="2026-02-10T20:26:03.038" v="9590" actId="1076"/>
+          <ac:spMkLst>
+            <pc:docMk/>
+            <pc:sldMk cId="3134398988" sldId="341"/>
+            <ac:spMk id="17" creationId="{694880DF-1471-C70C-BFFF-679A07071A7B}"/>
+          </ac:spMkLst>
+        </pc:spChg>
+        <pc:spChg chg="add mod">
+          <ac:chgData name="Joab Kloppers" userId="bcab5db0-8267-4c54-83c3-7ddba1e5c6be" providerId="ADAL" clId="{90E0EE0E-984C-4547-AADC-7DD4534EA015}" dt="2026-02-10T20:21:58.655" v="9487" actId="1076"/>
+          <ac:spMkLst>
+            <pc:docMk/>
+            <pc:sldMk cId="3134398988" sldId="341"/>
+            <ac:spMk id="18" creationId="{6AB63C6C-E21F-49A8-2DF3-799952C932C0}"/>
+          </ac:spMkLst>
+        </pc:spChg>
+        <pc:spChg chg="add mod">
+          <ac:chgData name="Joab Kloppers" userId="bcab5db0-8267-4c54-83c3-7ddba1e5c6be" providerId="ADAL" clId="{90E0EE0E-984C-4547-AADC-7DD4534EA015}" dt="2026-02-10T20:23:19.893" v="9514" actId="1076"/>
+          <ac:spMkLst>
+            <pc:docMk/>
+            <pc:sldMk cId="3134398988" sldId="341"/>
+            <ac:spMk id="21" creationId="{B7946254-962A-CE33-7F2D-B9E3052CCB5C}"/>
+          </ac:spMkLst>
+        </pc:spChg>
+        <pc:spChg chg="del">
+          <ac:chgData name="Joab Kloppers" userId="bcab5db0-8267-4c54-83c3-7ddba1e5c6be" providerId="ADAL" clId="{90E0EE0E-984C-4547-AADC-7DD4534EA015}" dt="2026-02-10T20:19:20.881" v="9426" actId="478"/>
+          <ac:spMkLst>
+            <pc:docMk/>
+            <pc:sldMk cId="3134398988" sldId="341"/>
+            <ac:spMk id="25" creationId="{55DB6C57-A0B7-8193-BFE2-DB1C55649123}"/>
+          </ac:spMkLst>
+        </pc:spChg>
+        <pc:spChg chg="add mod">
+          <ac:chgData name="Joab Kloppers" userId="bcab5db0-8267-4c54-83c3-7ddba1e5c6be" providerId="ADAL" clId="{90E0EE0E-984C-4547-AADC-7DD4534EA015}" dt="2026-02-10T20:26:12.801" v="9592" actId="1076"/>
+          <ac:spMkLst>
+            <pc:docMk/>
+            <pc:sldMk cId="3134398988" sldId="341"/>
+            <ac:spMk id="27" creationId="{E4C15B5D-90BA-CC39-68FC-5F992FFFF42F}"/>
+          </ac:spMkLst>
+        </pc:spChg>
+        <pc:spChg chg="del">
+          <ac:chgData name="Joab Kloppers" userId="bcab5db0-8267-4c54-83c3-7ddba1e5c6be" providerId="ADAL" clId="{90E0EE0E-984C-4547-AADC-7DD4534EA015}" dt="2026-02-10T20:19:16.160" v="9424" actId="478"/>
+          <ac:spMkLst>
+            <pc:docMk/>
+            <pc:sldMk cId="3134398988" sldId="341"/>
+            <ac:spMk id="32" creationId="{85DA6984-0D05-0673-1A38-2DCB88C67CAA}"/>
+          </ac:spMkLst>
+        </pc:spChg>
+        <pc:spChg chg="del mod">
+          <ac:chgData name="Joab Kloppers" userId="bcab5db0-8267-4c54-83c3-7ddba1e5c6be" providerId="ADAL" clId="{90E0EE0E-984C-4547-AADC-7DD4534EA015}" dt="2026-02-10T20:19:10.710" v="9421" actId="478"/>
+          <ac:spMkLst>
+            <pc:docMk/>
+            <pc:sldMk cId="3134398988" sldId="341"/>
+            <ac:spMk id="35" creationId="{1E25DD68-EE14-C8CC-9333-643122C741BB}"/>
+          </ac:spMkLst>
+        </pc:spChg>
+        <pc:spChg chg="mod">
+          <ac:chgData name="Joab Kloppers" userId="bcab5db0-8267-4c54-83c3-7ddba1e5c6be" providerId="ADAL" clId="{90E0EE0E-984C-4547-AADC-7DD4534EA015}" dt="2026-02-10T20:30:48.776" v="9696" actId="20577"/>
+          <ac:spMkLst>
+            <pc:docMk/>
+            <pc:sldMk cId="3134398988" sldId="341"/>
+            <ac:spMk id="38" creationId="{A2A16A3E-4296-0FC3-C911-74084EADC242}"/>
+          </ac:spMkLst>
+        </pc:spChg>
+        <pc:spChg chg="add mod">
+          <ac:chgData name="Joab Kloppers" userId="bcab5db0-8267-4c54-83c3-7ddba1e5c6be" providerId="ADAL" clId="{90E0EE0E-984C-4547-AADC-7DD4534EA015}" dt="2026-02-10T20:25:54.365" v="9588" actId="1076"/>
+          <ac:spMkLst>
+            <pc:docMk/>
+            <pc:sldMk cId="3134398988" sldId="341"/>
+            <ac:spMk id="39" creationId="{0B297A23-99FD-8358-4EB9-0490A0B62C1A}"/>
+          </ac:spMkLst>
+        </pc:spChg>
+        <pc:spChg chg="add mod">
+          <ac:chgData name="Joab Kloppers" userId="bcab5db0-8267-4c54-83c3-7ddba1e5c6be" providerId="ADAL" clId="{90E0EE0E-984C-4547-AADC-7DD4534EA015}" dt="2026-02-10T20:27:25.238" v="9624" actId="1076"/>
+          <ac:spMkLst>
+            <pc:docMk/>
+            <pc:sldMk cId="3134398988" sldId="341"/>
+            <ac:spMk id="45" creationId="{FEDBE1A9-6BB6-F83E-DF79-4E7B6300DEF9}"/>
+          </ac:spMkLst>
+        </pc:spChg>
+        <pc:picChg chg="add del mod">
+          <ac:chgData name="Joab Kloppers" userId="bcab5db0-8267-4c54-83c3-7ddba1e5c6be" providerId="ADAL" clId="{90E0EE0E-984C-4547-AADC-7DD4534EA015}" dt="2026-02-10T20:18:49.159" v="9414" actId="478"/>
+          <ac:picMkLst>
+            <pc:docMk/>
+            <pc:sldMk cId="3134398988" sldId="341"/>
+            <ac:picMk id="4" creationId="{1B4F7DA1-6F3B-DF44-6829-885F4C07C90D}"/>
+          </ac:picMkLst>
+        </pc:picChg>
+        <pc:picChg chg="add mod">
+          <ac:chgData name="Joab Kloppers" userId="bcab5db0-8267-4c54-83c3-7ddba1e5c6be" providerId="ADAL" clId="{90E0EE0E-984C-4547-AADC-7DD4534EA015}" dt="2026-02-10T20:18:59.099" v="9418" actId="14100"/>
+          <ac:picMkLst>
+            <pc:docMk/>
+            <pc:sldMk cId="3134398988" sldId="341"/>
+            <ac:picMk id="6" creationId="{C1AB545E-CBBA-0DBC-0D83-4B26E860A3E9}"/>
+          </ac:picMkLst>
+        </pc:picChg>
+        <pc:picChg chg="del">
+          <ac:chgData name="Joab Kloppers" userId="bcab5db0-8267-4c54-83c3-7ddba1e5c6be" providerId="ADAL" clId="{90E0EE0E-984C-4547-AADC-7DD4534EA015}" dt="2026-02-10T20:29:05.755" v="9625" actId="478"/>
+          <ac:picMkLst>
+            <pc:docMk/>
+            <pc:sldMk cId="3134398988" sldId="341"/>
+            <ac:picMk id="16" creationId="{F8C24508-944A-6E45-A242-7F46FB642809}"/>
+          </ac:picMkLst>
+        </pc:picChg>
+        <pc:picChg chg="del">
+          <ac:chgData name="Joab Kloppers" userId="bcab5db0-8267-4c54-83c3-7ddba1e5c6be" providerId="ADAL" clId="{90E0EE0E-984C-4547-AADC-7DD4534EA015}" dt="2026-02-10T20:18:18.571" v="9409" actId="478"/>
+          <ac:picMkLst>
+            <pc:docMk/>
+            <pc:sldMk cId="3134398988" sldId="341"/>
+            <ac:picMk id="22" creationId="{9392B5A8-D108-73C9-A5E9-EE728DE61AD0}"/>
+          </ac:picMkLst>
+        </pc:picChg>
+        <pc:picChg chg="add mod">
+          <ac:chgData name="Joab Kloppers" userId="bcab5db0-8267-4c54-83c3-7ddba1e5c6be" providerId="ADAL" clId="{90E0EE0E-984C-4547-AADC-7DD4534EA015}" dt="2026-02-10T20:29:23.568" v="9631" actId="1076"/>
+          <ac:picMkLst>
+            <pc:docMk/>
+            <pc:sldMk cId="3134398988" sldId="341"/>
+            <ac:picMk id="47" creationId="{342DB476-F6D3-B436-CA45-AE24E63DD302}"/>
+          </ac:picMkLst>
+        </pc:picChg>
+        <pc:cxnChg chg="add mod">
+          <ac:chgData name="Joab Kloppers" userId="bcab5db0-8267-4c54-83c3-7ddba1e5c6be" providerId="ADAL" clId="{90E0EE0E-984C-4547-AADC-7DD4534EA015}" dt="2026-02-10T20:26:00.529" v="9589" actId="14100"/>
+          <ac:cxnSpMkLst>
+            <pc:docMk/>
+            <pc:sldMk cId="3134398988" sldId="341"/>
+            <ac:cxnSpMk id="8" creationId="{B88CD4C8-7545-7C82-9810-545F301BB4A3}"/>
+          </ac:cxnSpMkLst>
+        </pc:cxnChg>
+        <pc:cxnChg chg="add del mod">
+          <ac:chgData name="Joab Kloppers" userId="bcab5db0-8267-4c54-83c3-7ddba1e5c6be" providerId="ADAL" clId="{90E0EE0E-984C-4547-AADC-7DD4534EA015}" dt="2026-02-10T20:20:45.243" v="9434" actId="11529"/>
+          <ac:cxnSpMkLst>
+            <pc:docMk/>
+            <pc:sldMk cId="3134398988" sldId="341"/>
+            <ac:cxnSpMk id="10" creationId="{AFB60792-15C1-D5F0-42BF-B798D176A58B}"/>
+          </ac:cxnSpMkLst>
+        </pc:cxnChg>
+        <pc:cxnChg chg="add mod">
+          <ac:chgData name="Joab Kloppers" userId="bcab5db0-8267-4c54-83c3-7ddba1e5c6be" providerId="ADAL" clId="{90E0EE0E-984C-4547-AADC-7DD4534EA015}" dt="2026-02-10T20:20:52.701" v="9436" actId="13822"/>
+          <ac:cxnSpMkLst>
+            <pc:docMk/>
+            <pc:sldMk cId="3134398988" sldId="341"/>
+            <ac:cxnSpMk id="13" creationId="{CB231952-3BDE-C96E-2D97-8104C17D7CB9}"/>
+          </ac:cxnSpMkLst>
+        </pc:cxnChg>
+        <pc:cxnChg chg="add mod">
+          <ac:chgData name="Joab Kloppers" userId="bcab5db0-8267-4c54-83c3-7ddba1e5c6be" providerId="ADAL" clId="{90E0EE0E-984C-4547-AADC-7DD4534EA015}" dt="2026-02-10T20:21:00.828" v="9438" actId="13822"/>
+          <ac:cxnSpMkLst>
+            <pc:docMk/>
+            <pc:sldMk cId="3134398988" sldId="341"/>
+            <ac:cxnSpMk id="15" creationId="{A62BABF9-266B-6777-6C16-EDBBF8066092}"/>
+          </ac:cxnSpMkLst>
+        </pc:cxnChg>
+        <pc:cxnChg chg="add mod">
+          <ac:chgData name="Joab Kloppers" userId="bcab5db0-8267-4c54-83c3-7ddba1e5c6be" providerId="ADAL" clId="{90E0EE0E-984C-4547-AADC-7DD4534EA015}" dt="2026-02-10T20:22:23.027" v="9490" actId="13822"/>
+          <ac:cxnSpMkLst>
+            <pc:docMk/>
+            <pc:sldMk cId="3134398988" sldId="341"/>
+            <ac:cxnSpMk id="20" creationId="{92F2A379-D195-021E-7225-7EB9A36A7B5B}"/>
+          </ac:cxnSpMkLst>
+        </pc:cxnChg>
+        <pc:cxnChg chg="del">
+          <ac:chgData name="Joab Kloppers" userId="bcab5db0-8267-4c54-83c3-7ddba1e5c6be" providerId="ADAL" clId="{90E0EE0E-984C-4547-AADC-7DD4534EA015}" dt="2026-02-10T20:19:18.193" v="9425" actId="478"/>
+          <ac:cxnSpMkLst>
+            <pc:docMk/>
+            <pc:sldMk cId="3134398988" sldId="341"/>
+            <ac:cxnSpMk id="24" creationId="{53948260-5551-C16B-9C91-D9DFDA8FFBB3}"/>
+          </ac:cxnSpMkLst>
+        </pc:cxnChg>
+        <pc:cxnChg chg="add mod">
+          <ac:chgData name="Joab Kloppers" userId="bcab5db0-8267-4c54-83c3-7ddba1e5c6be" providerId="ADAL" clId="{90E0EE0E-984C-4547-AADC-7DD4534EA015}" dt="2026-02-10T20:26:09.058" v="9591" actId="14100"/>
+          <ac:cxnSpMkLst>
+            <pc:docMk/>
+            <pc:sldMk cId="3134398988" sldId="341"/>
+            <ac:cxnSpMk id="26" creationId="{17DA7481-E0B5-8D0B-8B62-8F1CA411F6C8}"/>
+          </ac:cxnSpMkLst>
+        </pc:cxnChg>
+        <pc:cxnChg chg="del">
+          <ac:chgData name="Joab Kloppers" userId="bcab5db0-8267-4c54-83c3-7ddba1e5c6be" providerId="ADAL" clId="{90E0EE0E-984C-4547-AADC-7DD4534EA015}" dt="2026-02-10T20:19:13.593" v="9423" actId="478"/>
+          <ac:cxnSpMkLst>
+            <pc:docMk/>
+            <pc:sldMk cId="3134398988" sldId="341"/>
+            <ac:cxnSpMk id="29" creationId="{5A8EE7A6-7BA7-46AC-9FA9-AB5228705912}"/>
+          </ac:cxnSpMkLst>
+        </pc:cxnChg>
+        <pc:cxnChg chg="add del">
+          <ac:chgData name="Joab Kloppers" userId="bcab5db0-8267-4c54-83c3-7ddba1e5c6be" providerId="ADAL" clId="{90E0EE0E-984C-4547-AADC-7DD4534EA015}" dt="2026-02-10T20:25:14.530" v="9552" actId="11529"/>
+          <ac:cxnSpMkLst>
+            <pc:docMk/>
+            <pc:sldMk cId="3134398988" sldId="341"/>
+            <ac:cxnSpMk id="30" creationId="{71993123-7FF3-8210-D7E6-CA8E4A3AEF90}"/>
+          </ac:cxnSpMkLst>
+        </pc:cxnChg>
+        <pc:cxnChg chg="del">
+          <ac:chgData name="Joab Kloppers" userId="bcab5db0-8267-4c54-83c3-7ddba1e5c6be" providerId="ADAL" clId="{90E0EE0E-984C-4547-AADC-7DD4534EA015}" dt="2026-02-10T20:19:12.647" v="9422" actId="478"/>
+          <ac:cxnSpMkLst>
+            <pc:docMk/>
+            <pc:sldMk cId="3134398988" sldId="341"/>
+            <ac:cxnSpMk id="31" creationId="{03D406A9-8133-6A91-4BAC-B8BC0D061482}"/>
+          </ac:cxnSpMkLst>
+        </pc:cxnChg>
+        <pc:cxnChg chg="del">
+          <ac:chgData name="Joab Kloppers" userId="bcab5db0-8267-4c54-83c3-7ddba1e5c6be" providerId="ADAL" clId="{90E0EE0E-984C-4547-AADC-7DD4534EA015}" dt="2026-02-10T20:19:04.559" v="9419" actId="478"/>
+          <ac:cxnSpMkLst>
+            <pc:docMk/>
+            <pc:sldMk cId="3134398988" sldId="341"/>
+            <ac:cxnSpMk id="34" creationId="{AE8E8F41-DED7-6CB3-0395-788F792CA131}"/>
+          </ac:cxnSpMkLst>
+        </pc:cxnChg>
+        <pc:cxnChg chg="add mod">
+          <ac:chgData name="Joab Kloppers" userId="bcab5db0-8267-4c54-83c3-7ddba1e5c6be" providerId="ADAL" clId="{90E0EE0E-984C-4547-AADC-7DD4534EA015}" dt="2026-02-10T20:25:48.333" v="9587" actId="14100"/>
+          <ac:cxnSpMkLst>
+            <pc:docMk/>
+            <pc:sldMk cId="3134398988" sldId="341"/>
+            <ac:cxnSpMk id="36" creationId="{CC973BE6-3859-F65A-40C9-8C52D8671503}"/>
+          </ac:cxnSpMkLst>
+        </pc:cxnChg>
+        <pc:cxnChg chg="mod ord">
+          <ac:chgData name="Joab Kloppers" userId="bcab5db0-8267-4c54-83c3-7ddba1e5c6be" providerId="ADAL" clId="{90E0EE0E-984C-4547-AADC-7DD4534EA015}" dt="2026-02-10T20:29:36.959" v="9633" actId="14100"/>
+          <ac:cxnSpMkLst>
+            <pc:docMk/>
+            <pc:sldMk cId="3134398988" sldId="341"/>
+            <ac:cxnSpMk id="37" creationId="{BF184665-63BF-AFC8-777F-A85949981183}"/>
+          </ac:cxnSpMkLst>
+        </pc:cxnChg>
+        <pc:cxnChg chg="add mod">
+          <ac:chgData name="Joab Kloppers" userId="bcab5db0-8267-4c54-83c3-7ddba1e5c6be" providerId="ADAL" clId="{90E0EE0E-984C-4547-AADC-7DD4534EA015}" dt="2026-02-10T20:26:49.406" v="9594" actId="13822"/>
+          <ac:cxnSpMkLst>
+            <pc:docMk/>
+            <pc:sldMk cId="3134398988" sldId="341"/>
+            <ac:cxnSpMk id="44" creationId="{68984215-6ACC-7C6C-449D-3AFFBDE196C8}"/>
+          </ac:cxnSpMkLst>
+        </pc:cxnChg>
       </pc:sldChg>
     </pc:docChg>
   </pc:docChgLst>
@@ -3344,7 +3776,7 @@
           <a:p>
             <a:fld id="{7FF95820-84BB-3447-8286-60A51307E7F2}" type="datetimeFigureOut">
               <a:rPr lang="en-US" smtClean="0"/>
-              <a:t>2/4/2026</a:t>
+              <a:t>2/10/2026</a:t>
             </a:fld>
             <a:endParaRPr lang="en-US" dirty="0"/>
           </a:p>
@@ -3522,7 +3954,7 @@
           <a:p>
             <a:fld id="{FC08FC54-6AE4-6A4A-9756-823A0F1BE5A6}" type="datetimeFigureOut">
               <a:rPr lang="en-US" smtClean="0"/>
-              <a:t>2/4/2026</a:t>
+              <a:t>2/10/2026</a:t>
             </a:fld>
             <a:endParaRPr lang="en-US" dirty="0"/>
           </a:p>
@@ -4159,7 +4591,7 @@
             </a:pPr>
             <a:r>
               <a:rPr lang="en-US" dirty="0"/>
-              <a:t>Determine if the Incubator can operate whilst being hermetically sealed to prevent media inside the incubator from contaminating the microscope or general environment.</a:t>
+              <a:t>Determine the containment requirements that allow a containment system to function within a BSL-3</a:t>
             </a:r>
           </a:p>
           <a:p>
@@ -4179,7 +4611,7 @@
             </a:pPr>
             <a:r>
               <a:rPr lang="en-US" dirty="0"/>
-              <a:t>Determine the sterilization techniques that are required for a BLS-3 lab</a:t>
+              <a:t>Determine the sterilization techniques that are required for a BSL-3 lab</a:t>
             </a:r>
           </a:p>
           <a:p>
@@ -4196,7 +4628,17 @@
             </a:pPr>
             <a:r>
               <a:rPr lang="en-US" dirty="0"/>
-              <a:t>If it is feasible to begin prototyping and performing a conceptual design, the eventual goal is the following:</a:t>
+              <a:t>A part of determining the feasibility of this system, is to determine if it is possible to hermetically seal a culture vessel within a container whilst still allowing for optical viewing.</a:t>
+            </a:r>
+          </a:p>
+          <a:p>
+            <a:pPr marL="0" indent="0">
+              <a:buFont typeface="Arial" panose="020B0604020202020204" pitchFamily="34" charset="0"/>
+              <a:buNone/>
+            </a:pPr>
+            <a:r>
+              <a:rPr lang="en-US" dirty="0"/>
+              <a:t>This includes:</a:t>
             </a:r>
           </a:p>
           <a:p>
@@ -4206,7 +4648,7 @@
             </a:pPr>
             <a:r>
               <a:rPr lang="en-US" dirty="0"/>
-              <a:t>Prototype a stage top incubator that is completely hermetically sealed.</a:t>
+              <a:t>Prototyping an enclosure which holds a 96 well plate.</a:t>
             </a:r>
           </a:p>
           <a:p>
@@ -4216,7 +4658,7 @@
             </a:pPr>
             <a:r>
               <a:rPr lang="en-US" dirty="0"/>
-              <a:t>Prototype a stage top incubator that can maintain a stable temperature required for cell growth.</a:t>
+              <a:t>Prototyping an enclosure which offers complete hermetic seal comparable to an IP68 enclosure</a:t>
             </a:r>
           </a:p>
           <a:p>
@@ -4226,45 +4668,7 @@
             </a:pPr>
             <a:r>
               <a:rPr lang="en-US" dirty="0"/>
-              <a:t>Prototype a stage top incubator that is capable of being sterilized using existing BSL-3 protocols.</a:t>
-            </a:r>
-          </a:p>
-          <a:p>
-            <a:pPr marL="171450" indent="-171450">
-              <a:buFont typeface="Arial" panose="020B0604020202020204" pitchFamily="34" charset="0"/>
-              <a:buChar char="•"/>
-            </a:pPr>
-            <a:r>
-              <a:rPr lang="en-US" dirty="0"/>
-              <a:t>Prototype a stage top incubator that can fit </a:t>
-            </a:r>
-            <a:r>
-              <a:rPr lang="en-US" dirty="0" err="1"/>
-              <a:t>ontop</a:t>
-            </a:r>
-            <a:r>
-              <a:rPr lang="en-US" dirty="0"/>
-              <a:t> of a low magnification microscope for long term live cell imaging</a:t>
-            </a:r>
-          </a:p>
-          <a:p>
-            <a:pPr marL="171450" indent="-171450">
-              <a:buFont typeface="Arial" panose="020B0604020202020204" pitchFamily="34" charset="0"/>
-              <a:buChar char="•"/>
-            </a:pPr>
-            <a:r>
-              <a:rPr lang="en-US" dirty="0"/>
-              <a:t>Allow for the possibility of CO2/O2/Humidity regulation</a:t>
-            </a:r>
-          </a:p>
-          <a:p>
-            <a:pPr marL="171450" indent="-171450">
-              <a:buFont typeface="Arial" panose="020B0604020202020204" pitchFamily="34" charset="0"/>
-              <a:buChar char="•"/>
-            </a:pPr>
-            <a:r>
-              <a:rPr lang="en-US" dirty="0"/>
-              <a:t>Allow for the possibility of compatibility with several different culture dishes.</a:t>
+              <a:t>Prototyping an enclosure which provides suitable optical clarity for low magnification microscopy</a:t>
             </a:r>
           </a:p>
           <a:p>
@@ -4275,11 +4679,96 @@
             <a:endParaRPr lang="en-US" dirty="0"/>
           </a:p>
           <a:p>
+            <a:pPr marL="0" indent="0">
+              <a:buFont typeface="Arial" panose="020B0604020202020204" pitchFamily="34" charset="0"/>
+              <a:buNone/>
+            </a:pPr>
+            <a:r>
+              <a:rPr lang="en-US" dirty="0"/>
+              <a:t>If it is feasible to begin prototyping and performing a conceptual design, the eventual goal is the following:</a:t>
+            </a:r>
+          </a:p>
+          <a:p>
             <a:pPr marL="171450" indent="-171450">
               <a:buFont typeface="Arial" panose="020B0604020202020204" pitchFamily="34" charset="0"/>
               <a:buChar char="•"/>
             </a:pPr>
-            <a:endParaRPr lang="en-US"/>
+            <a:r>
+              <a:rPr lang="en-US" dirty="0"/>
+              <a:t>Prototype a stage top incubator that is completely hermetically sealed.</a:t>
+            </a:r>
+          </a:p>
+          <a:p>
+            <a:pPr marL="171450" indent="-171450">
+              <a:buFont typeface="Arial" panose="020B0604020202020204" pitchFamily="34" charset="0"/>
+              <a:buChar char="•"/>
+            </a:pPr>
+            <a:r>
+              <a:rPr lang="en-US" dirty="0"/>
+              <a:t>Prototype a stage top incubator that can maintain a stable temperature required for cell growth.</a:t>
+            </a:r>
+          </a:p>
+          <a:p>
+            <a:pPr marL="171450" indent="-171450">
+              <a:buFont typeface="Arial" panose="020B0604020202020204" pitchFamily="34" charset="0"/>
+              <a:buChar char="•"/>
+            </a:pPr>
+            <a:r>
+              <a:rPr lang="en-US" dirty="0"/>
+              <a:t>Prototype a stage top incubator that is capable of being sterilized using existing BSL-3 protocols.</a:t>
+            </a:r>
+          </a:p>
+          <a:p>
+            <a:pPr marL="171450" indent="-171450">
+              <a:buFont typeface="Arial" panose="020B0604020202020204" pitchFamily="34" charset="0"/>
+              <a:buChar char="•"/>
+            </a:pPr>
+            <a:r>
+              <a:rPr lang="en-US" dirty="0"/>
+              <a:t>Prototype a stage top incubator that can fit </a:t>
+            </a:r>
+            <a:r>
+              <a:rPr lang="en-US" dirty="0" err="1"/>
+              <a:t>ontop</a:t>
+            </a:r>
+            <a:r>
+              <a:rPr lang="en-US" dirty="0"/>
+              <a:t> of a low magnification microscope for long term live cell imaging</a:t>
+            </a:r>
+          </a:p>
+          <a:p>
+            <a:pPr marL="171450" indent="-171450">
+              <a:buFont typeface="Arial" panose="020B0604020202020204" pitchFamily="34" charset="0"/>
+              <a:buChar char="•"/>
+            </a:pPr>
+            <a:r>
+              <a:rPr lang="en-US" dirty="0"/>
+              <a:t>Allow for the possibility of CO2/O2/Humidity regulation</a:t>
+            </a:r>
+          </a:p>
+          <a:p>
+            <a:pPr marL="171450" indent="-171450">
+              <a:buFont typeface="Arial" panose="020B0604020202020204" pitchFamily="34" charset="0"/>
+              <a:buChar char="•"/>
+            </a:pPr>
+            <a:r>
+              <a:rPr lang="en-US" dirty="0"/>
+              <a:t>Allow for the possibility of compatibility with several different culture dishes.</a:t>
+            </a:r>
+          </a:p>
+          <a:p>
+            <a:pPr marL="171450" indent="-171450">
+              <a:buFont typeface="Arial" panose="020B0604020202020204" pitchFamily="34" charset="0"/>
+              <a:buChar char="•"/>
+            </a:pPr>
+            <a:endParaRPr lang="en-US" dirty="0"/>
+          </a:p>
+          <a:p>
+            <a:pPr marL="171450" indent="-171450">
+              <a:buFont typeface="Arial" panose="020B0604020202020204" pitchFamily="34" charset="0"/>
+              <a:buChar char="•"/>
+            </a:pPr>
+            <a:endParaRPr lang="en-US" dirty="0"/>
           </a:p>
           <a:p>
             <a:pPr marL="0" indent="0">
@@ -4301,6 +4790,252 @@
     <p:extLst>
       <p:ext uri="{BB962C8B-B14F-4D97-AF65-F5344CB8AC3E}">
         <p14:creationId xmlns:p14="http://schemas.microsoft.com/office/powerpoint/2010/main" val="4162733701"/>
+      </p:ext>
+    </p:extLst>
+  </p:cSld>
+  <p:clrMapOvr>
+    <a:masterClrMapping/>
+  </p:clrMapOvr>
+</p:notes>
+</file>
+
+<file path=ppt/notesSlides/notesSlide4.xml><?xml version="1.0" encoding="utf-8"?>
+<p:notes xmlns:a="http://schemas.openxmlformats.org/drawingml/2006/main" xmlns:r="http://schemas.openxmlformats.org/officeDocument/2006/relationships" xmlns:p="http://schemas.openxmlformats.org/presentationml/2006/main">
+  <p:cSld>
+    <p:spTree>
+      <p:nvGrpSpPr>
+        <p:cNvPr id="1" name=""/>
+        <p:cNvGrpSpPr/>
+        <p:nvPr/>
+      </p:nvGrpSpPr>
+      <p:grpSpPr>
+        <a:xfrm>
+          <a:off x="0" y="0"/>
+          <a:ext cx="0" cy="0"/>
+          <a:chOff x="0" y="0"/>
+          <a:chExt cx="0" cy="0"/>
+        </a:xfrm>
+      </p:grpSpPr>
+      <p:sp>
+        <p:nvSpPr>
+          <p:cNvPr id="2" name="Slide Image Placeholder 1"/>
+          <p:cNvSpPr>
+            <a:spLocks noGrp="1" noRot="1" noChangeAspect="1"/>
+          </p:cNvSpPr>
+          <p:nvPr>
+            <p:ph type="sldImg"/>
+          </p:nvPr>
+        </p:nvSpPr>
+        <p:spPr/>
+      </p:sp>
+      <p:sp>
+        <p:nvSpPr>
+          <p:cNvPr id="3" name="Notes Placeholder 2"/>
+          <p:cNvSpPr>
+            <a:spLocks noGrp="1"/>
+          </p:cNvSpPr>
+          <p:nvPr>
+            <p:ph type="body" idx="1"/>
+          </p:nvPr>
+        </p:nvSpPr>
+        <p:spPr/>
+        <p:txBody>
+          <a:bodyPr/>
+          <a:lstStyle/>
+          <a:p>
+            <a:r>
+              <a:rPr lang="en-US" dirty="0"/>
+              <a:t>First Round used a simple box design with a cavity that seats the multi-well plate.</a:t>
+            </a:r>
+          </a:p>
+          <a:p>
+            <a:r>
+              <a:rPr lang="en-US" dirty="0"/>
+              <a:t>The box will use plates on the top and bottom that are set in place using epoxy or glue sealant. These will be either both glass, or glass and aluminum plate.</a:t>
+            </a:r>
+          </a:p>
+          <a:p>
+            <a:endParaRPr lang="en-US" dirty="0"/>
+          </a:p>
+          <a:p>
+            <a:r>
+              <a:rPr lang="en-US" dirty="0"/>
+              <a:t>This design uses a rudimentary grove based into both the lid and base with sharp corners for an </a:t>
+            </a:r>
+            <a:r>
+              <a:rPr lang="en-US" dirty="0" err="1"/>
+              <a:t>o-ring</a:t>
+            </a:r>
+            <a:r>
+              <a:rPr lang="en-US" dirty="0"/>
+              <a:t>.</a:t>
+            </a:r>
+          </a:p>
+          <a:p>
+            <a:endParaRPr lang="en-US" dirty="0"/>
+          </a:p>
+          <a:p>
+            <a:r>
+              <a:rPr lang="en-US" dirty="0"/>
+              <a:t>The entire plate will be completely sealed within the chamber using the two plates on the outer surfaces, as well as the </a:t>
+            </a:r>
+            <a:r>
+              <a:rPr lang="en-US" dirty="0" err="1"/>
+              <a:t>o-ring</a:t>
+            </a:r>
+            <a:r>
+              <a:rPr lang="en-US" dirty="0"/>
+              <a:t> that sits in the groove.</a:t>
+            </a:r>
+            <a:endParaRPr lang="en-ZA" dirty="0"/>
+          </a:p>
+        </p:txBody>
+      </p:sp>
+    </p:spTree>
+    <p:extLst>
+      <p:ext uri="{BB962C8B-B14F-4D97-AF65-F5344CB8AC3E}">
+        <p14:creationId xmlns:p14="http://schemas.microsoft.com/office/powerpoint/2010/main" val="1694766969"/>
+      </p:ext>
+    </p:extLst>
+  </p:cSld>
+  <p:clrMapOvr>
+    <a:masterClrMapping/>
+  </p:clrMapOvr>
+</p:notes>
+</file>
+
+<file path=ppt/notesSlides/notesSlide5.xml><?xml version="1.0" encoding="utf-8"?>
+<p:notes xmlns:a="http://schemas.openxmlformats.org/drawingml/2006/main" xmlns:r="http://schemas.openxmlformats.org/officeDocument/2006/relationships" xmlns:p="http://schemas.openxmlformats.org/presentationml/2006/main">
+  <p:cSld>
+    <p:spTree>
+      <p:nvGrpSpPr>
+        <p:cNvPr id="1" name="">
+          <a:extLst>
+            <a:ext uri="{FF2B5EF4-FFF2-40B4-BE49-F238E27FC236}">
+              <a16:creationId xmlns:a16="http://schemas.microsoft.com/office/drawing/2014/main" id="{F40F5AC4-4B59-0074-7C7F-7D81FBFE03C6}"/>
+            </a:ext>
+          </a:extLst>
+        </p:cNvPr>
+        <p:cNvGrpSpPr/>
+        <p:nvPr/>
+      </p:nvGrpSpPr>
+      <p:grpSpPr>
+        <a:xfrm>
+          <a:off x="0" y="0"/>
+          <a:ext cx="0" cy="0"/>
+          <a:chOff x="0" y="0"/>
+          <a:chExt cx="0" cy="0"/>
+        </a:xfrm>
+      </p:grpSpPr>
+      <p:sp>
+        <p:nvSpPr>
+          <p:cNvPr id="2" name="Slide Image Placeholder 1">
+            <a:extLst>
+              <a:ext uri="{FF2B5EF4-FFF2-40B4-BE49-F238E27FC236}">
+                <a16:creationId xmlns:a16="http://schemas.microsoft.com/office/drawing/2014/main" id="{24775E91-6770-9745-4D2A-2A5960FDD466}"/>
+              </a:ext>
+            </a:extLst>
+          </p:cNvPr>
+          <p:cNvSpPr>
+            <a:spLocks noGrp="1" noRot="1" noChangeAspect="1"/>
+          </p:cNvSpPr>
+          <p:nvPr>
+            <p:ph type="sldImg"/>
+          </p:nvPr>
+        </p:nvSpPr>
+        <p:spPr/>
+      </p:sp>
+      <p:sp>
+        <p:nvSpPr>
+          <p:cNvPr id="3" name="Notes Placeholder 2">
+            <a:extLst>
+              <a:ext uri="{FF2B5EF4-FFF2-40B4-BE49-F238E27FC236}">
+                <a16:creationId xmlns:a16="http://schemas.microsoft.com/office/drawing/2014/main" id="{A26A415D-5F70-D27F-40AD-A7B89A5B3B8E}"/>
+              </a:ext>
+            </a:extLst>
+          </p:cNvPr>
+          <p:cNvSpPr>
+            <a:spLocks noGrp="1"/>
+          </p:cNvSpPr>
+          <p:nvPr>
+            <p:ph type="body" idx="1"/>
+          </p:nvPr>
+        </p:nvSpPr>
+        <p:spPr/>
+        <p:txBody>
+          <a:bodyPr/>
+          <a:lstStyle/>
+          <a:p>
+            <a:r>
+              <a:rPr lang="en-US" dirty="0"/>
+              <a:t>After 2 rounds of revision</a:t>
+            </a:r>
+            <a:r>
+              <a:rPr lang="en-ZA" dirty="0"/>
+              <a:t> the latest edition updates and improves several parts</a:t>
+            </a:r>
+          </a:p>
+          <a:p>
+            <a:pPr marL="228600" indent="-228600">
+              <a:buFont typeface="+mj-lt"/>
+              <a:buAutoNum type="arabicPeriod"/>
+            </a:pPr>
+            <a:r>
+              <a:rPr lang="en-ZA" dirty="0"/>
+              <a:t>O-Ring groove has been revised to use a recessed design that allows for aligned mating of lid and base</a:t>
+            </a:r>
+          </a:p>
+          <a:p>
+            <a:pPr marL="228600" indent="-228600">
+              <a:buFont typeface="+mj-lt"/>
+              <a:buAutoNum type="arabicPeriod"/>
+            </a:pPr>
+            <a:r>
+              <a:rPr lang="en-ZA" dirty="0"/>
+              <a:t>Bottom viewing plate removed and top viewing plate insert moved to inside of lid for better pressure seals.</a:t>
+            </a:r>
+          </a:p>
+          <a:p>
+            <a:pPr marL="228600" indent="-228600">
+              <a:buFont typeface="+mj-lt"/>
+              <a:buAutoNum type="arabicPeriod"/>
+            </a:pPr>
+            <a:r>
+              <a:rPr lang="en-ZA" dirty="0"/>
+              <a:t>Base uses a groove that seals against the base of the multi-well plate to allow for more direct optical viewing</a:t>
+            </a:r>
+          </a:p>
+          <a:p>
+            <a:pPr marL="228600" indent="-228600">
+              <a:buFont typeface="+mj-lt"/>
+              <a:buAutoNum type="arabicPeriod"/>
+            </a:pPr>
+            <a:r>
+              <a:rPr lang="en-ZA" dirty="0"/>
+              <a:t>Lid includes standoffs to press the plate into the base for sealing.</a:t>
+            </a:r>
+          </a:p>
+          <a:p>
+            <a:pPr marL="228600" indent="-228600">
+              <a:buFont typeface="+mj-lt"/>
+              <a:buAutoNum type="arabicPeriod"/>
+            </a:pPr>
+            <a:r>
+              <a:rPr lang="en-ZA" dirty="0"/>
+              <a:t>The lid is mounted to the base using a counter sunk screw and a </a:t>
+            </a:r>
+            <a:r>
+              <a:rPr lang="en-ZA"/>
+              <a:t>threaded insert in the base.</a:t>
+            </a:r>
+            <a:endParaRPr lang="en-US"/>
+          </a:p>
+        </p:txBody>
+      </p:sp>
+    </p:spTree>
+    <p:extLst>
+      <p:ext uri="{BB962C8B-B14F-4D97-AF65-F5344CB8AC3E}">
+        <p14:creationId xmlns:p14="http://schemas.microsoft.com/office/powerpoint/2010/main" val="2253760168"/>
       </p:ext>
     </p:extLst>
   </p:cSld>
@@ -8903,6 +9638,149 @@
           <p:cNvPr id="2" name="Title 1">
             <a:extLst>
               <a:ext uri="{FF2B5EF4-FFF2-40B4-BE49-F238E27FC236}">
+                <a16:creationId xmlns:a16="http://schemas.microsoft.com/office/drawing/2014/main" id="{314C27C8-165C-5513-DB4B-9D840097C545}"/>
+              </a:ext>
+            </a:extLst>
+          </p:cNvPr>
+          <p:cNvSpPr>
+            <a:spLocks noGrp="1"/>
+          </p:cNvSpPr>
+          <p:nvPr>
+            <p:ph type="title"/>
+          </p:nvPr>
+        </p:nvSpPr>
+        <p:spPr>
+          <a:xfrm>
+            <a:off x="1280160" y="1097280"/>
+            <a:ext cx="5029200" cy="1828800"/>
+          </a:xfrm>
+          <a:noFill/>
+        </p:spPr>
+        <p:txBody>
+          <a:bodyPr anchor="t" anchorCtr="0"/>
+          <a:lstStyle/>
+          <a:p>
+            <a:r>
+              <a:rPr lang="en-US" dirty="0"/>
+              <a:t>Growth strategy</a:t>
+            </a:r>
+          </a:p>
+        </p:txBody>
+      </p:sp>
+      <p:sp>
+        <p:nvSpPr>
+          <p:cNvPr id="3" name="Content Placeholder 2">
+            <a:extLst>
+              <a:ext uri="{FF2B5EF4-FFF2-40B4-BE49-F238E27FC236}">
+                <a16:creationId xmlns:a16="http://schemas.microsoft.com/office/drawing/2014/main" id="{FACE640F-7F5A-BDB7-205D-765FA80B6796}"/>
+              </a:ext>
+            </a:extLst>
+          </p:cNvPr>
+          <p:cNvSpPr>
+            <a:spLocks noGrp="1"/>
+          </p:cNvSpPr>
+          <p:nvPr>
+            <p:ph sz="half" idx="1"/>
+          </p:nvPr>
+        </p:nvSpPr>
+        <p:spPr>
+          <a:xfrm>
+            <a:off x="6784848" y="1097280"/>
+            <a:ext cx="4572000" cy="1828800"/>
+          </a:xfrm>
+          <a:noFill/>
+        </p:spPr>
+        <p:txBody>
+          <a:bodyPr>
+            <a:noAutofit/>
+          </a:bodyPr>
+          <a:lstStyle/>
+          <a:p>
+            <a:r>
+              <a:rPr lang="en-US" dirty="0"/>
+              <a:t>Expand market reach through strategic partnerships</a:t>
+            </a:r>
+          </a:p>
+          <a:p>
+            <a:r>
+              <a:rPr lang="en-US" dirty="0"/>
+              <a:t>Enhance product features based on user feedback</a:t>
+            </a:r>
+          </a:p>
+          <a:p>
+            <a:r>
+              <a:rPr lang="en-US" dirty="0"/>
+              <a:t>Explore international market opportunities</a:t>
+            </a:r>
+          </a:p>
+        </p:txBody>
+      </p:sp>
+      <p:graphicFrame>
+        <p:nvGraphicFramePr>
+          <p:cNvPr id="5" name="Content Placeholder 4" descr="Basic timeline SmartArt graphic">
+            <a:extLst>
+              <a:ext uri="{FF2B5EF4-FFF2-40B4-BE49-F238E27FC236}">
+                <a16:creationId xmlns:a16="http://schemas.microsoft.com/office/drawing/2014/main" id="{2DA25F38-CDC8-7982-99AE-8D5A8ECABC85}"/>
+              </a:ext>
+            </a:extLst>
+          </p:cNvPr>
+          <p:cNvGraphicFramePr>
+            <a:graphicFrameLocks noGrp="1"/>
+          </p:cNvGraphicFramePr>
+          <p:nvPr>
+            <p:ph sz="half" idx="2"/>
+            <p:extLst>
+              <p:ext uri="{D42A27DB-BD31-4B8C-83A1-F6EECF244321}">
+                <p14:modId xmlns:p14="http://schemas.microsoft.com/office/powerpoint/2010/main" val="4243408372"/>
+              </p:ext>
+            </p:extLst>
+          </p:nvPr>
+        </p:nvGraphicFramePr>
+        <p:xfrm>
+          <a:off x="1279525" y="3173413"/>
+          <a:ext cx="10077450" cy="3108325"/>
+        </p:xfrm>
+        <a:graphic>
+          <a:graphicData uri="http://schemas.openxmlformats.org/drawingml/2006/diagram">
+            <dgm:relIds xmlns:dgm="http://schemas.openxmlformats.org/drawingml/2006/diagram" xmlns:r="http://schemas.openxmlformats.org/officeDocument/2006/relationships" r:dm="rId2" r:lo="rId3" r:qs="rId4" r:cs="rId5"/>
+          </a:graphicData>
+        </a:graphic>
+      </p:graphicFrame>
+    </p:spTree>
+    <p:extLst>
+      <p:ext uri="{BB962C8B-B14F-4D97-AF65-F5344CB8AC3E}">
+        <p14:creationId xmlns:p14="http://schemas.microsoft.com/office/powerpoint/2010/main" val="729609147"/>
+      </p:ext>
+    </p:extLst>
+  </p:cSld>
+  <p:clrMapOvr>
+    <a:masterClrMapping/>
+  </p:clrMapOvr>
+</p:sld>
+</file>
+
+<file path=ppt/slides/slide11.xml><?xml version="1.0" encoding="utf-8"?>
+<p:sld xmlns:a="http://schemas.openxmlformats.org/drawingml/2006/main" xmlns:r="http://schemas.openxmlformats.org/officeDocument/2006/relationships" xmlns:p="http://schemas.openxmlformats.org/presentationml/2006/main" show="0">
+  <p:cSld>
+    <p:spTree>
+      <p:nvGrpSpPr>
+        <p:cNvPr id="1" name=""/>
+        <p:cNvGrpSpPr/>
+        <p:nvPr/>
+      </p:nvGrpSpPr>
+      <p:grpSpPr>
+        <a:xfrm>
+          <a:off x="0" y="0"/>
+          <a:ext cx="0" cy="0"/>
+          <a:chOff x="0" y="0"/>
+          <a:chExt cx="0" cy="0"/>
+        </a:xfrm>
+      </p:grpSpPr>
+      <p:sp>
+        <p:nvSpPr>
+          <p:cNvPr id="2" name="Title 1">
+            <a:extLst>
+              <a:ext uri="{FF2B5EF4-FFF2-40B4-BE49-F238E27FC236}">
                 <a16:creationId xmlns:a16="http://schemas.microsoft.com/office/drawing/2014/main" id="{B7545968-70F7-0180-6448-3547E442EF4A}"/>
               </a:ext>
             </a:extLst>
@@ -9242,7 +10120,7 @@
 </p:sld>
 </file>
 
-<file path=ppt/slides/slide11.xml><?xml version="1.0" encoding="utf-8"?>
+<file path=ppt/slides/slide12.xml><?xml version="1.0" encoding="utf-8"?>
 <p:sld xmlns:a="http://schemas.openxmlformats.org/drawingml/2006/main" xmlns:r="http://schemas.openxmlformats.org/officeDocument/2006/relationships" xmlns:p="http://schemas.openxmlformats.org/presentationml/2006/main" show="0">
   <p:cSld>
     <p:spTree>
@@ -9686,7 +10564,7 @@
 </p:sld>
 </file>
 
-<file path=ppt/slides/slide12.xml><?xml version="1.0" encoding="utf-8"?>
+<file path=ppt/slides/slide13.xml><?xml version="1.0" encoding="utf-8"?>
 <p:sld xmlns:a="http://schemas.openxmlformats.org/drawingml/2006/main" xmlns:r="http://schemas.openxmlformats.org/officeDocument/2006/relationships" xmlns:p="http://schemas.openxmlformats.org/presentationml/2006/main" show="0">
   <p:cSld>
     <p:spTree>
@@ -9856,7 +10734,7 @@
 </p:sld>
 </file>
 
-<file path=ppt/slides/slide13.xml><?xml version="1.0" encoding="utf-8"?>
+<file path=ppt/slides/slide14.xml><?xml version="1.0" encoding="utf-8"?>
 <p:sld xmlns:a="http://schemas.openxmlformats.org/drawingml/2006/main" xmlns:r="http://schemas.openxmlformats.org/officeDocument/2006/relationships" xmlns:p="http://schemas.openxmlformats.org/presentationml/2006/main" show="0">
   <p:cSld>
     <p:spTree>
@@ -10254,7 +11132,7 @@
           <a:p>
             <a:r>
               <a:rPr lang="en-US" dirty="0"/>
-              <a:t>Determine feasibility of designing a Stage-Top Incubator suitable for BSL-3</a:t>
+              <a:t>Determine feasibility of designing a stage-top bio-containment system suitable for BSL-3</a:t>
             </a:r>
           </a:p>
           <a:p>
@@ -10350,7 +11228,7 @@
 </file>
 
 <file path=ppt/slides/slide4.xml><?xml version="1.0" encoding="utf-8"?>
-<p:sld xmlns:a="http://schemas.openxmlformats.org/drawingml/2006/main" xmlns:r="http://schemas.openxmlformats.org/officeDocument/2006/relationships" xmlns:p="http://schemas.openxmlformats.org/presentationml/2006/main" show="0">
+<p:sld xmlns:a="http://schemas.openxmlformats.org/drawingml/2006/main" xmlns:r="http://schemas.openxmlformats.org/officeDocument/2006/relationships" xmlns:p="http://schemas.openxmlformats.org/presentationml/2006/main">
   <p:cSld>
     <p:spTree>
       <p:nvGrpSpPr>
@@ -10384,8 +11262,8 @@
         </p:nvSpPr>
         <p:spPr>
           <a:xfrm>
-            <a:off x="841248" y="2697480"/>
-            <a:ext cx="10515600" cy="2606040"/>
+            <a:off x="838200" y="209462"/>
+            <a:ext cx="10515600" cy="1098343"/>
           </a:xfrm>
           <a:noFill/>
         </p:spPr>
@@ -10397,75 +11275,409 @@
           <a:p>
             <a:r>
               <a:rPr lang="en-US" dirty="0"/>
-              <a:t>About us</a:t>
-            </a:r>
-          </a:p>
-        </p:txBody>
-      </p:sp>
-      <p:sp>
-        <p:nvSpPr>
-          <p:cNvPr id="3" name="Subtitle 2">
-            <a:extLst>
-              <a:ext uri="{FF2B5EF4-FFF2-40B4-BE49-F238E27FC236}">
-                <a16:creationId xmlns:a16="http://schemas.microsoft.com/office/drawing/2014/main" id="{72446868-83F0-CEEF-5E60-6D55C93B523F}"/>
-              </a:ext>
-            </a:extLst>
-          </p:cNvPr>
-          <p:cNvSpPr>
-            <a:spLocks noGrp="1"/>
-          </p:cNvSpPr>
-          <p:nvPr>
-            <p:ph type="subTitle" idx="1"/>
-          </p:nvPr>
-        </p:nvSpPr>
-        <p:spPr>
-          <a:xfrm>
-            <a:off x="841248" y="6044184"/>
-            <a:ext cx="10515600" cy="457200"/>
-          </a:xfrm>
-          <a:noFill/>
-        </p:spPr>
-        <p:txBody>
-          <a:bodyPr>
-            <a:normAutofit/>
-          </a:bodyPr>
-          <a:lstStyle/>
-          <a:p>
-            <a:r>
-              <a:rPr lang="en-US" dirty="0"/>
-              <a:t>Aiming to revolutionize industries through our forward-thinking solutions</a:t>
+              <a:t>Prototyping V1</a:t>
             </a:r>
           </a:p>
         </p:txBody>
       </p:sp>
       <p:pic>
         <p:nvPicPr>
-          <p:cNvPr id="10" name="Picture Placeholder 9" descr="Close up of bubbles">
+          <p:cNvPr id="16" name="Picture 15">
             <a:extLst>
               <a:ext uri="{FF2B5EF4-FFF2-40B4-BE49-F238E27FC236}">
-                <a16:creationId xmlns:a16="http://schemas.microsoft.com/office/drawing/2014/main" id="{99058E17-80B3-F3F9-AF6A-0518C39D940F}"/>
+                <a16:creationId xmlns:a16="http://schemas.microsoft.com/office/drawing/2014/main" id="{EC0B6619-4249-56D3-AA68-E9D9F6A518EF}"/>
               </a:ext>
             </a:extLst>
           </p:cNvPr>
           <p:cNvPicPr>
-            <a:picLocks noGrp="1" noChangeAspect="1"/>
+            <a:picLocks noChangeAspect="1"/>
           </p:cNvPicPr>
-          <p:nvPr>
-            <p:ph type="pic" sz="quarter" idx="13"/>
-          </p:nvPr>
+          <p:nvPr/>
         </p:nvPicPr>
         <p:blipFill>
-          <a:blip r:embed="rId2"/>
-          <a:srcRect l="83" r="83"/>
-          <a:stretch/>
+          <a:blip r:embed="rId3"/>
+          <a:stretch>
+            <a:fillRect/>
+          </a:stretch>
         </p:blipFill>
         <p:spPr>
           <a:xfrm>
-            <a:off x="0" y="0"/>
-            <a:ext cx="12188952" cy="2368296"/>
+            <a:off x="6939006" y="1815383"/>
+            <a:ext cx="4414794" cy="3231629"/>
           </a:xfrm>
+          <a:prstGeom prst="rect">
+            <a:avLst/>
+          </a:prstGeom>
         </p:spPr>
       </p:pic>
+      <p:pic>
+        <p:nvPicPr>
+          <p:cNvPr id="22" name="Picture 21">
+            <a:extLst>
+              <a:ext uri="{FF2B5EF4-FFF2-40B4-BE49-F238E27FC236}">
+                <a16:creationId xmlns:a16="http://schemas.microsoft.com/office/drawing/2014/main" id="{84FC55AD-FE16-0299-BFFE-CC8A810E6B37}"/>
+              </a:ext>
+            </a:extLst>
+          </p:cNvPr>
+          <p:cNvPicPr>
+            <a:picLocks noChangeAspect="1"/>
+          </p:cNvPicPr>
+          <p:nvPr/>
+        </p:nvPicPr>
+        <p:blipFill>
+          <a:blip r:embed="rId4"/>
+          <a:stretch>
+            <a:fillRect/>
+          </a:stretch>
+        </p:blipFill>
+        <p:spPr>
+          <a:xfrm>
+            <a:off x="262889" y="1815383"/>
+            <a:ext cx="6416031" cy="3231629"/>
+          </a:xfrm>
+          <a:prstGeom prst="rect">
+            <a:avLst/>
+          </a:prstGeom>
+        </p:spPr>
+      </p:pic>
+      <p:cxnSp>
+        <p:nvCxnSpPr>
+          <p:cNvPr id="24" name="Straight Arrow Connector 23">
+            <a:extLst>
+              <a:ext uri="{FF2B5EF4-FFF2-40B4-BE49-F238E27FC236}">
+                <a16:creationId xmlns:a16="http://schemas.microsoft.com/office/drawing/2014/main" id="{F1EA5270-97B0-DA22-7F2F-8ED6CAF1B1B7}"/>
+              </a:ext>
+            </a:extLst>
+          </p:cNvPr>
+          <p:cNvCxnSpPr/>
+          <p:nvPr/>
+        </p:nvCxnSpPr>
+        <p:spPr>
+          <a:xfrm>
+            <a:off x="631596" y="1307805"/>
+            <a:ext cx="490194" cy="1633358"/>
+          </a:xfrm>
+          <a:prstGeom prst="straightConnector1">
+            <a:avLst/>
+          </a:prstGeom>
+          <a:ln>
+            <a:solidFill>
+              <a:schemeClr val="tx1"/>
+            </a:solidFill>
+            <a:tailEnd type="triangle"/>
+          </a:ln>
+        </p:spPr>
+        <p:style>
+          <a:lnRef idx="1">
+            <a:schemeClr val="accent1"/>
+          </a:lnRef>
+          <a:fillRef idx="0">
+            <a:schemeClr val="accent1"/>
+          </a:fillRef>
+          <a:effectRef idx="0">
+            <a:schemeClr val="accent1"/>
+          </a:effectRef>
+          <a:fontRef idx="minor">
+            <a:schemeClr val="tx1"/>
+          </a:fontRef>
+        </p:style>
+      </p:cxnSp>
+      <p:sp>
+        <p:nvSpPr>
+          <p:cNvPr id="25" name="TextBox 24">
+            <a:extLst>
+              <a:ext uri="{FF2B5EF4-FFF2-40B4-BE49-F238E27FC236}">
+                <a16:creationId xmlns:a16="http://schemas.microsoft.com/office/drawing/2014/main" id="{BC2618DD-1892-E29D-47BA-8589984A0E8A}"/>
+              </a:ext>
+            </a:extLst>
+          </p:cNvPr>
+          <p:cNvSpPr txBox="1"/>
+          <p:nvPr/>
+        </p:nvSpPr>
+        <p:spPr>
+          <a:xfrm>
+            <a:off x="138649" y="1007596"/>
+            <a:ext cx="1399101" cy="369332"/>
+          </a:xfrm>
+          <a:prstGeom prst="rect">
+            <a:avLst/>
+          </a:prstGeom>
+          <a:noFill/>
+        </p:spPr>
+        <p:txBody>
+          <a:bodyPr wrap="none" rtlCol="0">
+            <a:spAutoFit/>
+          </a:bodyPr>
+          <a:lstStyle/>
+          <a:p>
+            <a:r>
+              <a:rPr lang="en-US" dirty="0"/>
+              <a:t>O-Ring Groove</a:t>
+            </a:r>
+          </a:p>
+        </p:txBody>
+      </p:sp>
+      <p:cxnSp>
+        <p:nvCxnSpPr>
+          <p:cNvPr id="29" name="Straight Arrow Connector 28">
+            <a:extLst>
+              <a:ext uri="{FF2B5EF4-FFF2-40B4-BE49-F238E27FC236}">
+                <a16:creationId xmlns:a16="http://schemas.microsoft.com/office/drawing/2014/main" id="{7024E816-5B85-11F8-35EC-225C0329971D}"/>
+              </a:ext>
+            </a:extLst>
+          </p:cNvPr>
+          <p:cNvCxnSpPr/>
+          <p:nvPr/>
+        </p:nvCxnSpPr>
+        <p:spPr>
+          <a:xfrm flipH="1" flipV="1">
+            <a:off x="2102177" y="2780907"/>
+            <a:ext cx="716437" cy="2611225"/>
+          </a:xfrm>
+          <a:prstGeom prst="straightConnector1">
+            <a:avLst/>
+          </a:prstGeom>
+          <a:ln>
+            <a:tailEnd type="triangle"/>
+          </a:ln>
+        </p:spPr>
+        <p:style>
+          <a:lnRef idx="1">
+            <a:schemeClr val="dk1"/>
+          </a:lnRef>
+          <a:fillRef idx="0">
+            <a:schemeClr val="dk1"/>
+          </a:fillRef>
+          <a:effectRef idx="0">
+            <a:schemeClr val="dk1"/>
+          </a:effectRef>
+          <a:fontRef idx="minor">
+            <a:schemeClr val="tx1"/>
+          </a:fontRef>
+        </p:style>
+      </p:cxnSp>
+      <p:cxnSp>
+        <p:nvCxnSpPr>
+          <p:cNvPr id="31" name="Straight Arrow Connector 30">
+            <a:extLst>
+              <a:ext uri="{FF2B5EF4-FFF2-40B4-BE49-F238E27FC236}">
+                <a16:creationId xmlns:a16="http://schemas.microsoft.com/office/drawing/2014/main" id="{E4EC052F-811E-C09D-98A9-9728117AA578}"/>
+              </a:ext>
+            </a:extLst>
+          </p:cNvPr>
+          <p:cNvCxnSpPr/>
+          <p:nvPr/>
+        </p:nvCxnSpPr>
+        <p:spPr>
+          <a:xfrm flipV="1">
+            <a:off x="2818614" y="4072379"/>
+            <a:ext cx="282805" cy="1319753"/>
+          </a:xfrm>
+          <a:prstGeom prst="straightConnector1">
+            <a:avLst/>
+          </a:prstGeom>
+          <a:ln>
+            <a:tailEnd type="triangle"/>
+          </a:ln>
+        </p:spPr>
+        <p:style>
+          <a:lnRef idx="1">
+            <a:schemeClr val="dk1"/>
+          </a:lnRef>
+          <a:fillRef idx="0">
+            <a:schemeClr val="dk1"/>
+          </a:fillRef>
+          <a:effectRef idx="0">
+            <a:schemeClr val="dk1"/>
+          </a:effectRef>
+          <a:fontRef idx="minor">
+            <a:schemeClr val="tx1"/>
+          </a:fontRef>
+        </p:style>
+      </p:cxnSp>
+      <p:sp>
+        <p:nvSpPr>
+          <p:cNvPr id="32" name="TextBox 31">
+            <a:extLst>
+              <a:ext uri="{FF2B5EF4-FFF2-40B4-BE49-F238E27FC236}">
+                <a16:creationId xmlns:a16="http://schemas.microsoft.com/office/drawing/2014/main" id="{DDA9F899-BE29-24FA-C41D-36583F125CF6}"/>
+              </a:ext>
+            </a:extLst>
+          </p:cNvPr>
+          <p:cNvSpPr txBox="1"/>
+          <p:nvPr/>
+        </p:nvSpPr>
+        <p:spPr>
+          <a:xfrm>
+            <a:off x="1537750" y="5392132"/>
+            <a:ext cx="2590004" cy="369332"/>
+          </a:xfrm>
+          <a:prstGeom prst="rect">
+            <a:avLst/>
+          </a:prstGeom>
+          <a:noFill/>
+        </p:spPr>
+        <p:txBody>
+          <a:bodyPr wrap="none" rtlCol="0">
+            <a:spAutoFit/>
+          </a:bodyPr>
+          <a:lstStyle/>
+          <a:p>
+            <a:r>
+              <a:rPr lang="en-US" dirty="0"/>
+              <a:t>Top and Bottom Plate Insert</a:t>
+            </a:r>
+          </a:p>
+        </p:txBody>
+      </p:sp>
+      <p:cxnSp>
+        <p:nvCxnSpPr>
+          <p:cNvPr id="34" name="Straight Arrow Connector 33">
+            <a:extLst>
+              <a:ext uri="{FF2B5EF4-FFF2-40B4-BE49-F238E27FC236}">
+                <a16:creationId xmlns:a16="http://schemas.microsoft.com/office/drawing/2014/main" id="{517535E0-6D4E-5EC7-FFBC-F5A505FDDD92}"/>
+              </a:ext>
+            </a:extLst>
+          </p:cNvPr>
+          <p:cNvCxnSpPr/>
+          <p:nvPr/>
+        </p:nvCxnSpPr>
+        <p:spPr>
+          <a:xfrm flipH="1" flipV="1">
+            <a:off x="4345757" y="3685880"/>
+            <a:ext cx="622169" cy="1706252"/>
+          </a:xfrm>
+          <a:prstGeom prst="straightConnector1">
+            <a:avLst/>
+          </a:prstGeom>
+          <a:ln>
+            <a:tailEnd type="triangle"/>
+          </a:ln>
+        </p:spPr>
+        <p:style>
+          <a:lnRef idx="1">
+            <a:schemeClr val="dk1"/>
+          </a:lnRef>
+          <a:fillRef idx="0">
+            <a:schemeClr val="dk1"/>
+          </a:fillRef>
+          <a:effectRef idx="0">
+            <a:schemeClr val="dk1"/>
+          </a:effectRef>
+          <a:fontRef idx="minor">
+            <a:schemeClr val="tx1"/>
+          </a:fontRef>
+        </p:style>
+      </p:cxnSp>
+      <p:sp>
+        <p:nvSpPr>
+          <p:cNvPr id="35" name="TextBox 34">
+            <a:extLst>
+              <a:ext uri="{FF2B5EF4-FFF2-40B4-BE49-F238E27FC236}">
+                <a16:creationId xmlns:a16="http://schemas.microsoft.com/office/drawing/2014/main" id="{3F4DCCD6-9DDA-667A-813F-B248A9C132FF}"/>
+              </a:ext>
+            </a:extLst>
+          </p:cNvPr>
+          <p:cNvSpPr txBox="1"/>
+          <p:nvPr/>
+        </p:nvSpPr>
+        <p:spPr>
+          <a:xfrm>
+            <a:off x="4387254" y="5393819"/>
+            <a:ext cx="1161344" cy="369332"/>
+          </a:xfrm>
+          <a:prstGeom prst="rect">
+            <a:avLst/>
+          </a:prstGeom>
+          <a:noFill/>
+        </p:spPr>
+        <p:txBody>
+          <a:bodyPr wrap="none" rtlCol="0">
+            <a:spAutoFit/>
+          </a:bodyPr>
+          <a:lstStyle/>
+          <a:p>
+            <a:r>
+              <a:rPr lang="en-US" dirty="0"/>
+              <a:t>Plate Cavity</a:t>
+            </a:r>
+          </a:p>
+        </p:txBody>
+      </p:sp>
+      <p:cxnSp>
+        <p:nvCxnSpPr>
+          <p:cNvPr id="37" name="Straight Arrow Connector 36">
+            <a:extLst>
+              <a:ext uri="{FF2B5EF4-FFF2-40B4-BE49-F238E27FC236}">
+                <a16:creationId xmlns:a16="http://schemas.microsoft.com/office/drawing/2014/main" id="{BD8243A6-ECCD-3ACC-9686-B609C752C91B}"/>
+              </a:ext>
+            </a:extLst>
+          </p:cNvPr>
+          <p:cNvCxnSpPr/>
+          <p:nvPr/>
+        </p:nvCxnSpPr>
+        <p:spPr>
+          <a:xfrm flipV="1">
+            <a:off x="8738647" y="4204355"/>
+            <a:ext cx="707011" cy="1187777"/>
+          </a:xfrm>
+          <a:prstGeom prst="straightConnector1">
+            <a:avLst/>
+          </a:prstGeom>
+          <a:ln>
+            <a:tailEnd type="triangle"/>
+          </a:ln>
+        </p:spPr>
+        <p:style>
+          <a:lnRef idx="1">
+            <a:schemeClr val="dk1"/>
+          </a:lnRef>
+          <a:fillRef idx="0">
+            <a:schemeClr val="dk1"/>
+          </a:fillRef>
+          <a:effectRef idx="0">
+            <a:schemeClr val="dk1"/>
+          </a:effectRef>
+          <a:fontRef idx="minor">
+            <a:schemeClr val="tx1"/>
+          </a:fontRef>
+        </p:style>
+      </p:cxnSp>
+      <p:sp>
+        <p:nvSpPr>
+          <p:cNvPr id="38" name="TextBox 37">
+            <a:extLst>
+              <a:ext uri="{FF2B5EF4-FFF2-40B4-BE49-F238E27FC236}">
+                <a16:creationId xmlns:a16="http://schemas.microsoft.com/office/drawing/2014/main" id="{2A6FCFB0-523B-627F-E71C-34AE61F532CB}"/>
+              </a:ext>
+            </a:extLst>
+          </p:cNvPr>
+          <p:cNvSpPr txBox="1"/>
+          <p:nvPr/>
+        </p:nvSpPr>
+        <p:spPr>
+          <a:xfrm>
+            <a:off x="7794542" y="5392132"/>
+            <a:ext cx="1888209" cy="369332"/>
+          </a:xfrm>
+          <a:prstGeom prst="rect">
+            <a:avLst/>
+          </a:prstGeom>
+          <a:noFill/>
+        </p:spPr>
+        <p:txBody>
+          <a:bodyPr wrap="none" rtlCol="0">
+            <a:spAutoFit/>
+          </a:bodyPr>
+          <a:lstStyle/>
+          <a:p>
+            <a:r>
+              <a:rPr lang="en-US" dirty="0"/>
+              <a:t>Secured Using Bolts</a:t>
+            </a:r>
+          </a:p>
+        </p:txBody>
+      </p:sp>
     </p:spTree>
     <p:extLst>
       <p:ext uri="{BB962C8B-B14F-4D97-AF65-F5344CB8AC3E}">
@@ -10480,6 +11692,716 @@
 </file>
 
 <file path=ppt/slides/slide5.xml><?xml version="1.0" encoding="utf-8"?>
+<p:sld xmlns:a="http://schemas.openxmlformats.org/drawingml/2006/main" xmlns:r="http://schemas.openxmlformats.org/officeDocument/2006/relationships" xmlns:p="http://schemas.openxmlformats.org/presentationml/2006/main">
+  <p:cSld>
+    <p:spTree>
+      <p:nvGrpSpPr>
+        <p:cNvPr id="1" name="">
+          <a:extLst>
+            <a:ext uri="{FF2B5EF4-FFF2-40B4-BE49-F238E27FC236}">
+              <a16:creationId xmlns:a16="http://schemas.microsoft.com/office/drawing/2014/main" id="{23F94AA3-FA04-4C74-855E-FCD7A0C6DD9D}"/>
+            </a:ext>
+          </a:extLst>
+        </p:cNvPr>
+        <p:cNvGrpSpPr/>
+        <p:nvPr/>
+      </p:nvGrpSpPr>
+      <p:grpSpPr>
+        <a:xfrm>
+          <a:off x="0" y="0"/>
+          <a:ext cx="0" cy="0"/>
+          <a:chOff x="0" y="0"/>
+          <a:chExt cx="0" cy="0"/>
+        </a:xfrm>
+      </p:grpSpPr>
+      <p:sp>
+        <p:nvSpPr>
+          <p:cNvPr id="2" name="Title 1">
+            <a:extLst>
+              <a:ext uri="{FF2B5EF4-FFF2-40B4-BE49-F238E27FC236}">
+                <a16:creationId xmlns:a16="http://schemas.microsoft.com/office/drawing/2014/main" id="{1C5EDC56-2648-71A0-B020-497F2AC0BCD2}"/>
+              </a:ext>
+            </a:extLst>
+          </p:cNvPr>
+          <p:cNvSpPr>
+            <a:spLocks noGrp="1"/>
+          </p:cNvSpPr>
+          <p:nvPr>
+            <p:ph type="ctrTitle"/>
+          </p:nvPr>
+        </p:nvSpPr>
+        <p:spPr>
+          <a:xfrm>
+            <a:off x="838200" y="209462"/>
+            <a:ext cx="10515600" cy="1098343"/>
+          </a:xfrm>
+          <a:noFill/>
+        </p:spPr>
+        <p:txBody>
+          <a:bodyPr anchor="ctr" anchorCtr="0">
+            <a:noAutofit/>
+          </a:bodyPr>
+          <a:lstStyle/>
+          <a:p>
+            <a:r>
+              <a:rPr lang="en-US" dirty="0"/>
+              <a:t>Prototyping V3.3</a:t>
+            </a:r>
+          </a:p>
+        </p:txBody>
+      </p:sp>
+      <p:sp>
+        <p:nvSpPr>
+          <p:cNvPr id="38" name="TextBox 37">
+            <a:extLst>
+              <a:ext uri="{FF2B5EF4-FFF2-40B4-BE49-F238E27FC236}">
+                <a16:creationId xmlns:a16="http://schemas.microsoft.com/office/drawing/2014/main" id="{A2A16A3E-4296-0FC3-C911-74084EADC242}"/>
+              </a:ext>
+            </a:extLst>
+          </p:cNvPr>
+          <p:cNvSpPr txBox="1"/>
+          <p:nvPr/>
+        </p:nvSpPr>
+        <p:spPr>
+          <a:xfrm>
+            <a:off x="7794542" y="5392132"/>
+            <a:ext cx="1967911" cy="646331"/>
+          </a:xfrm>
+          <a:prstGeom prst="rect">
+            <a:avLst/>
+          </a:prstGeom>
+          <a:noFill/>
+        </p:spPr>
+        <p:txBody>
+          <a:bodyPr wrap="none" rtlCol="0">
+            <a:spAutoFit/>
+          </a:bodyPr>
+          <a:lstStyle/>
+          <a:p>
+            <a:r>
+              <a:rPr lang="en-US" dirty="0"/>
+              <a:t>Secured Using </a:t>
+            </a:r>
+          </a:p>
+          <a:p>
+            <a:r>
+              <a:rPr lang="en-US" dirty="0"/>
+              <a:t>Counter Sunk Screws</a:t>
+            </a:r>
+          </a:p>
+        </p:txBody>
+      </p:sp>
+      <p:pic>
+        <p:nvPicPr>
+          <p:cNvPr id="6" name="Picture 5">
+            <a:extLst>
+              <a:ext uri="{FF2B5EF4-FFF2-40B4-BE49-F238E27FC236}">
+                <a16:creationId xmlns:a16="http://schemas.microsoft.com/office/drawing/2014/main" id="{C1AB545E-CBBA-0DBC-0D83-4B26E860A3E9}"/>
+              </a:ext>
+            </a:extLst>
+          </p:cNvPr>
+          <p:cNvPicPr>
+            <a:picLocks noChangeAspect="1"/>
+          </p:cNvPicPr>
+          <p:nvPr/>
+        </p:nvPicPr>
+        <p:blipFill>
+          <a:blip r:embed="rId3"/>
+          <a:stretch>
+            <a:fillRect/>
+          </a:stretch>
+        </p:blipFill>
+        <p:spPr>
+          <a:xfrm>
+            <a:off x="91870" y="1815383"/>
+            <a:ext cx="6509507" cy="3231629"/>
+          </a:xfrm>
+          <a:prstGeom prst="rect">
+            <a:avLst/>
+          </a:prstGeom>
+        </p:spPr>
+      </p:pic>
+      <p:cxnSp>
+        <p:nvCxnSpPr>
+          <p:cNvPr id="8" name="Straight Arrow Connector 7">
+            <a:extLst>
+              <a:ext uri="{FF2B5EF4-FFF2-40B4-BE49-F238E27FC236}">
+                <a16:creationId xmlns:a16="http://schemas.microsoft.com/office/drawing/2014/main" id="{B88CD4C8-7545-7C82-9810-545F301BB4A3}"/>
+              </a:ext>
+            </a:extLst>
+          </p:cNvPr>
+          <p:cNvCxnSpPr>
+            <a:cxnSpLocks/>
+          </p:cNvCxnSpPr>
+          <p:nvPr/>
+        </p:nvCxnSpPr>
+        <p:spPr>
+          <a:xfrm>
+            <a:off x="904973" y="1567765"/>
+            <a:ext cx="0" cy="1448812"/>
+          </a:xfrm>
+          <a:prstGeom prst="straightConnector1">
+            <a:avLst/>
+          </a:prstGeom>
+          <a:ln>
+            <a:tailEnd type="triangle"/>
+          </a:ln>
+        </p:spPr>
+        <p:style>
+          <a:lnRef idx="1">
+            <a:schemeClr val="dk1"/>
+          </a:lnRef>
+          <a:fillRef idx="0">
+            <a:schemeClr val="dk1"/>
+          </a:fillRef>
+          <a:effectRef idx="0">
+            <a:schemeClr val="dk1"/>
+          </a:effectRef>
+          <a:fontRef idx="minor">
+            <a:schemeClr val="tx1"/>
+          </a:fontRef>
+        </p:style>
+      </p:cxnSp>
+      <p:cxnSp>
+        <p:nvCxnSpPr>
+          <p:cNvPr id="13" name="Straight Arrow Connector 12">
+            <a:extLst>
+              <a:ext uri="{FF2B5EF4-FFF2-40B4-BE49-F238E27FC236}">
+                <a16:creationId xmlns:a16="http://schemas.microsoft.com/office/drawing/2014/main" id="{CB231952-3BDE-C96E-2D97-8104C17D7CB9}"/>
+              </a:ext>
+            </a:extLst>
+          </p:cNvPr>
+          <p:cNvCxnSpPr/>
+          <p:nvPr/>
+        </p:nvCxnSpPr>
+        <p:spPr>
+          <a:xfrm flipH="1">
+            <a:off x="1574276" y="1555423"/>
+            <a:ext cx="1762813" cy="1536569"/>
+          </a:xfrm>
+          <a:prstGeom prst="straightConnector1">
+            <a:avLst/>
+          </a:prstGeom>
+          <a:ln>
+            <a:tailEnd type="triangle"/>
+          </a:ln>
+        </p:spPr>
+        <p:style>
+          <a:lnRef idx="1">
+            <a:schemeClr val="dk1"/>
+          </a:lnRef>
+          <a:fillRef idx="0">
+            <a:schemeClr val="dk1"/>
+          </a:fillRef>
+          <a:effectRef idx="0">
+            <a:schemeClr val="dk1"/>
+          </a:effectRef>
+          <a:fontRef idx="minor">
+            <a:schemeClr val="tx1"/>
+          </a:fontRef>
+        </p:style>
+      </p:cxnSp>
+      <p:cxnSp>
+        <p:nvCxnSpPr>
+          <p:cNvPr id="15" name="Straight Arrow Connector 14">
+            <a:extLst>
+              <a:ext uri="{FF2B5EF4-FFF2-40B4-BE49-F238E27FC236}">
+                <a16:creationId xmlns:a16="http://schemas.microsoft.com/office/drawing/2014/main" id="{A62BABF9-266B-6777-6C16-EDBBF8066092}"/>
+              </a:ext>
+            </a:extLst>
+          </p:cNvPr>
+          <p:cNvCxnSpPr/>
+          <p:nvPr/>
+        </p:nvCxnSpPr>
+        <p:spPr>
+          <a:xfrm>
+            <a:off x="3346515" y="1555423"/>
+            <a:ext cx="0" cy="1461154"/>
+          </a:xfrm>
+          <a:prstGeom prst="straightConnector1">
+            <a:avLst/>
+          </a:prstGeom>
+          <a:ln>
+            <a:tailEnd type="triangle"/>
+          </a:ln>
+        </p:spPr>
+        <p:style>
+          <a:lnRef idx="1">
+            <a:schemeClr val="dk1"/>
+          </a:lnRef>
+          <a:fillRef idx="0">
+            <a:schemeClr val="dk1"/>
+          </a:fillRef>
+          <a:effectRef idx="0">
+            <a:schemeClr val="dk1"/>
+          </a:effectRef>
+          <a:fontRef idx="minor">
+            <a:schemeClr val="tx1"/>
+          </a:fontRef>
+        </p:style>
+      </p:cxnSp>
+      <p:sp>
+        <p:nvSpPr>
+          <p:cNvPr id="17" name="TextBox 16">
+            <a:extLst>
+              <a:ext uri="{FF2B5EF4-FFF2-40B4-BE49-F238E27FC236}">
+                <a16:creationId xmlns:a16="http://schemas.microsoft.com/office/drawing/2014/main" id="{694880DF-1471-C70C-BFFF-679A07071A7B}"/>
+              </a:ext>
+            </a:extLst>
+          </p:cNvPr>
+          <p:cNvSpPr txBox="1"/>
+          <p:nvPr/>
+        </p:nvSpPr>
+        <p:spPr>
+          <a:xfrm>
+            <a:off x="91870" y="1117303"/>
+            <a:ext cx="2238177" cy="369332"/>
+          </a:xfrm>
+          <a:prstGeom prst="rect">
+            <a:avLst/>
+          </a:prstGeom>
+          <a:noFill/>
+        </p:spPr>
+        <p:txBody>
+          <a:bodyPr wrap="none" rtlCol="0">
+            <a:spAutoFit/>
+          </a:bodyPr>
+          <a:lstStyle/>
+          <a:p>
+            <a:r>
+              <a:rPr lang="en-US" dirty="0"/>
+              <a:t>Recessed O-Ring Groove</a:t>
+            </a:r>
+            <a:endParaRPr lang="en-ZA" dirty="0"/>
+          </a:p>
+        </p:txBody>
+      </p:sp>
+      <p:sp>
+        <p:nvSpPr>
+          <p:cNvPr id="18" name="TextBox 17">
+            <a:extLst>
+              <a:ext uri="{FF2B5EF4-FFF2-40B4-BE49-F238E27FC236}">
+                <a16:creationId xmlns:a16="http://schemas.microsoft.com/office/drawing/2014/main" id="{6AB63C6C-E21F-49A8-2DF3-799952C932C0}"/>
+              </a:ext>
+            </a:extLst>
+          </p:cNvPr>
+          <p:cNvSpPr txBox="1"/>
+          <p:nvPr/>
+        </p:nvSpPr>
+        <p:spPr>
+          <a:xfrm>
+            <a:off x="2443831" y="1131405"/>
+            <a:ext cx="1786515" cy="369332"/>
+          </a:xfrm>
+          <a:prstGeom prst="rect">
+            <a:avLst/>
+          </a:prstGeom>
+          <a:noFill/>
+        </p:spPr>
+        <p:txBody>
+          <a:bodyPr wrap="none" rtlCol="0">
+            <a:spAutoFit/>
+          </a:bodyPr>
+          <a:lstStyle/>
+          <a:p>
+            <a:r>
+              <a:rPr lang="en-US" dirty="0"/>
+              <a:t>Plate Lid Standoffs</a:t>
+            </a:r>
+          </a:p>
+        </p:txBody>
+      </p:sp>
+      <p:cxnSp>
+        <p:nvCxnSpPr>
+          <p:cNvPr id="20" name="Straight Arrow Connector 19">
+            <a:extLst>
+              <a:ext uri="{FF2B5EF4-FFF2-40B4-BE49-F238E27FC236}">
+                <a16:creationId xmlns:a16="http://schemas.microsoft.com/office/drawing/2014/main" id="{92F2A379-D195-021E-7225-7EB9A36A7B5B}"/>
+              </a:ext>
+            </a:extLst>
+          </p:cNvPr>
+          <p:cNvCxnSpPr/>
+          <p:nvPr/>
+        </p:nvCxnSpPr>
+        <p:spPr>
+          <a:xfrm flipV="1">
+            <a:off x="1489435" y="3930977"/>
+            <a:ext cx="0" cy="1329180"/>
+          </a:xfrm>
+          <a:prstGeom prst="straightConnector1">
+            <a:avLst/>
+          </a:prstGeom>
+          <a:ln>
+            <a:tailEnd type="triangle"/>
+          </a:ln>
+        </p:spPr>
+        <p:style>
+          <a:lnRef idx="1">
+            <a:schemeClr val="dk1"/>
+          </a:lnRef>
+          <a:fillRef idx="0">
+            <a:schemeClr val="dk1"/>
+          </a:fillRef>
+          <a:effectRef idx="0">
+            <a:schemeClr val="dk1"/>
+          </a:effectRef>
+          <a:fontRef idx="minor">
+            <a:schemeClr val="tx1"/>
+          </a:fontRef>
+        </p:style>
+      </p:cxnSp>
+      <p:sp>
+        <p:nvSpPr>
+          <p:cNvPr id="21" name="TextBox 20">
+            <a:extLst>
+              <a:ext uri="{FF2B5EF4-FFF2-40B4-BE49-F238E27FC236}">
+                <a16:creationId xmlns:a16="http://schemas.microsoft.com/office/drawing/2014/main" id="{B7946254-962A-CE33-7F2D-B9E3052CCB5C}"/>
+              </a:ext>
+            </a:extLst>
+          </p:cNvPr>
+          <p:cNvSpPr txBox="1"/>
+          <p:nvPr/>
+        </p:nvSpPr>
+        <p:spPr>
+          <a:xfrm>
+            <a:off x="513751" y="5209273"/>
+            <a:ext cx="1930080" cy="369332"/>
+          </a:xfrm>
+          <a:prstGeom prst="rect">
+            <a:avLst/>
+          </a:prstGeom>
+          <a:noFill/>
+        </p:spPr>
+        <p:txBody>
+          <a:bodyPr wrap="none" rtlCol="0">
+            <a:spAutoFit/>
+          </a:bodyPr>
+          <a:lstStyle/>
+          <a:p>
+            <a:r>
+              <a:rPr lang="en-US" dirty="0"/>
+              <a:t>Sealing Plate Recess</a:t>
+            </a:r>
+          </a:p>
+        </p:txBody>
+      </p:sp>
+      <p:cxnSp>
+        <p:nvCxnSpPr>
+          <p:cNvPr id="26" name="Straight Arrow Connector 25">
+            <a:extLst>
+              <a:ext uri="{FF2B5EF4-FFF2-40B4-BE49-F238E27FC236}">
+                <a16:creationId xmlns:a16="http://schemas.microsoft.com/office/drawing/2014/main" id="{17DA7481-E0B5-8D0B-8B62-8F1CA411F6C8}"/>
+              </a:ext>
+            </a:extLst>
+          </p:cNvPr>
+          <p:cNvCxnSpPr>
+            <a:cxnSpLocks/>
+          </p:cNvCxnSpPr>
+          <p:nvPr/>
+        </p:nvCxnSpPr>
+        <p:spPr>
+          <a:xfrm flipV="1">
+            <a:off x="3846136" y="3016577"/>
+            <a:ext cx="0" cy="2192696"/>
+          </a:xfrm>
+          <a:prstGeom prst="straightConnector1">
+            <a:avLst/>
+          </a:prstGeom>
+          <a:ln>
+            <a:tailEnd type="triangle"/>
+          </a:ln>
+        </p:spPr>
+        <p:style>
+          <a:lnRef idx="1">
+            <a:schemeClr val="dk1"/>
+          </a:lnRef>
+          <a:fillRef idx="0">
+            <a:schemeClr val="dk1"/>
+          </a:fillRef>
+          <a:effectRef idx="0">
+            <a:schemeClr val="dk1"/>
+          </a:effectRef>
+          <a:fontRef idx="minor">
+            <a:schemeClr val="tx1"/>
+          </a:fontRef>
+        </p:style>
+      </p:cxnSp>
+      <p:sp>
+        <p:nvSpPr>
+          <p:cNvPr id="27" name="TextBox 26">
+            <a:extLst>
+              <a:ext uri="{FF2B5EF4-FFF2-40B4-BE49-F238E27FC236}">
+                <a16:creationId xmlns:a16="http://schemas.microsoft.com/office/drawing/2014/main" id="{E4C15B5D-90BA-CC39-68FC-5F992FFFF42F}"/>
+              </a:ext>
+            </a:extLst>
+          </p:cNvPr>
+          <p:cNvSpPr txBox="1"/>
+          <p:nvPr/>
+        </p:nvSpPr>
+        <p:spPr>
+          <a:xfrm>
+            <a:off x="3072980" y="5209273"/>
+            <a:ext cx="1536831" cy="369332"/>
+          </a:xfrm>
+          <a:prstGeom prst="rect">
+            <a:avLst/>
+          </a:prstGeom>
+          <a:noFill/>
+        </p:spPr>
+        <p:txBody>
+          <a:bodyPr wrap="none" rtlCol="0">
+            <a:spAutoFit/>
+          </a:bodyPr>
+          <a:lstStyle/>
+          <a:p>
+            <a:r>
+              <a:rPr lang="en-US" dirty="0"/>
+              <a:t>Top Plate Insert</a:t>
+            </a:r>
+          </a:p>
+        </p:txBody>
+      </p:sp>
+      <p:cxnSp>
+        <p:nvCxnSpPr>
+          <p:cNvPr id="36" name="Straight Arrow Connector 35">
+            <a:extLst>
+              <a:ext uri="{FF2B5EF4-FFF2-40B4-BE49-F238E27FC236}">
+                <a16:creationId xmlns:a16="http://schemas.microsoft.com/office/drawing/2014/main" id="{CC973BE6-3859-F65A-40C9-8C52D8671503}"/>
+              </a:ext>
+            </a:extLst>
+          </p:cNvPr>
+          <p:cNvCxnSpPr>
+            <a:cxnSpLocks/>
+          </p:cNvCxnSpPr>
+          <p:nvPr/>
+        </p:nvCxnSpPr>
+        <p:spPr>
+          <a:xfrm flipH="1">
+            <a:off x="4722829" y="1567765"/>
+            <a:ext cx="399926" cy="1703336"/>
+          </a:xfrm>
+          <a:prstGeom prst="straightConnector1">
+            <a:avLst/>
+          </a:prstGeom>
+          <a:ln>
+            <a:tailEnd type="triangle"/>
+          </a:ln>
+        </p:spPr>
+        <p:style>
+          <a:lnRef idx="1">
+            <a:schemeClr val="dk1"/>
+          </a:lnRef>
+          <a:fillRef idx="0">
+            <a:schemeClr val="dk1"/>
+          </a:fillRef>
+          <a:effectRef idx="0">
+            <a:schemeClr val="dk1"/>
+          </a:effectRef>
+          <a:fontRef idx="minor">
+            <a:schemeClr val="tx1"/>
+          </a:fontRef>
+        </p:style>
+      </p:cxnSp>
+      <p:sp>
+        <p:nvSpPr>
+          <p:cNvPr id="39" name="TextBox 38">
+            <a:extLst>
+              <a:ext uri="{FF2B5EF4-FFF2-40B4-BE49-F238E27FC236}">
+                <a16:creationId xmlns:a16="http://schemas.microsoft.com/office/drawing/2014/main" id="{0B297A23-99FD-8358-4EB9-0490A0B62C1A}"/>
+              </a:ext>
+            </a:extLst>
+          </p:cNvPr>
+          <p:cNvSpPr txBox="1"/>
+          <p:nvPr/>
+        </p:nvSpPr>
+        <p:spPr>
+          <a:xfrm>
+            <a:off x="4614551" y="1131405"/>
+            <a:ext cx="1161344" cy="369332"/>
+          </a:xfrm>
+          <a:prstGeom prst="rect">
+            <a:avLst/>
+          </a:prstGeom>
+          <a:noFill/>
+        </p:spPr>
+        <p:txBody>
+          <a:bodyPr wrap="none" rtlCol="0">
+            <a:spAutoFit/>
+          </a:bodyPr>
+          <a:lstStyle/>
+          <a:p>
+            <a:r>
+              <a:rPr lang="en-US" dirty="0"/>
+              <a:t>Plate Cavity</a:t>
+            </a:r>
+          </a:p>
+        </p:txBody>
+      </p:sp>
+      <p:cxnSp>
+        <p:nvCxnSpPr>
+          <p:cNvPr id="44" name="Straight Arrow Connector 43">
+            <a:extLst>
+              <a:ext uri="{FF2B5EF4-FFF2-40B4-BE49-F238E27FC236}">
+                <a16:creationId xmlns:a16="http://schemas.microsoft.com/office/drawing/2014/main" id="{68984215-6ACC-7C6C-449D-3AFFBDE196C8}"/>
+              </a:ext>
+            </a:extLst>
+          </p:cNvPr>
+          <p:cNvCxnSpPr/>
+          <p:nvPr/>
+        </p:nvCxnSpPr>
+        <p:spPr>
+          <a:xfrm flipH="1" flipV="1">
+            <a:off x="4468305" y="3930977"/>
+            <a:ext cx="726918" cy="1329180"/>
+          </a:xfrm>
+          <a:prstGeom prst="straightConnector1">
+            <a:avLst/>
+          </a:prstGeom>
+          <a:ln>
+            <a:tailEnd type="triangle"/>
+          </a:ln>
+        </p:spPr>
+        <p:style>
+          <a:lnRef idx="1">
+            <a:schemeClr val="dk1"/>
+          </a:lnRef>
+          <a:fillRef idx="0">
+            <a:schemeClr val="dk1"/>
+          </a:fillRef>
+          <a:effectRef idx="0">
+            <a:schemeClr val="dk1"/>
+          </a:effectRef>
+          <a:fontRef idx="minor">
+            <a:schemeClr val="tx1"/>
+          </a:fontRef>
+        </p:style>
+      </p:cxnSp>
+      <p:sp>
+        <p:nvSpPr>
+          <p:cNvPr id="45" name="TextBox 44">
+            <a:extLst>
+              <a:ext uri="{FF2B5EF4-FFF2-40B4-BE49-F238E27FC236}">
+                <a16:creationId xmlns:a16="http://schemas.microsoft.com/office/drawing/2014/main" id="{FEDBE1A9-6BB6-F83E-DF79-4E7B6300DEF9}"/>
+              </a:ext>
+            </a:extLst>
+          </p:cNvPr>
+          <p:cNvSpPr txBox="1"/>
+          <p:nvPr/>
+        </p:nvSpPr>
+        <p:spPr>
+          <a:xfrm>
+            <a:off x="4609811" y="5209273"/>
+            <a:ext cx="1336776" cy="646331"/>
+          </a:xfrm>
+          <a:prstGeom prst="rect">
+            <a:avLst/>
+          </a:prstGeom>
+          <a:noFill/>
+        </p:spPr>
+        <p:txBody>
+          <a:bodyPr wrap="none" rtlCol="0">
+            <a:spAutoFit/>
+          </a:bodyPr>
+          <a:lstStyle/>
+          <a:p>
+            <a:r>
+              <a:rPr lang="en-US" dirty="0"/>
+              <a:t>Un-Obscured </a:t>
+            </a:r>
+          </a:p>
+          <a:p>
+            <a:r>
+              <a:rPr lang="en-US" dirty="0"/>
+              <a:t>Viewing port</a:t>
+            </a:r>
+          </a:p>
+        </p:txBody>
+      </p:sp>
+      <p:pic>
+        <p:nvPicPr>
+          <p:cNvPr id="47" name="Picture 46">
+            <a:extLst>
+              <a:ext uri="{FF2B5EF4-FFF2-40B4-BE49-F238E27FC236}">
+                <a16:creationId xmlns:a16="http://schemas.microsoft.com/office/drawing/2014/main" id="{342DB476-F6D3-B436-CA45-AE24E63DD302}"/>
+              </a:ext>
+            </a:extLst>
+          </p:cNvPr>
+          <p:cNvPicPr>
+            <a:picLocks noChangeAspect="1"/>
+          </p:cNvPicPr>
+          <p:nvPr/>
+        </p:nvPicPr>
+        <p:blipFill>
+          <a:blip r:embed="rId4"/>
+          <a:stretch>
+            <a:fillRect/>
+          </a:stretch>
+        </p:blipFill>
+        <p:spPr>
+          <a:xfrm>
+            <a:off x="7073925" y="1813186"/>
+            <a:ext cx="4372202" cy="3231628"/>
+          </a:xfrm>
+          <a:prstGeom prst="rect">
+            <a:avLst/>
+          </a:prstGeom>
+        </p:spPr>
+      </p:pic>
+      <p:cxnSp>
+        <p:nvCxnSpPr>
+          <p:cNvPr id="37" name="Straight Arrow Connector 36">
+            <a:extLst>
+              <a:ext uri="{FF2B5EF4-FFF2-40B4-BE49-F238E27FC236}">
+                <a16:creationId xmlns:a16="http://schemas.microsoft.com/office/drawing/2014/main" id="{BF184665-63BF-AFC8-777F-A85949981183}"/>
+              </a:ext>
+            </a:extLst>
+          </p:cNvPr>
+          <p:cNvCxnSpPr>
+            <a:cxnSpLocks/>
+          </p:cNvCxnSpPr>
+          <p:nvPr/>
+        </p:nvCxnSpPr>
+        <p:spPr>
+          <a:xfrm flipV="1">
+            <a:off x="8738647" y="3930977"/>
+            <a:ext cx="801279" cy="1461155"/>
+          </a:xfrm>
+          <a:prstGeom prst="straightConnector1">
+            <a:avLst/>
+          </a:prstGeom>
+          <a:ln>
+            <a:tailEnd type="triangle"/>
+          </a:ln>
+        </p:spPr>
+        <p:style>
+          <a:lnRef idx="1">
+            <a:schemeClr val="dk1"/>
+          </a:lnRef>
+          <a:fillRef idx="0">
+            <a:schemeClr val="dk1"/>
+          </a:fillRef>
+          <a:effectRef idx="0">
+            <a:schemeClr val="dk1"/>
+          </a:effectRef>
+          <a:fontRef idx="minor">
+            <a:schemeClr val="tx1"/>
+          </a:fontRef>
+        </p:style>
+      </p:cxnSp>
+    </p:spTree>
+    <p:extLst>
+      <p:ext uri="{BB962C8B-B14F-4D97-AF65-F5344CB8AC3E}">
+        <p14:creationId xmlns:p14="http://schemas.microsoft.com/office/powerpoint/2010/main" val="3134398988"/>
+      </p:ext>
+    </p:extLst>
+  </p:cSld>
+  <p:clrMapOvr>
+    <a:masterClrMapping/>
+  </p:clrMapOvr>
+</p:sld>
+</file>
+
+<file path=ppt/slides/slide6.xml><?xml version="1.0" encoding="utf-8"?>
 <p:sld xmlns:a="http://schemas.openxmlformats.org/drawingml/2006/main" xmlns:r="http://schemas.openxmlformats.org/officeDocument/2006/relationships" xmlns:p="http://schemas.openxmlformats.org/presentationml/2006/main" show="0">
   <p:cSld>
     <p:spTree>
@@ -10579,7 +12501,7 @@
 </p:sld>
 </file>
 
-<file path=ppt/slides/slide6.xml><?xml version="1.0" encoding="utf-8"?>
+<file path=ppt/slides/slide7.xml><?xml version="1.0" encoding="utf-8"?>
 <p:sld xmlns:a="http://schemas.openxmlformats.org/drawingml/2006/main" xmlns:r="http://schemas.openxmlformats.org/officeDocument/2006/relationships" xmlns:p="http://schemas.openxmlformats.org/presentationml/2006/main" show="0">
   <p:cSld>
     <p:spTree>
@@ -10729,7 +12651,7 @@
 </p:sld>
 </file>
 
-<file path=ppt/slides/slide7.xml><?xml version="1.0" encoding="utf-8"?>
+<file path=ppt/slides/slide8.xml><?xml version="1.0" encoding="utf-8"?>
 <p:sld xmlns:a="http://schemas.openxmlformats.org/drawingml/2006/main" xmlns:r="http://schemas.openxmlformats.org/officeDocument/2006/relationships" xmlns:p="http://schemas.openxmlformats.org/presentationml/2006/main" show="0">
   <p:cSld>
     <p:bg>
@@ -10829,7 +12751,7 @@
 </p:sld>
 </file>
 
-<file path=ppt/slides/slide8.xml><?xml version="1.0" encoding="utf-8"?>
+<file path=ppt/slides/slide9.xml><?xml version="1.0" encoding="utf-8"?>
 <p:sld xmlns:a="http://schemas.openxmlformats.org/drawingml/2006/main" xmlns:r="http://schemas.openxmlformats.org/officeDocument/2006/relationships" xmlns:p="http://schemas.openxmlformats.org/presentationml/2006/main" show="0">
   <p:cSld>
     <p:spTree>
@@ -10984,149 +12906,6 @@
     <p:extLst>
       <p:ext uri="{BB962C8B-B14F-4D97-AF65-F5344CB8AC3E}">
         <p14:creationId xmlns:p14="http://schemas.microsoft.com/office/powerpoint/2010/main" val="2737241225"/>
-      </p:ext>
-    </p:extLst>
-  </p:cSld>
-  <p:clrMapOvr>
-    <a:masterClrMapping/>
-  </p:clrMapOvr>
-</p:sld>
-</file>
-
-<file path=ppt/slides/slide9.xml><?xml version="1.0" encoding="utf-8"?>
-<p:sld xmlns:a="http://schemas.openxmlformats.org/drawingml/2006/main" xmlns:r="http://schemas.openxmlformats.org/officeDocument/2006/relationships" xmlns:p="http://schemas.openxmlformats.org/presentationml/2006/main" show="0">
-  <p:cSld>
-    <p:spTree>
-      <p:nvGrpSpPr>
-        <p:cNvPr id="1" name=""/>
-        <p:cNvGrpSpPr/>
-        <p:nvPr/>
-      </p:nvGrpSpPr>
-      <p:grpSpPr>
-        <a:xfrm>
-          <a:off x="0" y="0"/>
-          <a:ext cx="0" cy="0"/>
-          <a:chOff x="0" y="0"/>
-          <a:chExt cx="0" cy="0"/>
-        </a:xfrm>
-      </p:grpSpPr>
-      <p:sp>
-        <p:nvSpPr>
-          <p:cNvPr id="2" name="Title 1">
-            <a:extLst>
-              <a:ext uri="{FF2B5EF4-FFF2-40B4-BE49-F238E27FC236}">
-                <a16:creationId xmlns:a16="http://schemas.microsoft.com/office/drawing/2014/main" id="{314C27C8-165C-5513-DB4B-9D840097C545}"/>
-              </a:ext>
-            </a:extLst>
-          </p:cNvPr>
-          <p:cNvSpPr>
-            <a:spLocks noGrp="1"/>
-          </p:cNvSpPr>
-          <p:nvPr>
-            <p:ph type="title"/>
-          </p:nvPr>
-        </p:nvSpPr>
-        <p:spPr>
-          <a:xfrm>
-            <a:off x="1280160" y="1097280"/>
-            <a:ext cx="5029200" cy="1828800"/>
-          </a:xfrm>
-          <a:noFill/>
-        </p:spPr>
-        <p:txBody>
-          <a:bodyPr anchor="t" anchorCtr="0"/>
-          <a:lstStyle/>
-          <a:p>
-            <a:r>
-              <a:rPr lang="en-US" dirty="0"/>
-              <a:t>Growth strategy</a:t>
-            </a:r>
-          </a:p>
-        </p:txBody>
-      </p:sp>
-      <p:sp>
-        <p:nvSpPr>
-          <p:cNvPr id="3" name="Content Placeholder 2">
-            <a:extLst>
-              <a:ext uri="{FF2B5EF4-FFF2-40B4-BE49-F238E27FC236}">
-                <a16:creationId xmlns:a16="http://schemas.microsoft.com/office/drawing/2014/main" id="{FACE640F-7F5A-BDB7-205D-765FA80B6796}"/>
-              </a:ext>
-            </a:extLst>
-          </p:cNvPr>
-          <p:cNvSpPr>
-            <a:spLocks noGrp="1"/>
-          </p:cNvSpPr>
-          <p:nvPr>
-            <p:ph sz="half" idx="1"/>
-          </p:nvPr>
-        </p:nvSpPr>
-        <p:spPr>
-          <a:xfrm>
-            <a:off x="6784848" y="1097280"/>
-            <a:ext cx="4572000" cy="1828800"/>
-          </a:xfrm>
-          <a:noFill/>
-        </p:spPr>
-        <p:txBody>
-          <a:bodyPr>
-            <a:noAutofit/>
-          </a:bodyPr>
-          <a:lstStyle/>
-          <a:p>
-            <a:r>
-              <a:rPr lang="en-US" dirty="0"/>
-              <a:t>Expand market reach through strategic partnerships</a:t>
-            </a:r>
-          </a:p>
-          <a:p>
-            <a:r>
-              <a:rPr lang="en-US" dirty="0"/>
-              <a:t>Enhance product features based on user feedback</a:t>
-            </a:r>
-          </a:p>
-          <a:p>
-            <a:r>
-              <a:rPr lang="en-US" dirty="0"/>
-              <a:t>Explore international market opportunities</a:t>
-            </a:r>
-          </a:p>
-        </p:txBody>
-      </p:sp>
-      <p:graphicFrame>
-        <p:nvGraphicFramePr>
-          <p:cNvPr id="5" name="Content Placeholder 4" descr="Basic timeline SmartArt graphic">
-            <a:extLst>
-              <a:ext uri="{FF2B5EF4-FFF2-40B4-BE49-F238E27FC236}">
-                <a16:creationId xmlns:a16="http://schemas.microsoft.com/office/drawing/2014/main" id="{2DA25F38-CDC8-7982-99AE-8D5A8ECABC85}"/>
-              </a:ext>
-            </a:extLst>
-          </p:cNvPr>
-          <p:cNvGraphicFramePr>
-            <a:graphicFrameLocks noGrp="1"/>
-          </p:cNvGraphicFramePr>
-          <p:nvPr>
-            <p:ph sz="half" idx="2"/>
-            <p:extLst>
-              <p:ext uri="{D42A27DB-BD31-4B8C-83A1-F6EECF244321}">
-                <p14:modId xmlns:p14="http://schemas.microsoft.com/office/powerpoint/2010/main" val="4243408372"/>
-              </p:ext>
-            </p:extLst>
-          </p:nvPr>
-        </p:nvGraphicFramePr>
-        <p:xfrm>
-          <a:off x="1279525" y="3173413"/>
-          <a:ext cx="10077450" cy="3108325"/>
-        </p:xfrm>
-        <a:graphic>
-          <a:graphicData uri="http://schemas.openxmlformats.org/drawingml/2006/diagram">
-            <dgm:relIds xmlns:dgm="http://schemas.openxmlformats.org/drawingml/2006/diagram" xmlns:r="http://schemas.openxmlformats.org/officeDocument/2006/relationships" r:dm="rId2" r:lo="rId3" r:qs="rId4" r:cs="rId5"/>
-          </a:graphicData>
-        </a:graphic>
-      </p:graphicFrame>
-    </p:spTree>
-    <p:extLst>
-      <p:ext uri="{BB962C8B-B14F-4D97-AF65-F5344CB8AC3E}">
-        <p14:creationId xmlns:p14="http://schemas.microsoft.com/office/powerpoint/2010/main" val="729609147"/>
       </p:ext>
     </p:extLst>
   </p:cSld>
@@ -12240,15 +14019,6 @@
 </file>
 
 <file path=customXml/item2.xml><?xml version="1.0" encoding="utf-8"?>
-<?mso-contentType ?>
-<FormTemplates xmlns="http://schemas.microsoft.com/sharepoint/v3/contenttype/forms">
-  <Display>DocumentLibraryForm</Display>
-  <Edit>DocumentLibraryForm</Edit>
-  <New>DocumentLibraryForm</New>
-</FormTemplates>
-</file>
-
-<file path=customXml/item3.xml><?xml version="1.0" encoding="utf-8"?>
 <p:properties xmlns:p="http://schemas.microsoft.com/office/2006/metadata/properties" xmlns:xsi="http://www.w3.org/2001/XMLSchema-instance" xmlns:pc="http://schemas.microsoft.com/office/infopath/2007/PartnerControls">
   <documentManagement>
     <_ip_UnifiedCompliancePolicyUIAction xmlns="http://schemas.microsoft.com/sharepoint/v3" xsi:nil="true"/>
@@ -12266,6 +14036,15 @@
     <MediaServiceKeyPoints xmlns="71af3243-3dd4-4a8d-8c0d-dd76da1f02a5" xsi:nil="true"/>
   </documentManagement>
 </p:properties>
+</file>
+
+<file path=customXml/item3.xml><?xml version="1.0" encoding="utf-8"?>
+<?mso-contentType ?>
+<FormTemplates xmlns="http://schemas.microsoft.com/sharepoint/v3/contenttype/forms">
+  <Display>DocumentLibraryForm</Display>
+  <Edit>DocumentLibraryForm</Edit>
+  <New>DocumentLibraryForm</New>
+</FormTemplates>
 </file>
 
 <file path=customXml/itemProps1.xml><?xml version="1.0" encoding="utf-8"?>
@@ -12290,14 +14069,6 @@
 </file>
 
 <file path=customXml/itemProps2.xml><?xml version="1.0" encoding="utf-8"?>
-<ds:datastoreItem xmlns:ds="http://schemas.openxmlformats.org/officeDocument/2006/customXml" ds:itemID="{DF8397A0-8C35-4EEE-8E61-47C914415B57}">
-  <ds:schemaRefs>
-    <ds:schemaRef ds:uri="http://schemas.microsoft.com/sharepoint/v3/contenttype/forms"/>
-  </ds:schemaRefs>
-</ds:datastoreItem>
-</file>
-
-<file path=customXml/itemProps3.xml><?xml version="1.0" encoding="utf-8"?>
 <ds:datastoreItem xmlns:ds="http://schemas.openxmlformats.org/officeDocument/2006/customXml" ds:itemID="{B881D8D6-8849-400B-8BC9-21D401C7DD06}">
   <ds:schemaRefs>
     <ds:schemaRef ds:uri="http://schemas.microsoft.com/office/2006/metadata/properties"/>
@@ -12309,6 +14080,14 @@
 </ds:datastoreItem>
 </file>
 
+<file path=customXml/itemProps3.xml><?xml version="1.0" encoding="utf-8"?>
+<ds:datastoreItem xmlns:ds="http://schemas.openxmlformats.org/officeDocument/2006/customXml" ds:itemID="{DF8397A0-8C35-4EEE-8E61-47C914415B57}">
+  <ds:schemaRefs>
+    <ds:schemaRef ds:uri="http://schemas.microsoft.com/sharepoint/v3/contenttype/forms"/>
+  </ds:schemaRefs>
+</ds:datastoreItem>
+</file>
+
 <file path=docMetadata/LabelInfo.xml><?xml version="1.0" encoding="utf-8"?>
 <clbl:labelList xmlns:clbl="http://schemas.microsoft.com/office/2020/mipLabelMetadata"/>
 </file>
</xml_diff>

<commit_message>
Edited Draft 1 with some change and fixes.
</commit_message>
<xml_diff>
--- a/Onboarding_Presentation.pptx
+++ b/Onboarding_Presentation.pptx
@@ -16,14 +16,14 @@
     <p:sldId id="264" r:id="rId7"/>
     <p:sldId id="259" r:id="rId8"/>
     <p:sldId id="341" r:id="rId9"/>
-    <p:sldId id="257" r:id="rId10"/>
-    <p:sldId id="261" r:id="rId11"/>
-    <p:sldId id="258" r:id="rId12"/>
-    <p:sldId id="263" r:id="rId13"/>
-    <p:sldId id="265" r:id="rId14"/>
-    <p:sldId id="268" r:id="rId15"/>
-    <p:sldId id="267" r:id="rId16"/>
-    <p:sldId id="266" r:id="rId17"/>
+    <p:sldId id="266" r:id="rId10"/>
+    <p:sldId id="257" r:id="rId11"/>
+    <p:sldId id="261" r:id="rId12"/>
+    <p:sldId id="258" r:id="rId13"/>
+    <p:sldId id="263" r:id="rId14"/>
+    <p:sldId id="265" r:id="rId15"/>
+    <p:sldId id="268" r:id="rId16"/>
+    <p:sldId id="267" r:id="rId17"/>
     <p:sldId id="340" r:id="rId18"/>
   </p:sldIdLst>
   <p:sldSz cx="12192000" cy="6858000"/>
@@ -157,20 +157,12 @@
 </p:cmAuthorLst>
 </file>
 
-<file path=ppt/revisionInfo.xml><?xml version="1.0" encoding="utf-8"?>
-<p1510:revInfo xmlns:a="http://schemas.openxmlformats.org/drawingml/2006/main" xmlns:r="http://schemas.openxmlformats.org/officeDocument/2006/relationships" xmlns:p1510="http://schemas.microsoft.com/office/powerpoint/2015/10/main">
-  <p1510:revLst>
-    <p1510:client id="{984C69CA-C70A-4355-93EF-976B02AB29CC}" v="10" dt="2026-02-10T20:26:52.889"/>
-  </p1510:revLst>
-</p1510:revInfo>
-</file>
-
 <file path=ppt/changesInfos/changesInfo1.xml><?xml version="1.0" encoding="utf-8"?>
 <pc:chgInfo xmlns:a="http://schemas.openxmlformats.org/drawingml/2006/main" xmlns:r="http://schemas.openxmlformats.org/officeDocument/2006/relationships" xmlns:ac="http://schemas.microsoft.com/office/drawing/2013/main/command" xmlns:pc="http://schemas.microsoft.com/office/powerpoint/2013/main/command">
   <pc:docChgLst>
     <pc:chgData name="Joab Kloppers" userId="bcab5db0-8267-4c54-83c3-7ddba1e5c6be" providerId="ADAL" clId="{90E0EE0E-984C-4547-AADC-7DD4534EA015}"/>
     <pc:docChg chg="undo custSel addSld delSld modSld sldOrd">
-      <pc:chgData name="Joab Kloppers" userId="bcab5db0-8267-4c54-83c3-7ddba1e5c6be" providerId="ADAL" clId="{90E0EE0E-984C-4547-AADC-7DD4534EA015}" dt="2026-02-10T20:38:11.141" v="10355" actId="20577"/>
+      <pc:chgData name="Joab Kloppers" userId="bcab5db0-8267-4c54-83c3-7ddba1e5c6be" providerId="ADAL" clId="{90E0EE0E-984C-4547-AADC-7DD4534EA015}" dt="2026-02-21T12:08:04.153" v="10532" actId="1076"/>
       <pc:docMkLst>
         <pc:docMk/>
       </pc:docMkLst>
@@ -200,30 +192,6 @@
             <pc:docMk/>
             <pc:sldMk cId="1008037533" sldId="259"/>
             <ac:spMk id="2" creationId="{954ABE40-AA00-F366-A36A-B3F1AADBF025}"/>
-          </ac:spMkLst>
-        </pc:spChg>
-        <pc:spChg chg="del">
-          <ac:chgData name="Joab Kloppers" userId="bcab5db0-8267-4c54-83c3-7ddba1e5c6be" providerId="ADAL" clId="{90E0EE0E-984C-4547-AADC-7DD4534EA015}" dt="2026-02-10T19:01:23.594" v="8602" actId="478"/>
-          <ac:spMkLst>
-            <pc:docMk/>
-            <pc:sldMk cId="1008037533" sldId="259"/>
-            <ac:spMk id="3" creationId="{72446868-83F0-CEEF-5E60-6D55C93B523F}"/>
-          </ac:spMkLst>
-        </pc:spChg>
-        <pc:spChg chg="add del mod">
-          <ac:chgData name="Joab Kloppers" userId="bcab5db0-8267-4c54-83c3-7ddba1e5c6be" providerId="ADAL" clId="{90E0EE0E-984C-4547-AADC-7DD4534EA015}" dt="2026-02-10T18:57:05.363" v="8575" actId="478"/>
-          <ac:spMkLst>
-            <pc:docMk/>
-            <pc:sldMk cId="1008037533" sldId="259"/>
-            <ac:spMk id="5" creationId="{5003907A-4466-BCC9-5192-9F5EB08A6344}"/>
-          </ac:spMkLst>
-        </pc:spChg>
-        <pc:spChg chg="add del mod">
-          <ac:chgData name="Joab Kloppers" userId="bcab5db0-8267-4c54-83c3-7ddba1e5c6be" providerId="ADAL" clId="{90E0EE0E-984C-4547-AADC-7DD4534EA015}" dt="2026-02-10T19:01:26.798" v="8603" actId="478"/>
-          <ac:spMkLst>
-            <pc:docMk/>
-            <pc:sldMk cId="1008037533" sldId="259"/>
-            <ac:spMk id="12" creationId="{88309AD4-D043-FB6A-1DE5-5F9029EFEDA2}"/>
           </ac:spMkLst>
         </pc:spChg>
         <pc:spChg chg="add mod">
@@ -258,44 +226,12 @@
             <ac:spMk id="38" creationId="{2A6FCFB0-523B-627F-E71C-34AE61F532CB}"/>
           </ac:spMkLst>
         </pc:spChg>
-        <pc:picChg chg="add del mod">
-          <ac:chgData name="Joab Kloppers" userId="bcab5db0-8267-4c54-83c3-7ddba1e5c6be" providerId="ADAL" clId="{90E0EE0E-984C-4547-AADC-7DD4534EA015}" dt="2026-02-10T19:07:58.920" v="8623" actId="478"/>
-          <ac:picMkLst>
-            <pc:docMk/>
-            <pc:sldMk cId="1008037533" sldId="259"/>
-            <ac:picMk id="7" creationId="{4B29A6B2-C61F-686A-8009-D6BB83DC559E}"/>
-          </ac:picMkLst>
-        </pc:picChg>
-        <pc:picChg chg="add del mod">
-          <ac:chgData name="Joab Kloppers" userId="bcab5db0-8267-4c54-83c3-7ddba1e5c6be" providerId="ADAL" clId="{90E0EE0E-984C-4547-AADC-7DD4534EA015}" dt="2026-02-10T19:07:03.540" v="8616" actId="478"/>
-          <ac:picMkLst>
-            <pc:docMk/>
-            <pc:sldMk cId="1008037533" sldId="259"/>
-            <ac:picMk id="9" creationId="{31185738-B179-B8F6-5900-343D12BD5C1A}"/>
-          </ac:picMkLst>
-        </pc:picChg>
-        <pc:picChg chg="del mod">
-          <ac:chgData name="Joab Kloppers" userId="bcab5db0-8267-4c54-83c3-7ddba1e5c6be" providerId="ADAL" clId="{90E0EE0E-984C-4547-AADC-7DD4534EA015}" dt="2026-02-10T18:57:00.458" v="8573" actId="478"/>
-          <ac:picMkLst>
-            <pc:docMk/>
-            <pc:sldMk cId="1008037533" sldId="259"/>
-            <ac:picMk id="10" creationId="{99058E17-80B3-F3F9-AF6A-0518C39D940F}"/>
-          </ac:picMkLst>
-        </pc:picChg>
         <pc:picChg chg="add mod">
           <ac:chgData name="Joab Kloppers" userId="bcab5db0-8267-4c54-83c3-7ddba1e5c6be" providerId="ADAL" clId="{90E0EE0E-984C-4547-AADC-7DD4534EA015}" dt="2026-02-10T19:08:16.243" v="8630" actId="1076"/>
           <ac:picMkLst>
             <pc:docMk/>
             <pc:sldMk cId="1008037533" sldId="259"/>
             <ac:picMk id="16" creationId="{EC0B6619-4249-56D3-AA68-E9D9F6A518EF}"/>
-          </ac:picMkLst>
-        </pc:picChg>
-        <pc:picChg chg="add del mod">
-          <ac:chgData name="Joab Kloppers" userId="bcab5db0-8267-4c54-83c3-7ddba1e5c6be" providerId="ADAL" clId="{90E0EE0E-984C-4547-AADC-7DD4534EA015}" dt="2026-02-10T19:09:17.308" v="8635" actId="478"/>
-          <ac:picMkLst>
-            <pc:docMk/>
-            <pc:sldMk cId="1008037533" sldId="259"/>
-            <ac:picMk id="18" creationId="{E1277B87-0C77-8423-8457-35A3F9AC18EB}"/>
           </ac:picMkLst>
         </pc:picChg>
         <pc:picChg chg="add mod">
@@ -306,36 +242,12 @@
             <ac:picMk id="22" creationId="{84FC55AD-FE16-0299-BFFE-CC8A810E6B37}"/>
           </ac:picMkLst>
         </pc:picChg>
-        <pc:cxnChg chg="add del mod">
-          <ac:chgData name="Joab Kloppers" userId="bcab5db0-8267-4c54-83c3-7ddba1e5c6be" providerId="ADAL" clId="{90E0EE0E-984C-4547-AADC-7DD4534EA015}" dt="2026-02-10T19:08:22.701" v="8632" actId="478"/>
-          <ac:cxnSpMkLst>
-            <pc:docMk/>
-            <pc:sldMk cId="1008037533" sldId="259"/>
-            <ac:cxnSpMk id="14" creationId="{F6B44CDF-CD4E-3112-29BD-A00FBADE2FAD}"/>
-          </ac:cxnSpMkLst>
-        </pc:cxnChg>
-        <pc:cxnChg chg="add del">
-          <ac:chgData name="Joab Kloppers" userId="bcab5db0-8267-4c54-83c3-7ddba1e5c6be" providerId="ADAL" clId="{90E0EE0E-984C-4547-AADC-7DD4534EA015}" dt="2026-02-10T19:08:33.558" v="8634" actId="11529"/>
-          <ac:cxnSpMkLst>
-            <pc:docMk/>
-            <pc:sldMk cId="1008037533" sldId="259"/>
-            <ac:cxnSpMk id="20" creationId="{8DC3B800-FF99-A6E3-E192-855E3C7CE328}"/>
-          </ac:cxnSpMkLst>
-        </pc:cxnChg>
         <pc:cxnChg chg="add mod">
           <ac:chgData name="Joab Kloppers" userId="bcab5db0-8267-4c54-83c3-7ddba1e5c6be" providerId="ADAL" clId="{90E0EE0E-984C-4547-AADC-7DD4534EA015}" dt="2026-02-10T19:09:43.222" v="8640" actId="208"/>
           <ac:cxnSpMkLst>
             <pc:docMk/>
             <pc:sldMk cId="1008037533" sldId="259"/>
             <ac:cxnSpMk id="24" creationId="{F1EA5270-97B0-DA22-7F2F-8ED6CAF1B1B7}"/>
-          </ac:cxnSpMkLst>
-        </pc:cxnChg>
-        <pc:cxnChg chg="add del">
-          <ac:chgData name="Joab Kloppers" userId="bcab5db0-8267-4c54-83c3-7ddba1e5c6be" providerId="ADAL" clId="{90E0EE0E-984C-4547-AADC-7DD4534EA015}" dt="2026-02-10T20:08:18.256" v="8659" actId="11529"/>
-          <ac:cxnSpMkLst>
-            <pc:docMk/>
-            <pc:sldMk cId="1008037533" sldId="259"/>
-            <ac:cxnSpMk id="27" creationId="{107D5145-AB29-5E1D-32DA-2D9337901861}"/>
           </ac:cxnSpMkLst>
         </pc:cxnChg>
         <pc:cxnChg chg="add mod">
@@ -423,12 +335,28 @@
           <pc:sldMk cId="729609147" sldId="265"/>
         </pc:sldMkLst>
       </pc:sldChg>
-      <pc:sldChg chg="mod modShow">
-        <pc:chgData name="Joab Kloppers" userId="bcab5db0-8267-4c54-83c3-7ddba1e5c6be" providerId="ADAL" clId="{90E0EE0E-984C-4547-AADC-7DD4534EA015}" dt="2026-02-02T07:26:53.099" v="7703" actId="729"/>
+      <pc:sldChg chg="delSp modSp mod ord modShow">
+        <pc:chgData name="Joab Kloppers" userId="bcab5db0-8267-4c54-83c3-7ddba1e5c6be" providerId="ADAL" clId="{90E0EE0E-984C-4547-AADC-7DD4534EA015}" dt="2026-02-21T12:08:04.153" v="10532" actId="1076"/>
         <pc:sldMkLst>
           <pc:docMk/>
           <pc:sldMk cId="643777997" sldId="266"/>
         </pc:sldMkLst>
+        <pc:spChg chg="mod">
+          <ac:chgData name="Joab Kloppers" userId="bcab5db0-8267-4c54-83c3-7ddba1e5c6be" providerId="ADAL" clId="{90E0EE0E-984C-4547-AADC-7DD4534EA015}" dt="2026-02-21T12:08:04.153" v="10532" actId="1076"/>
+          <ac:spMkLst>
+            <pc:docMk/>
+            <pc:sldMk cId="643777997" sldId="266"/>
+            <ac:spMk id="3" creationId="{05948542-FCE1-3AE6-C6C9-17975609DF70}"/>
+          </ac:spMkLst>
+        </pc:spChg>
+        <pc:spChg chg="del mod">
+          <ac:chgData name="Joab Kloppers" userId="bcab5db0-8267-4c54-83c3-7ddba1e5c6be" providerId="ADAL" clId="{90E0EE0E-984C-4547-AADC-7DD4534EA015}" dt="2026-02-21T12:07:57.119" v="10529" actId="478"/>
+          <ac:spMkLst>
+            <pc:docMk/>
+            <pc:sldMk cId="643777997" sldId="266"/>
+            <ac:spMk id="4" creationId="{3EE67564-0457-E486-97D0-8109D2C97B3F}"/>
+          </ac:spMkLst>
+        </pc:spChg>
       </pc:sldChg>
       <pc:sldChg chg="mod modShow">
         <pc:chgData name="Joab Kloppers" userId="bcab5db0-8267-4c54-83c3-7ddba1e5c6be" providerId="ADAL" clId="{90E0EE0E-984C-4547-AADC-7DD4534EA015}" dt="2026-02-02T07:26:53.099" v="7703" actId="729"/>
@@ -527,36 +455,12 @@
             <ac:spMk id="21" creationId="{B7946254-962A-CE33-7F2D-B9E3052CCB5C}"/>
           </ac:spMkLst>
         </pc:spChg>
-        <pc:spChg chg="del">
-          <ac:chgData name="Joab Kloppers" userId="bcab5db0-8267-4c54-83c3-7ddba1e5c6be" providerId="ADAL" clId="{90E0EE0E-984C-4547-AADC-7DD4534EA015}" dt="2026-02-10T20:19:20.881" v="9426" actId="478"/>
-          <ac:spMkLst>
-            <pc:docMk/>
-            <pc:sldMk cId="3134398988" sldId="341"/>
-            <ac:spMk id="25" creationId="{55DB6C57-A0B7-8193-BFE2-DB1C55649123}"/>
-          </ac:spMkLst>
-        </pc:spChg>
         <pc:spChg chg="add mod">
           <ac:chgData name="Joab Kloppers" userId="bcab5db0-8267-4c54-83c3-7ddba1e5c6be" providerId="ADAL" clId="{90E0EE0E-984C-4547-AADC-7DD4534EA015}" dt="2026-02-10T20:26:12.801" v="9592" actId="1076"/>
           <ac:spMkLst>
             <pc:docMk/>
             <pc:sldMk cId="3134398988" sldId="341"/>
             <ac:spMk id="27" creationId="{E4C15B5D-90BA-CC39-68FC-5F992FFFF42F}"/>
-          </ac:spMkLst>
-        </pc:spChg>
-        <pc:spChg chg="del">
-          <ac:chgData name="Joab Kloppers" userId="bcab5db0-8267-4c54-83c3-7ddba1e5c6be" providerId="ADAL" clId="{90E0EE0E-984C-4547-AADC-7DD4534EA015}" dt="2026-02-10T20:19:16.160" v="9424" actId="478"/>
-          <ac:spMkLst>
-            <pc:docMk/>
-            <pc:sldMk cId="3134398988" sldId="341"/>
-            <ac:spMk id="32" creationId="{85DA6984-0D05-0673-1A38-2DCB88C67CAA}"/>
-          </ac:spMkLst>
-        </pc:spChg>
-        <pc:spChg chg="del mod">
-          <ac:chgData name="Joab Kloppers" userId="bcab5db0-8267-4c54-83c3-7ddba1e5c6be" providerId="ADAL" clId="{90E0EE0E-984C-4547-AADC-7DD4534EA015}" dt="2026-02-10T20:19:10.710" v="9421" actId="478"/>
-          <ac:spMkLst>
-            <pc:docMk/>
-            <pc:sldMk cId="3134398988" sldId="341"/>
-            <ac:spMk id="35" creationId="{1E25DD68-EE14-C8CC-9333-643122C741BB}"/>
           </ac:spMkLst>
         </pc:spChg>
         <pc:spChg chg="mod">
@@ -583,36 +487,12 @@
             <ac:spMk id="45" creationId="{FEDBE1A9-6BB6-F83E-DF79-4E7B6300DEF9}"/>
           </ac:spMkLst>
         </pc:spChg>
-        <pc:picChg chg="add del mod">
-          <ac:chgData name="Joab Kloppers" userId="bcab5db0-8267-4c54-83c3-7ddba1e5c6be" providerId="ADAL" clId="{90E0EE0E-984C-4547-AADC-7DD4534EA015}" dt="2026-02-10T20:18:49.159" v="9414" actId="478"/>
-          <ac:picMkLst>
-            <pc:docMk/>
-            <pc:sldMk cId="3134398988" sldId="341"/>
-            <ac:picMk id="4" creationId="{1B4F7DA1-6F3B-DF44-6829-885F4C07C90D}"/>
-          </ac:picMkLst>
-        </pc:picChg>
         <pc:picChg chg="add mod">
           <ac:chgData name="Joab Kloppers" userId="bcab5db0-8267-4c54-83c3-7ddba1e5c6be" providerId="ADAL" clId="{90E0EE0E-984C-4547-AADC-7DD4534EA015}" dt="2026-02-10T20:18:59.099" v="9418" actId="14100"/>
           <ac:picMkLst>
             <pc:docMk/>
             <pc:sldMk cId="3134398988" sldId="341"/>
             <ac:picMk id="6" creationId="{C1AB545E-CBBA-0DBC-0D83-4B26E860A3E9}"/>
-          </ac:picMkLst>
-        </pc:picChg>
-        <pc:picChg chg="del">
-          <ac:chgData name="Joab Kloppers" userId="bcab5db0-8267-4c54-83c3-7ddba1e5c6be" providerId="ADAL" clId="{90E0EE0E-984C-4547-AADC-7DD4534EA015}" dt="2026-02-10T20:29:05.755" v="9625" actId="478"/>
-          <ac:picMkLst>
-            <pc:docMk/>
-            <pc:sldMk cId="3134398988" sldId="341"/>
-            <ac:picMk id="16" creationId="{F8C24508-944A-6E45-A242-7F46FB642809}"/>
-          </ac:picMkLst>
-        </pc:picChg>
-        <pc:picChg chg="del">
-          <ac:chgData name="Joab Kloppers" userId="bcab5db0-8267-4c54-83c3-7ddba1e5c6be" providerId="ADAL" clId="{90E0EE0E-984C-4547-AADC-7DD4534EA015}" dt="2026-02-10T20:18:18.571" v="9409" actId="478"/>
-          <ac:picMkLst>
-            <pc:docMk/>
-            <pc:sldMk cId="3134398988" sldId="341"/>
-            <ac:picMk id="22" creationId="{9392B5A8-D108-73C9-A5E9-EE728DE61AD0}"/>
           </ac:picMkLst>
         </pc:picChg>
         <pc:picChg chg="add mod">
@@ -629,14 +509,6 @@
             <pc:docMk/>
             <pc:sldMk cId="3134398988" sldId="341"/>
             <ac:cxnSpMk id="8" creationId="{B88CD4C8-7545-7C82-9810-545F301BB4A3}"/>
-          </ac:cxnSpMkLst>
-        </pc:cxnChg>
-        <pc:cxnChg chg="add del mod">
-          <ac:chgData name="Joab Kloppers" userId="bcab5db0-8267-4c54-83c3-7ddba1e5c6be" providerId="ADAL" clId="{90E0EE0E-984C-4547-AADC-7DD4534EA015}" dt="2026-02-10T20:20:45.243" v="9434" actId="11529"/>
-          <ac:cxnSpMkLst>
-            <pc:docMk/>
-            <pc:sldMk cId="3134398988" sldId="341"/>
-            <ac:cxnSpMk id="10" creationId="{AFB60792-15C1-D5F0-42BF-B798D176A58B}"/>
           </ac:cxnSpMkLst>
         </pc:cxnChg>
         <pc:cxnChg chg="add mod">
@@ -663,52 +535,12 @@
             <ac:cxnSpMk id="20" creationId="{92F2A379-D195-021E-7225-7EB9A36A7B5B}"/>
           </ac:cxnSpMkLst>
         </pc:cxnChg>
-        <pc:cxnChg chg="del">
-          <ac:chgData name="Joab Kloppers" userId="bcab5db0-8267-4c54-83c3-7ddba1e5c6be" providerId="ADAL" clId="{90E0EE0E-984C-4547-AADC-7DD4534EA015}" dt="2026-02-10T20:19:18.193" v="9425" actId="478"/>
-          <ac:cxnSpMkLst>
-            <pc:docMk/>
-            <pc:sldMk cId="3134398988" sldId="341"/>
-            <ac:cxnSpMk id="24" creationId="{53948260-5551-C16B-9C91-D9DFDA8FFBB3}"/>
-          </ac:cxnSpMkLst>
-        </pc:cxnChg>
         <pc:cxnChg chg="add mod">
           <ac:chgData name="Joab Kloppers" userId="bcab5db0-8267-4c54-83c3-7ddba1e5c6be" providerId="ADAL" clId="{90E0EE0E-984C-4547-AADC-7DD4534EA015}" dt="2026-02-10T20:26:09.058" v="9591" actId="14100"/>
           <ac:cxnSpMkLst>
             <pc:docMk/>
             <pc:sldMk cId="3134398988" sldId="341"/>
             <ac:cxnSpMk id="26" creationId="{17DA7481-E0B5-8D0B-8B62-8F1CA411F6C8}"/>
-          </ac:cxnSpMkLst>
-        </pc:cxnChg>
-        <pc:cxnChg chg="del">
-          <ac:chgData name="Joab Kloppers" userId="bcab5db0-8267-4c54-83c3-7ddba1e5c6be" providerId="ADAL" clId="{90E0EE0E-984C-4547-AADC-7DD4534EA015}" dt="2026-02-10T20:19:13.593" v="9423" actId="478"/>
-          <ac:cxnSpMkLst>
-            <pc:docMk/>
-            <pc:sldMk cId="3134398988" sldId="341"/>
-            <ac:cxnSpMk id="29" creationId="{5A8EE7A6-7BA7-46AC-9FA9-AB5228705912}"/>
-          </ac:cxnSpMkLst>
-        </pc:cxnChg>
-        <pc:cxnChg chg="add del">
-          <ac:chgData name="Joab Kloppers" userId="bcab5db0-8267-4c54-83c3-7ddba1e5c6be" providerId="ADAL" clId="{90E0EE0E-984C-4547-AADC-7DD4534EA015}" dt="2026-02-10T20:25:14.530" v="9552" actId="11529"/>
-          <ac:cxnSpMkLst>
-            <pc:docMk/>
-            <pc:sldMk cId="3134398988" sldId="341"/>
-            <ac:cxnSpMk id="30" creationId="{71993123-7FF3-8210-D7E6-CA8E4A3AEF90}"/>
-          </ac:cxnSpMkLst>
-        </pc:cxnChg>
-        <pc:cxnChg chg="del">
-          <ac:chgData name="Joab Kloppers" userId="bcab5db0-8267-4c54-83c3-7ddba1e5c6be" providerId="ADAL" clId="{90E0EE0E-984C-4547-AADC-7DD4534EA015}" dt="2026-02-10T20:19:12.647" v="9422" actId="478"/>
-          <ac:cxnSpMkLst>
-            <pc:docMk/>
-            <pc:sldMk cId="3134398988" sldId="341"/>
-            <ac:cxnSpMk id="31" creationId="{03D406A9-8133-6A91-4BAC-B8BC0D061482}"/>
-          </ac:cxnSpMkLst>
-        </pc:cxnChg>
-        <pc:cxnChg chg="del">
-          <ac:chgData name="Joab Kloppers" userId="bcab5db0-8267-4c54-83c3-7ddba1e5c6be" providerId="ADAL" clId="{90E0EE0E-984C-4547-AADC-7DD4534EA015}" dt="2026-02-10T20:19:04.559" v="9419" actId="478"/>
-          <ac:cxnSpMkLst>
-            <pc:docMk/>
-            <pc:sldMk cId="3134398988" sldId="341"/>
-            <ac:cxnSpMk id="34" creationId="{AE8E8F41-DED7-6CB3-0395-788F792CA131}"/>
           </ac:cxnSpMkLst>
         </pc:cxnChg>
         <pc:cxnChg chg="add mod">
@@ -3776,7 +3608,7 @@
           <a:p>
             <a:fld id="{7FF95820-84BB-3447-8286-60A51307E7F2}" type="datetimeFigureOut">
               <a:rPr lang="en-US" smtClean="0"/>
-              <a:t>2/10/2026</a:t>
+              <a:t>2/21/2026</a:t>
             </a:fld>
             <a:endParaRPr lang="en-US" dirty="0"/>
           </a:p>
@@ -3954,7 +3786,7 @@
           <a:p>
             <a:fld id="{FC08FC54-6AE4-6A4A-9756-823A0F1BE5A6}" type="datetimeFigureOut">
               <a:rPr lang="en-US" smtClean="0"/>
-              <a:t>2/10/2026</a:t>
+              <a:t>2/21/2026</a:t>
             </a:fld>
             <a:endParaRPr lang="en-US" dirty="0"/>
           </a:p>
@@ -9638,6 +9470,170 @@
           <p:cNvPr id="2" name="Title 1">
             <a:extLst>
               <a:ext uri="{FF2B5EF4-FFF2-40B4-BE49-F238E27FC236}">
+                <a16:creationId xmlns:a16="http://schemas.microsoft.com/office/drawing/2014/main" id="{338A15DE-D135-0710-9984-A0A55E960CB0}"/>
+              </a:ext>
+            </a:extLst>
+          </p:cNvPr>
+          <p:cNvSpPr>
+            <a:spLocks noGrp="1"/>
+          </p:cNvSpPr>
+          <p:nvPr>
+            <p:ph type="title"/>
+          </p:nvPr>
+        </p:nvSpPr>
+        <p:spPr>
+          <a:xfrm>
+            <a:off x="1280160" y="3931920"/>
+            <a:ext cx="5029200" cy="1828800"/>
+          </a:xfrm>
+          <a:noFill/>
+        </p:spPr>
+        <p:txBody>
+          <a:bodyPr/>
+          <a:lstStyle/>
+          <a:p>
+            <a:r>
+              <a:rPr lang="en-US" dirty="0"/>
+              <a:t>market comparison</a:t>
+            </a:r>
+          </a:p>
+        </p:txBody>
+      </p:sp>
+      <p:pic>
+        <p:nvPicPr>
+          <p:cNvPr id="6" name="Picture Placeholder 17" descr="Scientist looking at a test tube">
+            <a:extLst>
+              <a:ext uri="{FF2B5EF4-FFF2-40B4-BE49-F238E27FC236}">
+                <a16:creationId xmlns:a16="http://schemas.microsoft.com/office/drawing/2014/main" id="{23F775E2-246C-F1D2-C3A0-D4C55F65CC82}"/>
+              </a:ext>
+            </a:extLst>
+          </p:cNvPr>
+          <p:cNvPicPr>
+            <a:picLocks noGrp="1" noChangeAspect="1"/>
+          </p:cNvPicPr>
+          <p:nvPr>
+            <p:ph type="pic" sz="quarter" idx="14"/>
+          </p:nvPr>
+        </p:nvPicPr>
+        <p:blipFill>
+          <a:blip r:embed="rId2">
+            <a:extLst>
+              <a:ext uri="{28A0092B-C50C-407E-A947-70E740481C1C}">
+                <a14:useLocalDpi xmlns:a14="http://schemas.microsoft.com/office/drawing/2010/main" val="0"/>
+              </a:ext>
+            </a:extLst>
+          </a:blip>
+          <a:srcRect t="26" b="26"/>
+          <a:stretch/>
+        </p:blipFill>
+        <p:spPr>
+          <a:xfrm>
+            <a:off x="1280160" y="548640"/>
+            <a:ext cx="3017520" cy="3017520"/>
+          </a:xfrm>
+        </p:spPr>
+      </p:pic>
+      <p:sp>
+        <p:nvSpPr>
+          <p:cNvPr id="3" name="Content Placeholder 2">
+            <a:extLst>
+              <a:ext uri="{FF2B5EF4-FFF2-40B4-BE49-F238E27FC236}">
+                <a16:creationId xmlns:a16="http://schemas.microsoft.com/office/drawing/2014/main" id="{ECC8AA23-D8D0-93BE-5C5F-103A750B0D2F}"/>
+              </a:ext>
+            </a:extLst>
+          </p:cNvPr>
+          <p:cNvSpPr>
+            <a:spLocks noGrp="1"/>
+          </p:cNvSpPr>
+          <p:nvPr>
+            <p:ph sz="half" idx="1"/>
+          </p:nvPr>
+        </p:nvSpPr>
+        <p:spPr>
+          <a:xfrm>
+            <a:off x="7205472" y="731520"/>
+            <a:ext cx="4306824" cy="5394960"/>
+          </a:xfrm>
+          <a:noFill/>
+        </p:spPr>
+        <p:txBody>
+          <a:bodyPr vert="horz" lIns="91440" tIns="45720" rIns="91440" bIns="45720" rtlCol="0" anchor="b" anchorCtr="0">
+            <a:noAutofit/>
+          </a:bodyPr>
+          <a:lstStyle/>
+          <a:p>
+            <a:r>
+              <a:rPr lang="en-US" dirty="0"/>
+              <a:t>Stands out in market</a:t>
+            </a:r>
+          </a:p>
+          <a:p>
+            <a:r>
+              <a:rPr lang="en-US" dirty="0"/>
+              <a:t>Innovative features</a:t>
+            </a:r>
+          </a:p>
+          <a:p>
+            <a:r>
+              <a:rPr lang="en-US" dirty="0"/>
+              <a:t>Provides unique solution</a:t>
+            </a:r>
+          </a:p>
+          <a:p>
+            <a:r>
+              <a:rPr lang="en-US" dirty="0"/>
+              <a:t>Edge over competitors</a:t>
+            </a:r>
+          </a:p>
+          <a:p>
+            <a:r>
+              <a:rPr lang="en-US" dirty="0"/>
+              <a:t>User-focused design</a:t>
+            </a:r>
+          </a:p>
+          <a:p>
+            <a:r>
+              <a:rPr lang="en-US" dirty="0"/>
+              <a:t>Prioritizes user experience</a:t>
+            </a:r>
+          </a:p>
+        </p:txBody>
+      </p:sp>
+    </p:spTree>
+    <p:extLst>
+      <p:ext uri="{BB962C8B-B14F-4D97-AF65-F5344CB8AC3E}">
+        <p14:creationId xmlns:p14="http://schemas.microsoft.com/office/powerpoint/2010/main" val="2737241225"/>
+      </p:ext>
+    </p:extLst>
+  </p:cSld>
+  <p:clrMapOvr>
+    <a:masterClrMapping/>
+  </p:clrMapOvr>
+</p:sld>
+</file>
+
+<file path=ppt/slides/slide11.xml><?xml version="1.0" encoding="utf-8"?>
+<p:sld xmlns:a="http://schemas.openxmlformats.org/drawingml/2006/main" xmlns:r="http://schemas.openxmlformats.org/officeDocument/2006/relationships" xmlns:p="http://schemas.openxmlformats.org/presentationml/2006/main" show="0">
+  <p:cSld>
+    <p:spTree>
+      <p:nvGrpSpPr>
+        <p:cNvPr id="1" name=""/>
+        <p:cNvGrpSpPr/>
+        <p:nvPr/>
+      </p:nvGrpSpPr>
+      <p:grpSpPr>
+        <a:xfrm>
+          <a:off x="0" y="0"/>
+          <a:ext cx="0" cy="0"/>
+          <a:chOff x="0" y="0"/>
+          <a:chExt cx="0" cy="0"/>
+        </a:xfrm>
+      </p:grpSpPr>
+      <p:sp>
+        <p:nvSpPr>
+          <p:cNvPr id="2" name="Title 1">
+            <a:extLst>
+              <a:ext uri="{FF2B5EF4-FFF2-40B4-BE49-F238E27FC236}">
                 <a16:creationId xmlns:a16="http://schemas.microsoft.com/office/drawing/2014/main" id="{314C27C8-165C-5513-DB4B-9D840097C545}"/>
               </a:ext>
             </a:extLst>
@@ -9759,7 +9755,7 @@
 </p:sld>
 </file>
 
-<file path=ppt/slides/slide11.xml><?xml version="1.0" encoding="utf-8"?>
+<file path=ppt/slides/slide12.xml><?xml version="1.0" encoding="utf-8"?>
 <p:sld xmlns:a="http://schemas.openxmlformats.org/drawingml/2006/main" xmlns:r="http://schemas.openxmlformats.org/officeDocument/2006/relationships" xmlns:p="http://schemas.openxmlformats.org/presentationml/2006/main" show="0">
   <p:cSld>
     <p:spTree>
@@ -10120,7 +10116,7 @@
 </p:sld>
 </file>
 
-<file path=ppt/slides/slide12.xml><?xml version="1.0" encoding="utf-8"?>
+<file path=ppt/slides/slide13.xml><?xml version="1.0" encoding="utf-8"?>
 <p:sld xmlns:a="http://schemas.openxmlformats.org/drawingml/2006/main" xmlns:r="http://schemas.openxmlformats.org/officeDocument/2006/relationships" xmlns:p="http://schemas.openxmlformats.org/presentationml/2006/main" show="0">
   <p:cSld>
     <p:spTree>
@@ -10564,176 +10560,6 @@
 </p:sld>
 </file>
 
-<file path=ppt/slides/slide13.xml><?xml version="1.0" encoding="utf-8"?>
-<p:sld xmlns:a="http://schemas.openxmlformats.org/drawingml/2006/main" xmlns:r="http://schemas.openxmlformats.org/officeDocument/2006/relationships" xmlns:p="http://schemas.openxmlformats.org/presentationml/2006/main" show="0">
-  <p:cSld>
-    <p:spTree>
-      <p:nvGrpSpPr>
-        <p:cNvPr id="1" name=""/>
-        <p:cNvGrpSpPr/>
-        <p:nvPr/>
-      </p:nvGrpSpPr>
-      <p:grpSpPr>
-        <a:xfrm>
-          <a:off x="0" y="0"/>
-          <a:ext cx="0" cy="0"/>
-          <a:chOff x="0" y="0"/>
-          <a:chExt cx="0" cy="0"/>
-        </a:xfrm>
-      </p:grpSpPr>
-      <p:sp>
-        <p:nvSpPr>
-          <p:cNvPr id="2" name="Title 1">
-            <a:extLst>
-              <a:ext uri="{FF2B5EF4-FFF2-40B4-BE49-F238E27FC236}">
-                <a16:creationId xmlns:a16="http://schemas.microsoft.com/office/drawing/2014/main" id="{5D030A76-B788-B363-104E-266B7C7F7208}"/>
-              </a:ext>
-            </a:extLst>
-          </p:cNvPr>
-          <p:cNvSpPr>
-            <a:spLocks noGrp="1"/>
-          </p:cNvSpPr>
-          <p:nvPr>
-            <p:ph type="title"/>
-          </p:nvPr>
-        </p:nvSpPr>
-        <p:spPr>
-          <a:xfrm>
-            <a:off x="1280160" y="1097280"/>
-            <a:ext cx="9821955" cy="914400"/>
-          </a:xfrm>
-          <a:noFill/>
-        </p:spPr>
-        <p:txBody>
-          <a:bodyPr anchor="t" anchorCtr="0"/>
-          <a:lstStyle/>
-          <a:p>
-            <a:r>
-              <a:rPr lang="en-US" dirty="0"/>
-              <a:t>Summary</a:t>
-            </a:r>
-          </a:p>
-        </p:txBody>
-      </p:sp>
-      <p:sp>
-        <p:nvSpPr>
-          <p:cNvPr id="3" name="Content Placeholder 2">
-            <a:extLst>
-              <a:ext uri="{FF2B5EF4-FFF2-40B4-BE49-F238E27FC236}">
-                <a16:creationId xmlns:a16="http://schemas.microsoft.com/office/drawing/2014/main" id="{05948542-FCE1-3AE6-C6C9-17975609DF70}"/>
-              </a:ext>
-            </a:extLst>
-          </p:cNvPr>
-          <p:cNvSpPr>
-            <a:spLocks noGrp="1"/>
-          </p:cNvSpPr>
-          <p:nvPr>
-            <p:ph sz="half" idx="1"/>
-          </p:nvPr>
-        </p:nvSpPr>
-        <p:spPr>
-          <a:xfrm>
-            <a:off x="1280160" y="2377440"/>
-            <a:ext cx="4663440" cy="3566160"/>
-          </a:xfrm>
-          <a:solidFill>
-            <a:schemeClr val="accent4"/>
-          </a:solidFill>
-        </p:spPr>
-        <p:txBody>
-          <a:bodyPr vert="horz" lIns="365760" tIns="365760" rIns="365760" bIns="365760" rtlCol="0" anchor="t">
-            <a:normAutofit lnSpcReduction="10000"/>
-          </a:bodyPr>
-          <a:lstStyle/>
-          <a:p>
-            <a:r>
-              <a:rPr lang="en-US" dirty="0"/>
-              <a:t>With this product, Adatum Corporation is positioned for success in the dynamic market. </a:t>
-            </a:r>
-          </a:p>
-          <a:p>
-            <a:r>
-              <a:rPr lang="en-US" dirty="0"/>
-              <a:t>With a focus on innovation, user experience, and strategic growth, we anticipate reaching new heights in the coming year.</a:t>
-            </a:r>
-          </a:p>
-          <a:p>
-            <a:r>
-              <a:rPr lang="en-US" dirty="0"/>
-              <a:t>Our commitment to user satisfaction underscores every aspect of our operations</a:t>
-            </a:r>
-          </a:p>
-        </p:txBody>
-      </p:sp>
-      <p:sp>
-        <p:nvSpPr>
-          <p:cNvPr id="4" name="Content Placeholder 3">
-            <a:extLst>
-              <a:ext uri="{FF2B5EF4-FFF2-40B4-BE49-F238E27FC236}">
-                <a16:creationId xmlns:a16="http://schemas.microsoft.com/office/drawing/2014/main" id="{3EE67564-0457-E486-97D0-8109D2C97B3F}"/>
-              </a:ext>
-            </a:extLst>
-          </p:cNvPr>
-          <p:cNvSpPr>
-            <a:spLocks noGrp="1"/>
-          </p:cNvSpPr>
-          <p:nvPr>
-            <p:ph sz="half" idx="2"/>
-          </p:nvPr>
-        </p:nvSpPr>
-        <p:spPr>
-          <a:xfrm>
-            <a:off x="6309360" y="2377440"/>
-            <a:ext cx="4663440" cy="3566160"/>
-          </a:xfrm>
-          <a:solidFill>
-            <a:schemeClr val="accent4"/>
-          </a:solidFill>
-        </p:spPr>
-        <p:txBody>
-          <a:bodyPr vert="horz" lIns="365760" tIns="365760" rIns="365760" bIns="365760" rtlCol="0" anchor="t">
-            <a:normAutofit lnSpcReduction="10000"/>
-          </a:bodyPr>
-          <a:lstStyle/>
-          <a:p>
-            <a:r>
-              <a:rPr lang="en-US" dirty="0"/>
-              <a:t>Strong market positioning</a:t>
-            </a:r>
-          </a:p>
-          <a:p>
-            <a:r>
-              <a:rPr lang="en-US" dirty="0"/>
-              <a:t>Robust growth strategy</a:t>
-            </a:r>
-          </a:p>
-          <a:p>
-            <a:r>
-              <a:rPr lang="en-US" dirty="0"/>
-              <a:t>Innovative product development</a:t>
-            </a:r>
-          </a:p>
-          <a:p>
-            <a:r>
-              <a:rPr lang="en-US" dirty="0"/>
-              <a:t>Commitment to user satisfaction</a:t>
-            </a:r>
-          </a:p>
-        </p:txBody>
-      </p:sp>
-    </p:spTree>
-    <p:extLst>
-      <p:ext uri="{BB962C8B-B14F-4D97-AF65-F5344CB8AC3E}">
-        <p14:creationId xmlns:p14="http://schemas.microsoft.com/office/powerpoint/2010/main" val="643777997"/>
-      </p:ext>
-    </p:extLst>
-  </p:cSld>
-  <p:clrMapOvr>
-    <a:masterClrMapping/>
-  </p:clrMapOvr>
-</p:sld>
-</file>
-
 <file path=ppt/slides/slide14.xml><?xml version="1.0" encoding="utf-8"?>
 <p:sld xmlns:a="http://schemas.openxmlformats.org/drawingml/2006/main" xmlns:r="http://schemas.openxmlformats.org/officeDocument/2006/relationships" xmlns:p="http://schemas.openxmlformats.org/presentationml/2006/main" show="0">
   <p:cSld>
@@ -12402,6 +12228,126 @@
 </file>
 
 <file path=ppt/slides/slide6.xml><?xml version="1.0" encoding="utf-8"?>
+<p:sld xmlns:a="http://schemas.openxmlformats.org/drawingml/2006/main" xmlns:r="http://schemas.openxmlformats.org/officeDocument/2006/relationships" xmlns:p="http://schemas.openxmlformats.org/presentationml/2006/main">
+  <p:cSld>
+    <p:spTree>
+      <p:nvGrpSpPr>
+        <p:cNvPr id="1" name=""/>
+        <p:cNvGrpSpPr/>
+        <p:nvPr/>
+      </p:nvGrpSpPr>
+      <p:grpSpPr>
+        <a:xfrm>
+          <a:off x="0" y="0"/>
+          <a:ext cx="0" cy="0"/>
+          <a:chOff x="0" y="0"/>
+          <a:chExt cx="0" cy="0"/>
+        </a:xfrm>
+      </p:grpSpPr>
+      <p:sp>
+        <p:nvSpPr>
+          <p:cNvPr id="2" name="Title 1">
+            <a:extLst>
+              <a:ext uri="{FF2B5EF4-FFF2-40B4-BE49-F238E27FC236}">
+                <a16:creationId xmlns:a16="http://schemas.microsoft.com/office/drawing/2014/main" id="{5D030A76-B788-B363-104E-266B7C7F7208}"/>
+              </a:ext>
+            </a:extLst>
+          </p:cNvPr>
+          <p:cNvSpPr>
+            <a:spLocks noGrp="1"/>
+          </p:cNvSpPr>
+          <p:nvPr>
+            <p:ph type="title"/>
+          </p:nvPr>
+        </p:nvSpPr>
+        <p:spPr>
+          <a:xfrm>
+            <a:off x="1280160" y="1097280"/>
+            <a:ext cx="9821955" cy="914400"/>
+          </a:xfrm>
+          <a:noFill/>
+        </p:spPr>
+        <p:txBody>
+          <a:bodyPr anchor="t" anchorCtr="0"/>
+          <a:lstStyle/>
+          <a:p>
+            <a:r>
+              <a:rPr lang="en-US" dirty="0"/>
+              <a:t>Summary</a:t>
+            </a:r>
+          </a:p>
+        </p:txBody>
+      </p:sp>
+      <p:sp>
+        <p:nvSpPr>
+          <p:cNvPr id="3" name="Content Placeholder 2">
+            <a:extLst>
+              <a:ext uri="{FF2B5EF4-FFF2-40B4-BE49-F238E27FC236}">
+                <a16:creationId xmlns:a16="http://schemas.microsoft.com/office/drawing/2014/main" id="{05948542-FCE1-3AE6-C6C9-17975609DF70}"/>
+              </a:ext>
+            </a:extLst>
+          </p:cNvPr>
+          <p:cNvSpPr>
+            <a:spLocks noGrp="1"/>
+          </p:cNvSpPr>
+          <p:nvPr>
+            <p:ph sz="half" idx="1"/>
+          </p:nvPr>
+        </p:nvSpPr>
+        <p:spPr>
+          <a:xfrm>
+            <a:off x="3512997" y="2419970"/>
+            <a:ext cx="4663440" cy="3566160"/>
+          </a:xfrm>
+          <a:solidFill>
+            <a:schemeClr val="accent4"/>
+          </a:solidFill>
+        </p:spPr>
+        <p:txBody>
+          <a:bodyPr vert="horz" lIns="365760" tIns="365760" rIns="365760" bIns="365760" rtlCol="0" anchor="t">
+            <a:normAutofit/>
+          </a:bodyPr>
+          <a:lstStyle/>
+          <a:p>
+            <a:r>
+              <a:rPr lang="en-US" dirty="0"/>
+              <a:t>O-ring provides sufficient seals</a:t>
+            </a:r>
+          </a:p>
+          <a:p>
+            <a:r>
+              <a:rPr lang="en-US" dirty="0"/>
+              <a:t>Compatible with Greiner Multi-well plates</a:t>
+            </a:r>
+          </a:p>
+          <a:p>
+            <a:r>
+              <a:rPr lang="en-US" dirty="0"/>
+              <a:t>Secured using countersunk screws</a:t>
+            </a:r>
+          </a:p>
+          <a:p>
+            <a:r>
+              <a:rPr lang="en-US" dirty="0"/>
+              <a:t>Unobstructed viewing from bottom</a:t>
+            </a:r>
+          </a:p>
+        </p:txBody>
+      </p:sp>
+    </p:spTree>
+    <p:extLst>
+      <p:ext uri="{BB962C8B-B14F-4D97-AF65-F5344CB8AC3E}">
+        <p14:creationId xmlns:p14="http://schemas.microsoft.com/office/powerpoint/2010/main" val="643777997"/>
+      </p:ext>
+    </p:extLst>
+  </p:cSld>
+  <p:clrMapOvr>
+    <a:masterClrMapping/>
+  </p:clrMapOvr>
+</p:sld>
+</file>
+
+<file path=ppt/slides/slide7.xml><?xml version="1.0" encoding="utf-8"?>
 <p:sld xmlns:a="http://schemas.openxmlformats.org/drawingml/2006/main" xmlns:r="http://schemas.openxmlformats.org/officeDocument/2006/relationships" xmlns:p="http://schemas.openxmlformats.org/presentationml/2006/main" show="0">
   <p:cSld>
     <p:spTree>
@@ -12501,7 +12447,7 @@
 </p:sld>
 </file>
 
-<file path=ppt/slides/slide7.xml><?xml version="1.0" encoding="utf-8"?>
+<file path=ppt/slides/slide8.xml><?xml version="1.0" encoding="utf-8"?>
 <p:sld xmlns:a="http://schemas.openxmlformats.org/drawingml/2006/main" xmlns:r="http://schemas.openxmlformats.org/officeDocument/2006/relationships" xmlns:p="http://schemas.openxmlformats.org/presentationml/2006/main" show="0">
   <p:cSld>
     <p:spTree>
@@ -12651,7 +12597,7 @@
 </p:sld>
 </file>
 
-<file path=ppt/slides/slide8.xml><?xml version="1.0" encoding="utf-8"?>
+<file path=ppt/slides/slide9.xml><?xml version="1.0" encoding="utf-8"?>
 <p:sld xmlns:a="http://schemas.openxmlformats.org/drawingml/2006/main" xmlns:r="http://schemas.openxmlformats.org/officeDocument/2006/relationships" xmlns:p="http://schemas.openxmlformats.org/presentationml/2006/main" show="0">
   <p:cSld>
     <p:bg>
@@ -12742,170 +12688,6 @@
     <p:extLst>
       <p:ext uri="{BB962C8B-B14F-4D97-AF65-F5344CB8AC3E}">
         <p14:creationId xmlns:p14="http://schemas.microsoft.com/office/powerpoint/2010/main" val="3058085568"/>
-      </p:ext>
-    </p:extLst>
-  </p:cSld>
-  <p:clrMapOvr>
-    <a:masterClrMapping/>
-  </p:clrMapOvr>
-</p:sld>
-</file>
-
-<file path=ppt/slides/slide9.xml><?xml version="1.0" encoding="utf-8"?>
-<p:sld xmlns:a="http://schemas.openxmlformats.org/drawingml/2006/main" xmlns:r="http://schemas.openxmlformats.org/officeDocument/2006/relationships" xmlns:p="http://schemas.openxmlformats.org/presentationml/2006/main" show="0">
-  <p:cSld>
-    <p:spTree>
-      <p:nvGrpSpPr>
-        <p:cNvPr id="1" name=""/>
-        <p:cNvGrpSpPr/>
-        <p:nvPr/>
-      </p:nvGrpSpPr>
-      <p:grpSpPr>
-        <a:xfrm>
-          <a:off x="0" y="0"/>
-          <a:ext cx="0" cy="0"/>
-          <a:chOff x="0" y="0"/>
-          <a:chExt cx="0" cy="0"/>
-        </a:xfrm>
-      </p:grpSpPr>
-      <p:sp>
-        <p:nvSpPr>
-          <p:cNvPr id="2" name="Title 1">
-            <a:extLst>
-              <a:ext uri="{FF2B5EF4-FFF2-40B4-BE49-F238E27FC236}">
-                <a16:creationId xmlns:a16="http://schemas.microsoft.com/office/drawing/2014/main" id="{338A15DE-D135-0710-9984-A0A55E960CB0}"/>
-              </a:ext>
-            </a:extLst>
-          </p:cNvPr>
-          <p:cNvSpPr>
-            <a:spLocks noGrp="1"/>
-          </p:cNvSpPr>
-          <p:nvPr>
-            <p:ph type="title"/>
-          </p:nvPr>
-        </p:nvSpPr>
-        <p:spPr>
-          <a:xfrm>
-            <a:off x="1280160" y="3931920"/>
-            <a:ext cx="5029200" cy="1828800"/>
-          </a:xfrm>
-          <a:noFill/>
-        </p:spPr>
-        <p:txBody>
-          <a:bodyPr/>
-          <a:lstStyle/>
-          <a:p>
-            <a:r>
-              <a:rPr lang="en-US" dirty="0"/>
-              <a:t>market comparison</a:t>
-            </a:r>
-          </a:p>
-        </p:txBody>
-      </p:sp>
-      <p:pic>
-        <p:nvPicPr>
-          <p:cNvPr id="6" name="Picture Placeholder 17" descr="Scientist looking at a test tube">
-            <a:extLst>
-              <a:ext uri="{FF2B5EF4-FFF2-40B4-BE49-F238E27FC236}">
-                <a16:creationId xmlns:a16="http://schemas.microsoft.com/office/drawing/2014/main" id="{23F775E2-246C-F1D2-C3A0-D4C55F65CC82}"/>
-              </a:ext>
-            </a:extLst>
-          </p:cNvPr>
-          <p:cNvPicPr>
-            <a:picLocks noGrp="1" noChangeAspect="1"/>
-          </p:cNvPicPr>
-          <p:nvPr>
-            <p:ph type="pic" sz="quarter" idx="14"/>
-          </p:nvPr>
-        </p:nvPicPr>
-        <p:blipFill>
-          <a:blip r:embed="rId2">
-            <a:extLst>
-              <a:ext uri="{28A0092B-C50C-407E-A947-70E740481C1C}">
-                <a14:useLocalDpi xmlns:a14="http://schemas.microsoft.com/office/drawing/2010/main" val="0"/>
-              </a:ext>
-            </a:extLst>
-          </a:blip>
-          <a:srcRect t="26" b="26"/>
-          <a:stretch/>
-        </p:blipFill>
-        <p:spPr>
-          <a:xfrm>
-            <a:off x="1280160" y="548640"/>
-            <a:ext cx="3017520" cy="3017520"/>
-          </a:xfrm>
-        </p:spPr>
-      </p:pic>
-      <p:sp>
-        <p:nvSpPr>
-          <p:cNvPr id="3" name="Content Placeholder 2">
-            <a:extLst>
-              <a:ext uri="{FF2B5EF4-FFF2-40B4-BE49-F238E27FC236}">
-                <a16:creationId xmlns:a16="http://schemas.microsoft.com/office/drawing/2014/main" id="{ECC8AA23-D8D0-93BE-5C5F-103A750B0D2F}"/>
-              </a:ext>
-            </a:extLst>
-          </p:cNvPr>
-          <p:cNvSpPr>
-            <a:spLocks noGrp="1"/>
-          </p:cNvSpPr>
-          <p:nvPr>
-            <p:ph sz="half" idx="1"/>
-          </p:nvPr>
-        </p:nvSpPr>
-        <p:spPr>
-          <a:xfrm>
-            <a:off x="7205472" y="731520"/>
-            <a:ext cx="4306824" cy="5394960"/>
-          </a:xfrm>
-          <a:noFill/>
-        </p:spPr>
-        <p:txBody>
-          <a:bodyPr vert="horz" lIns="91440" tIns="45720" rIns="91440" bIns="45720" rtlCol="0" anchor="b" anchorCtr="0">
-            <a:noAutofit/>
-          </a:bodyPr>
-          <a:lstStyle/>
-          <a:p>
-            <a:r>
-              <a:rPr lang="en-US" dirty="0"/>
-              <a:t>Stands out in market</a:t>
-            </a:r>
-          </a:p>
-          <a:p>
-            <a:r>
-              <a:rPr lang="en-US" dirty="0"/>
-              <a:t>Innovative features</a:t>
-            </a:r>
-          </a:p>
-          <a:p>
-            <a:r>
-              <a:rPr lang="en-US" dirty="0"/>
-              <a:t>Provides unique solution</a:t>
-            </a:r>
-          </a:p>
-          <a:p>
-            <a:r>
-              <a:rPr lang="en-US" dirty="0"/>
-              <a:t>Edge over competitors</a:t>
-            </a:r>
-          </a:p>
-          <a:p>
-            <a:r>
-              <a:rPr lang="en-US" dirty="0"/>
-              <a:t>User-focused design</a:t>
-            </a:r>
-          </a:p>
-          <a:p>
-            <a:r>
-              <a:rPr lang="en-US" dirty="0"/>
-              <a:t>Prioritizes user experience</a:t>
-            </a:r>
-          </a:p>
-        </p:txBody>
-      </p:sp>
-    </p:spTree>
-    <p:extLst>
-      <p:ext uri="{BB962C8B-B14F-4D97-AF65-F5344CB8AC3E}">
-        <p14:creationId xmlns:p14="http://schemas.microsoft.com/office/powerpoint/2010/main" val="2737241225"/>
       </p:ext>
     </p:extLst>
   </p:cSld>
@@ -14019,6 +13801,15 @@
 </file>
 
 <file path=customXml/item2.xml><?xml version="1.0" encoding="utf-8"?>
+<?mso-contentType ?>
+<FormTemplates xmlns="http://schemas.microsoft.com/sharepoint/v3/contenttype/forms">
+  <Display>DocumentLibraryForm</Display>
+  <Edit>DocumentLibraryForm</Edit>
+  <New>DocumentLibraryForm</New>
+</FormTemplates>
+</file>
+
+<file path=customXml/item3.xml><?xml version="1.0" encoding="utf-8"?>
 <p:properties xmlns:p="http://schemas.microsoft.com/office/2006/metadata/properties" xmlns:xsi="http://www.w3.org/2001/XMLSchema-instance" xmlns:pc="http://schemas.microsoft.com/office/infopath/2007/PartnerControls">
   <documentManagement>
     <_ip_UnifiedCompliancePolicyUIAction xmlns="http://schemas.microsoft.com/sharepoint/v3" xsi:nil="true"/>
@@ -14036,15 +13827,6 @@
     <MediaServiceKeyPoints xmlns="71af3243-3dd4-4a8d-8c0d-dd76da1f02a5" xsi:nil="true"/>
   </documentManagement>
 </p:properties>
-</file>
-
-<file path=customXml/item3.xml><?xml version="1.0" encoding="utf-8"?>
-<?mso-contentType ?>
-<FormTemplates xmlns="http://schemas.microsoft.com/sharepoint/v3/contenttype/forms">
-  <Display>DocumentLibraryForm</Display>
-  <Edit>DocumentLibraryForm</Edit>
-  <New>DocumentLibraryForm</New>
-</FormTemplates>
 </file>
 
 <file path=customXml/itemProps1.xml><?xml version="1.0" encoding="utf-8"?>
@@ -14069,6 +13851,14 @@
 </file>
 
 <file path=customXml/itemProps2.xml><?xml version="1.0" encoding="utf-8"?>
+<ds:datastoreItem xmlns:ds="http://schemas.openxmlformats.org/officeDocument/2006/customXml" ds:itemID="{DF8397A0-8C35-4EEE-8E61-47C914415B57}">
+  <ds:schemaRefs>
+    <ds:schemaRef ds:uri="http://schemas.microsoft.com/sharepoint/v3/contenttype/forms"/>
+  </ds:schemaRefs>
+</ds:datastoreItem>
+</file>
+
+<file path=customXml/itemProps3.xml><?xml version="1.0" encoding="utf-8"?>
 <ds:datastoreItem xmlns:ds="http://schemas.openxmlformats.org/officeDocument/2006/customXml" ds:itemID="{B881D8D6-8849-400B-8BC9-21D401C7DD06}">
   <ds:schemaRefs>
     <ds:schemaRef ds:uri="http://schemas.microsoft.com/office/2006/metadata/properties"/>
@@ -14080,14 +13870,6 @@
 </ds:datastoreItem>
 </file>
 
-<file path=customXml/itemProps3.xml><?xml version="1.0" encoding="utf-8"?>
-<ds:datastoreItem xmlns:ds="http://schemas.openxmlformats.org/officeDocument/2006/customXml" ds:itemID="{DF8397A0-8C35-4EEE-8E61-47C914415B57}">
-  <ds:schemaRefs>
-    <ds:schemaRef ds:uri="http://schemas.microsoft.com/sharepoint/v3/contenttype/forms"/>
-  </ds:schemaRefs>
-</ds:datastoreItem>
-</file>
-
 <file path=docMetadata/LabelInfo.xml><?xml version="1.0" encoding="utf-8"?>
 <clbl:labelList xmlns:clbl="http://schemas.microsoft.com/office/2020/mipLabelMetadata"/>
 </file>
</xml_diff>

<commit_message>
Added Research notes, final report and onpboarding presentation
</commit_message>
<xml_diff>
--- a/Onboarding_Presentation.pptx
+++ b/Onboarding_Presentation.pptx
@@ -157,416 +157,53 @@
 </p:cmAuthorLst>
 </file>
 
+<file path=ppt/revisionInfo.xml><?xml version="1.0" encoding="utf-8"?>
+<p1510:revInfo xmlns:a="http://schemas.openxmlformats.org/drawingml/2006/main" xmlns:r="http://schemas.openxmlformats.org/officeDocument/2006/relationships" xmlns:p1510="http://schemas.microsoft.com/office/powerpoint/2015/10/main">
+  <p1510:revLst>
+    <p1510:client id="{FCF8817A-E007-4D65-9F3A-211847F11E0D}" v="1" dt="2026-06-01T11:39:11.483"/>
+  </p1510:revLst>
+</p1510:revInfo>
+</file>
+
 <file path=ppt/changesInfos/changesInfo1.xml><?xml version="1.0" encoding="utf-8"?>
 <pc:chgInfo xmlns:a="http://schemas.openxmlformats.org/drawingml/2006/main" xmlns:r="http://schemas.openxmlformats.org/officeDocument/2006/relationships" xmlns:ac="http://schemas.microsoft.com/office/drawing/2013/main/command" xmlns:pc="http://schemas.microsoft.com/office/powerpoint/2013/main/command">
   <pc:docChgLst>
     <pc:chgData name="Joab Kloppers" userId="bcab5db0-8267-4c54-83c3-7ddba1e5c6be" providerId="ADAL" clId="{90E0EE0E-984C-4547-AADC-7DD4534EA015}"/>
     <pc:docChg chg="undo custSel addSld delSld modSld sldOrd">
-      <pc:chgData name="Joab Kloppers" userId="bcab5db0-8267-4c54-83c3-7ddba1e5c6be" providerId="ADAL" clId="{90E0EE0E-984C-4547-AADC-7DD4534EA015}" dt="2026-02-21T12:08:04.153" v="10532" actId="1076"/>
+      <pc:chgData name="Joab Kloppers" userId="bcab5db0-8267-4c54-83c3-7ddba1e5c6be" providerId="ADAL" clId="{90E0EE0E-984C-4547-AADC-7DD4534EA015}" dt="2026-06-01T11:46:15.116" v="11325" actId="6549"/>
       <pc:docMkLst>
         <pc:docMk/>
       </pc:docMkLst>
-      <pc:sldChg chg="mod modShow">
-        <pc:chgData name="Joab Kloppers" userId="bcab5db0-8267-4c54-83c3-7ddba1e5c6be" providerId="ADAL" clId="{90E0EE0E-984C-4547-AADC-7DD4534EA015}" dt="2026-02-02T07:26:42.609" v="7702" actId="729"/>
-        <pc:sldMkLst>
-          <pc:docMk/>
-          <pc:sldMk cId="435195399" sldId="257"/>
-        </pc:sldMkLst>
-      </pc:sldChg>
-      <pc:sldChg chg="mod modShow">
-        <pc:chgData name="Joab Kloppers" userId="bcab5db0-8267-4c54-83c3-7ddba1e5c6be" providerId="ADAL" clId="{90E0EE0E-984C-4547-AADC-7DD4534EA015}" dt="2026-02-02T07:26:53.099" v="7703" actId="729"/>
-        <pc:sldMkLst>
-          <pc:docMk/>
-          <pc:sldMk cId="3058085568" sldId="258"/>
-        </pc:sldMkLst>
-      </pc:sldChg>
-      <pc:sldChg chg="addSp delSp modSp mod modShow modNotesTx">
-        <pc:chgData name="Joab Kloppers" userId="bcab5db0-8267-4c54-83c3-7ddba1e5c6be" providerId="ADAL" clId="{90E0EE0E-984C-4547-AADC-7DD4534EA015}" dt="2026-02-10T20:16:13.327" v="9403" actId="729"/>
-        <pc:sldMkLst>
-          <pc:docMk/>
-          <pc:sldMk cId="1008037533" sldId="259"/>
-        </pc:sldMkLst>
-        <pc:spChg chg="mod">
-          <ac:chgData name="Joab Kloppers" userId="bcab5db0-8267-4c54-83c3-7ddba1e5c6be" providerId="ADAL" clId="{90E0EE0E-984C-4547-AADC-7DD4534EA015}" dt="2026-02-10T20:11:53.006" v="8777" actId="20577"/>
-          <ac:spMkLst>
-            <pc:docMk/>
-            <pc:sldMk cId="1008037533" sldId="259"/>
-            <ac:spMk id="2" creationId="{954ABE40-AA00-F366-A36A-B3F1AADBF025}"/>
-          </ac:spMkLst>
-        </pc:spChg>
-        <pc:spChg chg="add mod">
-          <ac:chgData name="Joab Kloppers" userId="bcab5db0-8267-4c54-83c3-7ddba1e5c6be" providerId="ADAL" clId="{90E0EE0E-984C-4547-AADC-7DD4534EA015}" dt="2026-02-10T20:07:55.308" v="8657" actId="1076"/>
-          <ac:spMkLst>
-            <pc:docMk/>
-            <pc:sldMk cId="1008037533" sldId="259"/>
-            <ac:spMk id="25" creationId="{BC2618DD-1892-E29D-47BA-8589984A0E8A}"/>
-          </ac:spMkLst>
-        </pc:spChg>
-        <pc:spChg chg="add mod">
-          <ac:chgData name="Joab Kloppers" userId="bcab5db0-8267-4c54-83c3-7ddba1e5c6be" providerId="ADAL" clId="{90E0EE0E-984C-4547-AADC-7DD4534EA015}" dt="2026-02-10T20:10:10.061" v="8730" actId="1076"/>
-          <ac:spMkLst>
-            <pc:docMk/>
-            <pc:sldMk cId="1008037533" sldId="259"/>
-            <ac:spMk id="32" creationId="{DDA9F899-BE29-24FA-C41D-36583F125CF6}"/>
-          </ac:spMkLst>
-        </pc:spChg>
-        <pc:spChg chg="add mod">
-          <ac:chgData name="Joab Kloppers" userId="bcab5db0-8267-4c54-83c3-7ddba1e5c6be" providerId="ADAL" clId="{90E0EE0E-984C-4547-AADC-7DD4534EA015}" dt="2026-02-10T20:11:37.166" v="8774" actId="1076"/>
-          <ac:spMkLst>
-            <pc:docMk/>
-            <pc:sldMk cId="1008037533" sldId="259"/>
-            <ac:spMk id="35" creationId="{3F4DCCD6-9DDA-667A-813F-B248A9C132FF}"/>
-          </ac:spMkLst>
-        </pc:spChg>
-        <pc:spChg chg="add mod">
-          <ac:chgData name="Joab Kloppers" userId="bcab5db0-8267-4c54-83c3-7ddba1e5c6be" providerId="ADAL" clId="{90E0EE0E-984C-4547-AADC-7DD4534EA015}" dt="2026-02-10T20:11:25.298" v="8773" actId="1076"/>
-          <ac:spMkLst>
-            <pc:docMk/>
-            <pc:sldMk cId="1008037533" sldId="259"/>
-            <ac:spMk id="38" creationId="{2A6FCFB0-523B-627F-E71C-34AE61F532CB}"/>
-          </ac:spMkLst>
-        </pc:spChg>
-        <pc:picChg chg="add mod">
-          <ac:chgData name="Joab Kloppers" userId="bcab5db0-8267-4c54-83c3-7ddba1e5c6be" providerId="ADAL" clId="{90E0EE0E-984C-4547-AADC-7DD4534EA015}" dt="2026-02-10T19:08:16.243" v="8630" actId="1076"/>
-          <ac:picMkLst>
-            <pc:docMk/>
-            <pc:sldMk cId="1008037533" sldId="259"/>
-            <ac:picMk id="16" creationId="{EC0B6619-4249-56D3-AA68-E9D9F6A518EF}"/>
-          </ac:picMkLst>
-        </pc:picChg>
-        <pc:picChg chg="add mod">
-          <ac:chgData name="Joab Kloppers" userId="bcab5db0-8267-4c54-83c3-7ddba1e5c6be" providerId="ADAL" clId="{90E0EE0E-984C-4547-AADC-7DD4534EA015}" dt="2026-02-10T19:09:24.612" v="8638" actId="14100"/>
-          <ac:picMkLst>
-            <pc:docMk/>
-            <pc:sldMk cId="1008037533" sldId="259"/>
-            <ac:picMk id="22" creationId="{84FC55AD-FE16-0299-BFFE-CC8A810E6B37}"/>
-          </ac:picMkLst>
-        </pc:picChg>
-        <pc:cxnChg chg="add mod">
-          <ac:chgData name="Joab Kloppers" userId="bcab5db0-8267-4c54-83c3-7ddba1e5c6be" providerId="ADAL" clId="{90E0EE0E-984C-4547-AADC-7DD4534EA015}" dt="2026-02-10T19:09:43.222" v="8640" actId="208"/>
-          <ac:cxnSpMkLst>
-            <pc:docMk/>
-            <pc:sldMk cId="1008037533" sldId="259"/>
-            <ac:cxnSpMk id="24" creationId="{F1EA5270-97B0-DA22-7F2F-8ED6CAF1B1B7}"/>
-          </ac:cxnSpMkLst>
-        </pc:cxnChg>
-        <pc:cxnChg chg="add mod">
-          <ac:chgData name="Joab Kloppers" userId="bcab5db0-8267-4c54-83c3-7ddba1e5c6be" providerId="ADAL" clId="{90E0EE0E-984C-4547-AADC-7DD4534EA015}" dt="2026-02-10T20:08:31.657" v="8661" actId="13822"/>
-          <ac:cxnSpMkLst>
-            <pc:docMk/>
-            <pc:sldMk cId="1008037533" sldId="259"/>
-            <ac:cxnSpMk id="29" creationId="{7024E816-5B85-11F8-35EC-225C0329971D}"/>
-          </ac:cxnSpMkLst>
-        </pc:cxnChg>
-        <pc:cxnChg chg="add mod">
-          <ac:chgData name="Joab Kloppers" userId="bcab5db0-8267-4c54-83c3-7ddba1e5c6be" providerId="ADAL" clId="{90E0EE0E-984C-4547-AADC-7DD4534EA015}" dt="2026-02-10T20:08:43.870" v="8663" actId="13822"/>
-          <ac:cxnSpMkLst>
-            <pc:docMk/>
-            <pc:sldMk cId="1008037533" sldId="259"/>
-            <ac:cxnSpMk id="31" creationId="{E4EC052F-811E-C09D-98A9-9728117AA578}"/>
-          </ac:cxnSpMkLst>
-        </pc:cxnChg>
-        <pc:cxnChg chg="add mod">
-          <ac:chgData name="Joab Kloppers" userId="bcab5db0-8267-4c54-83c3-7ddba1e5c6be" providerId="ADAL" clId="{90E0EE0E-984C-4547-AADC-7DD4534EA015}" dt="2026-02-10T20:10:20.793" v="8732" actId="13822"/>
-          <ac:cxnSpMkLst>
-            <pc:docMk/>
-            <pc:sldMk cId="1008037533" sldId="259"/>
-            <ac:cxnSpMk id="34" creationId="{517535E0-6D4E-5EC7-FFBC-F5A505FDDD92}"/>
-          </ac:cxnSpMkLst>
-        </pc:cxnChg>
-        <pc:cxnChg chg="add mod">
-          <ac:chgData name="Joab Kloppers" userId="bcab5db0-8267-4c54-83c3-7ddba1e5c6be" providerId="ADAL" clId="{90E0EE0E-984C-4547-AADC-7DD4534EA015}" dt="2026-02-10T20:11:10.072" v="8750" actId="13822"/>
-          <ac:cxnSpMkLst>
-            <pc:docMk/>
-            <pc:sldMk cId="1008037533" sldId="259"/>
-            <ac:cxnSpMk id="37" creationId="{BD8243A6-ECCD-3ACC-9686-B609C752C91B}"/>
-          </ac:cxnSpMkLst>
-        </pc:cxnChg>
-      </pc:sldChg>
-      <pc:sldChg chg="mod modShow">
-        <pc:chgData name="Joab Kloppers" userId="bcab5db0-8267-4c54-83c3-7ddba1e5c6be" providerId="ADAL" clId="{90E0EE0E-984C-4547-AADC-7DD4534EA015}" dt="2026-02-02T07:26:53.099" v="7703" actId="729"/>
-        <pc:sldMkLst>
-          <pc:docMk/>
-          <pc:sldMk cId="3666674671" sldId="261"/>
-        </pc:sldMkLst>
-      </pc:sldChg>
-      <pc:sldChg chg="mod modShow">
-        <pc:chgData name="Joab Kloppers" userId="bcab5db0-8267-4c54-83c3-7ddba1e5c6be" providerId="ADAL" clId="{90E0EE0E-984C-4547-AADC-7DD4534EA015}" dt="2026-02-02T07:26:53.099" v="7703" actId="729"/>
-        <pc:sldMkLst>
-          <pc:docMk/>
-          <pc:sldMk cId="2737241225" sldId="263"/>
-        </pc:sldMkLst>
-      </pc:sldChg>
-      <pc:sldChg chg="modSp mod ord modNotesTx">
-        <pc:chgData name="Joab Kloppers" userId="bcab5db0-8267-4c54-83c3-7ddba1e5c6be" providerId="ADAL" clId="{90E0EE0E-984C-4547-AADC-7DD4534EA015}" dt="2026-02-10T18:56:02.236" v="8571" actId="20577"/>
-        <pc:sldMkLst>
-          <pc:docMk/>
-          <pc:sldMk cId="837402205" sldId="264"/>
-        </pc:sldMkLst>
-        <pc:spChg chg="mod">
-          <ac:chgData name="Joab Kloppers" userId="bcab5db0-8267-4c54-83c3-7ddba1e5c6be" providerId="ADAL" clId="{90E0EE0E-984C-4547-AADC-7DD4534EA015}" dt="2026-01-27T08:06:49.398" v="4010" actId="20577"/>
-          <ac:spMkLst>
-            <pc:docMk/>
-            <pc:sldMk cId="837402205" sldId="264"/>
-            <ac:spMk id="2" creationId="{47A9874B-BCA9-8420-1595-EDD1865A099A}"/>
-          </ac:spMkLst>
-        </pc:spChg>
-        <pc:spChg chg="mod">
-          <ac:chgData name="Joab Kloppers" userId="bcab5db0-8267-4c54-83c3-7ddba1e5c6be" providerId="ADAL" clId="{90E0EE0E-984C-4547-AADC-7DD4534EA015}" dt="2026-02-10T18:23:17.407" v="7782" actId="20577"/>
-          <ac:spMkLst>
-            <pc:docMk/>
-            <pc:sldMk cId="837402205" sldId="264"/>
-            <ac:spMk id="3" creationId="{68A5FD2B-E3E5-1C2B-0151-21F216B14A33}"/>
-          </ac:spMkLst>
-        </pc:spChg>
-        <pc:spChg chg="mod">
-          <ac:chgData name="Joab Kloppers" userId="bcab5db0-8267-4c54-83c3-7ddba1e5c6be" providerId="ADAL" clId="{90E0EE0E-984C-4547-AADC-7DD4534EA015}" dt="2026-01-27T14:20:02.694" v="4720" actId="5793"/>
-          <ac:spMkLst>
-            <pc:docMk/>
-            <pc:sldMk cId="837402205" sldId="264"/>
-            <ac:spMk id="4" creationId="{ACFBB810-3430-2C29-1AA0-9744AA0A1AA3}"/>
-          </ac:spMkLst>
-        </pc:spChg>
-      </pc:sldChg>
-      <pc:sldChg chg="mod modShow">
-        <pc:chgData name="Joab Kloppers" userId="bcab5db0-8267-4c54-83c3-7ddba1e5c6be" providerId="ADAL" clId="{90E0EE0E-984C-4547-AADC-7DD4534EA015}" dt="2026-02-02T07:26:53.099" v="7703" actId="729"/>
-        <pc:sldMkLst>
-          <pc:docMk/>
-          <pc:sldMk cId="729609147" sldId="265"/>
-        </pc:sldMkLst>
-      </pc:sldChg>
-      <pc:sldChg chg="delSp modSp mod ord modShow">
-        <pc:chgData name="Joab Kloppers" userId="bcab5db0-8267-4c54-83c3-7ddba1e5c6be" providerId="ADAL" clId="{90E0EE0E-984C-4547-AADC-7DD4534EA015}" dt="2026-02-21T12:08:04.153" v="10532" actId="1076"/>
+      <pc:sldChg chg="addSp delSp modSp mod ord modShow">
+        <pc:chgData name="Joab Kloppers" userId="bcab5db0-8267-4c54-83c3-7ddba1e5c6be" providerId="ADAL" clId="{90E0EE0E-984C-4547-AADC-7DD4534EA015}" dt="2026-06-01T11:46:15.116" v="11325" actId="6549"/>
         <pc:sldMkLst>
           <pc:docMk/>
           <pc:sldMk cId="643777997" sldId="266"/>
         </pc:sldMkLst>
         <pc:spChg chg="mod">
-          <ac:chgData name="Joab Kloppers" userId="bcab5db0-8267-4c54-83c3-7ddba1e5c6be" providerId="ADAL" clId="{90E0EE0E-984C-4547-AADC-7DD4534EA015}" dt="2026-02-21T12:08:04.153" v="10532" actId="1076"/>
+          <ac:chgData name="Joab Kloppers" userId="bcab5db0-8267-4c54-83c3-7ddba1e5c6be" providerId="ADAL" clId="{90E0EE0E-984C-4547-AADC-7DD4534EA015}" dt="2026-06-01T11:39:45.478" v="10584" actId="313"/>
+          <ac:spMkLst>
+            <pc:docMk/>
+            <pc:sldMk cId="643777997" sldId="266"/>
+            <ac:spMk id="2" creationId="{5D030A76-B788-B363-104E-266B7C7F7208}"/>
+          </ac:spMkLst>
+        </pc:spChg>
+        <pc:spChg chg="mod">
+          <ac:chgData name="Joab Kloppers" userId="bcab5db0-8267-4c54-83c3-7ddba1e5c6be" providerId="ADAL" clId="{90E0EE0E-984C-4547-AADC-7DD4534EA015}" dt="2026-06-01T11:40:48.383" v="10718" actId="20577"/>
           <ac:spMkLst>
             <pc:docMk/>
             <pc:sldMk cId="643777997" sldId="266"/>
             <ac:spMk id="3" creationId="{05948542-FCE1-3AE6-C6C9-17975609DF70}"/>
           </ac:spMkLst>
         </pc:spChg>
-        <pc:spChg chg="del mod">
-          <ac:chgData name="Joab Kloppers" userId="bcab5db0-8267-4c54-83c3-7ddba1e5c6be" providerId="ADAL" clId="{90E0EE0E-984C-4547-AADC-7DD4534EA015}" dt="2026-02-21T12:07:57.119" v="10529" actId="478"/>
+        <pc:spChg chg="add mod">
+          <ac:chgData name="Joab Kloppers" userId="bcab5db0-8267-4c54-83c3-7ddba1e5c6be" providerId="ADAL" clId="{90E0EE0E-984C-4547-AADC-7DD4534EA015}" dt="2026-06-01T11:46:15.116" v="11325" actId="6549"/>
           <ac:spMkLst>
             <pc:docMk/>
             <pc:sldMk cId="643777997" sldId="266"/>
-            <ac:spMk id="4" creationId="{3EE67564-0457-E486-97D0-8109D2C97B3F}"/>
+            <ac:spMk id="4" creationId="{3A50BD22-B986-7C11-B7AD-9D8DCCA3BF79}"/>
           </ac:spMkLst>
         </pc:spChg>
-      </pc:sldChg>
-      <pc:sldChg chg="mod modShow">
-        <pc:chgData name="Joab Kloppers" userId="bcab5db0-8267-4c54-83c3-7ddba1e5c6be" providerId="ADAL" clId="{90E0EE0E-984C-4547-AADC-7DD4534EA015}" dt="2026-02-02T07:26:53.099" v="7703" actId="729"/>
-        <pc:sldMkLst>
-          <pc:docMk/>
-          <pc:sldMk cId="3604630649" sldId="267"/>
-        </pc:sldMkLst>
-      </pc:sldChg>
-      <pc:sldChg chg="mod modShow">
-        <pc:chgData name="Joab Kloppers" userId="bcab5db0-8267-4c54-83c3-7ddba1e5c6be" providerId="ADAL" clId="{90E0EE0E-984C-4547-AADC-7DD4534EA015}" dt="2026-02-02T07:26:53.099" v="7703" actId="729"/>
-        <pc:sldMkLst>
-          <pc:docMk/>
-          <pc:sldMk cId="4259977132" sldId="268"/>
-        </pc:sldMkLst>
-      </pc:sldChg>
-      <pc:sldChg chg="modSp mod">
-        <pc:chgData name="Joab Kloppers" userId="bcab5db0-8267-4c54-83c3-7ddba1e5c6be" providerId="ADAL" clId="{90E0EE0E-984C-4547-AADC-7DD4534EA015}" dt="2026-02-04T11:15:20.449" v="7731" actId="20577"/>
-        <pc:sldMkLst>
-          <pc:docMk/>
-          <pc:sldMk cId="855215445" sldId="325"/>
-        </pc:sldMkLst>
-        <pc:spChg chg="mod">
-          <ac:chgData name="Joab Kloppers" userId="bcab5db0-8267-4c54-83c3-7ddba1e5c6be" providerId="ADAL" clId="{90E0EE0E-984C-4547-AADC-7DD4534EA015}" dt="2026-02-04T11:15:20.449" v="7731" actId="20577"/>
-          <ac:spMkLst>
-            <pc:docMk/>
-            <pc:sldMk cId="855215445" sldId="325"/>
-            <ac:spMk id="4" creationId="{305E10E9-9AB7-0642-D4C4-DDFDAB7B5B2C}"/>
-          </ac:spMkLst>
-        </pc:spChg>
-      </pc:sldChg>
-      <pc:sldChg chg="addSp delSp modSp mod modNotesTx">
-        <pc:chgData name="Joab Kloppers" userId="bcab5db0-8267-4c54-83c3-7ddba1e5c6be" providerId="ADAL" clId="{90E0EE0E-984C-4547-AADC-7DD4534EA015}" dt="2026-02-02T07:25:18.742" v="7698" actId="14100"/>
-        <pc:sldMkLst>
-          <pc:docMk/>
-          <pc:sldMk cId="2910866480" sldId="326"/>
-        </pc:sldMkLst>
-        <pc:spChg chg="add mod">
-          <ac:chgData name="Joab Kloppers" userId="bcab5db0-8267-4c54-83c3-7ddba1e5c6be" providerId="ADAL" clId="{90E0EE0E-984C-4547-AADC-7DD4534EA015}" dt="2026-01-27T08:04:46.232" v="3957" actId="1076"/>
-          <ac:spMkLst>
-            <pc:docMk/>
-            <pc:sldMk cId="2910866480" sldId="326"/>
-            <ac:spMk id="9" creationId="{7DB5B9F5-CCD3-E801-9886-CF7A979EA539}"/>
-          </ac:spMkLst>
-        </pc:spChg>
-        <pc:picChg chg="add mod">
-          <ac:chgData name="Joab Kloppers" userId="bcab5db0-8267-4c54-83c3-7ddba1e5c6be" providerId="ADAL" clId="{90E0EE0E-984C-4547-AADC-7DD4534EA015}" dt="2026-02-02T07:25:18.742" v="7698" actId="14100"/>
-          <ac:picMkLst>
-            <pc:docMk/>
-            <pc:sldMk cId="2910866480" sldId="326"/>
-            <ac:picMk id="11" creationId="{E33E74C7-99AB-786E-B042-51476A2C4847}"/>
-          </ac:picMkLst>
-        </pc:picChg>
-      </pc:sldChg>
-      <pc:sldChg chg="mod modShow">
-        <pc:chgData name="Joab Kloppers" userId="bcab5db0-8267-4c54-83c3-7ddba1e5c6be" providerId="ADAL" clId="{90E0EE0E-984C-4547-AADC-7DD4534EA015}" dt="2026-02-02T07:26:53.099" v="7703" actId="729"/>
-        <pc:sldMkLst>
-          <pc:docMk/>
-          <pc:sldMk cId="487522735" sldId="340"/>
-        </pc:sldMkLst>
-      </pc:sldChg>
-      <pc:sldChg chg="addSp delSp modSp add mod modNotesTx">
-        <pc:chgData name="Joab Kloppers" userId="bcab5db0-8267-4c54-83c3-7ddba1e5c6be" providerId="ADAL" clId="{90E0EE0E-984C-4547-AADC-7DD4534EA015}" dt="2026-02-10T20:38:11.141" v="10355" actId="20577"/>
-        <pc:sldMkLst>
-          <pc:docMk/>
-          <pc:sldMk cId="3134398988" sldId="341"/>
-        </pc:sldMkLst>
-        <pc:spChg chg="mod">
-          <ac:chgData name="Joab Kloppers" userId="bcab5db0-8267-4c54-83c3-7ddba1e5c6be" providerId="ADAL" clId="{90E0EE0E-984C-4547-AADC-7DD4534EA015}" dt="2026-02-10T20:16:21.670" v="9408" actId="20577"/>
-          <ac:spMkLst>
-            <pc:docMk/>
-            <pc:sldMk cId="3134398988" sldId="341"/>
-            <ac:spMk id="2" creationId="{1C5EDC56-2648-71A0-B020-497F2AC0BCD2}"/>
-          </ac:spMkLst>
-        </pc:spChg>
-        <pc:spChg chg="add mod">
-          <ac:chgData name="Joab Kloppers" userId="bcab5db0-8267-4c54-83c3-7ddba1e5c6be" providerId="ADAL" clId="{90E0EE0E-984C-4547-AADC-7DD4534EA015}" dt="2026-02-10T20:26:03.038" v="9590" actId="1076"/>
-          <ac:spMkLst>
-            <pc:docMk/>
-            <pc:sldMk cId="3134398988" sldId="341"/>
-            <ac:spMk id="17" creationId="{694880DF-1471-C70C-BFFF-679A07071A7B}"/>
-          </ac:spMkLst>
-        </pc:spChg>
-        <pc:spChg chg="add mod">
-          <ac:chgData name="Joab Kloppers" userId="bcab5db0-8267-4c54-83c3-7ddba1e5c6be" providerId="ADAL" clId="{90E0EE0E-984C-4547-AADC-7DD4534EA015}" dt="2026-02-10T20:21:58.655" v="9487" actId="1076"/>
-          <ac:spMkLst>
-            <pc:docMk/>
-            <pc:sldMk cId="3134398988" sldId="341"/>
-            <ac:spMk id="18" creationId="{6AB63C6C-E21F-49A8-2DF3-799952C932C0}"/>
-          </ac:spMkLst>
-        </pc:spChg>
-        <pc:spChg chg="add mod">
-          <ac:chgData name="Joab Kloppers" userId="bcab5db0-8267-4c54-83c3-7ddba1e5c6be" providerId="ADAL" clId="{90E0EE0E-984C-4547-AADC-7DD4534EA015}" dt="2026-02-10T20:23:19.893" v="9514" actId="1076"/>
-          <ac:spMkLst>
-            <pc:docMk/>
-            <pc:sldMk cId="3134398988" sldId="341"/>
-            <ac:spMk id="21" creationId="{B7946254-962A-CE33-7F2D-B9E3052CCB5C}"/>
-          </ac:spMkLst>
-        </pc:spChg>
-        <pc:spChg chg="add mod">
-          <ac:chgData name="Joab Kloppers" userId="bcab5db0-8267-4c54-83c3-7ddba1e5c6be" providerId="ADAL" clId="{90E0EE0E-984C-4547-AADC-7DD4534EA015}" dt="2026-02-10T20:26:12.801" v="9592" actId="1076"/>
-          <ac:spMkLst>
-            <pc:docMk/>
-            <pc:sldMk cId="3134398988" sldId="341"/>
-            <ac:spMk id="27" creationId="{E4C15B5D-90BA-CC39-68FC-5F992FFFF42F}"/>
-          </ac:spMkLst>
-        </pc:spChg>
-        <pc:spChg chg="mod">
-          <ac:chgData name="Joab Kloppers" userId="bcab5db0-8267-4c54-83c3-7ddba1e5c6be" providerId="ADAL" clId="{90E0EE0E-984C-4547-AADC-7DD4534EA015}" dt="2026-02-10T20:30:48.776" v="9696" actId="20577"/>
-          <ac:spMkLst>
-            <pc:docMk/>
-            <pc:sldMk cId="3134398988" sldId="341"/>
-            <ac:spMk id="38" creationId="{A2A16A3E-4296-0FC3-C911-74084EADC242}"/>
-          </ac:spMkLst>
-        </pc:spChg>
-        <pc:spChg chg="add mod">
-          <ac:chgData name="Joab Kloppers" userId="bcab5db0-8267-4c54-83c3-7ddba1e5c6be" providerId="ADAL" clId="{90E0EE0E-984C-4547-AADC-7DD4534EA015}" dt="2026-02-10T20:25:54.365" v="9588" actId="1076"/>
-          <ac:spMkLst>
-            <pc:docMk/>
-            <pc:sldMk cId="3134398988" sldId="341"/>
-            <ac:spMk id="39" creationId="{0B297A23-99FD-8358-4EB9-0490A0B62C1A}"/>
-          </ac:spMkLst>
-        </pc:spChg>
-        <pc:spChg chg="add mod">
-          <ac:chgData name="Joab Kloppers" userId="bcab5db0-8267-4c54-83c3-7ddba1e5c6be" providerId="ADAL" clId="{90E0EE0E-984C-4547-AADC-7DD4534EA015}" dt="2026-02-10T20:27:25.238" v="9624" actId="1076"/>
-          <ac:spMkLst>
-            <pc:docMk/>
-            <pc:sldMk cId="3134398988" sldId="341"/>
-            <ac:spMk id="45" creationId="{FEDBE1A9-6BB6-F83E-DF79-4E7B6300DEF9}"/>
-          </ac:spMkLst>
-        </pc:spChg>
-        <pc:picChg chg="add mod">
-          <ac:chgData name="Joab Kloppers" userId="bcab5db0-8267-4c54-83c3-7ddba1e5c6be" providerId="ADAL" clId="{90E0EE0E-984C-4547-AADC-7DD4534EA015}" dt="2026-02-10T20:18:59.099" v="9418" actId="14100"/>
-          <ac:picMkLst>
-            <pc:docMk/>
-            <pc:sldMk cId="3134398988" sldId="341"/>
-            <ac:picMk id="6" creationId="{C1AB545E-CBBA-0DBC-0D83-4B26E860A3E9}"/>
-          </ac:picMkLst>
-        </pc:picChg>
-        <pc:picChg chg="add mod">
-          <ac:chgData name="Joab Kloppers" userId="bcab5db0-8267-4c54-83c3-7ddba1e5c6be" providerId="ADAL" clId="{90E0EE0E-984C-4547-AADC-7DD4534EA015}" dt="2026-02-10T20:29:23.568" v="9631" actId="1076"/>
-          <ac:picMkLst>
-            <pc:docMk/>
-            <pc:sldMk cId="3134398988" sldId="341"/>
-            <ac:picMk id="47" creationId="{342DB476-F6D3-B436-CA45-AE24E63DD302}"/>
-          </ac:picMkLst>
-        </pc:picChg>
-        <pc:cxnChg chg="add mod">
-          <ac:chgData name="Joab Kloppers" userId="bcab5db0-8267-4c54-83c3-7ddba1e5c6be" providerId="ADAL" clId="{90E0EE0E-984C-4547-AADC-7DD4534EA015}" dt="2026-02-10T20:26:00.529" v="9589" actId="14100"/>
-          <ac:cxnSpMkLst>
-            <pc:docMk/>
-            <pc:sldMk cId="3134398988" sldId="341"/>
-            <ac:cxnSpMk id="8" creationId="{B88CD4C8-7545-7C82-9810-545F301BB4A3}"/>
-          </ac:cxnSpMkLst>
-        </pc:cxnChg>
-        <pc:cxnChg chg="add mod">
-          <ac:chgData name="Joab Kloppers" userId="bcab5db0-8267-4c54-83c3-7ddba1e5c6be" providerId="ADAL" clId="{90E0EE0E-984C-4547-AADC-7DD4534EA015}" dt="2026-02-10T20:20:52.701" v="9436" actId="13822"/>
-          <ac:cxnSpMkLst>
-            <pc:docMk/>
-            <pc:sldMk cId="3134398988" sldId="341"/>
-            <ac:cxnSpMk id="13" creationId="{CB231952-3BDE-C96E-2D97-8104C17D7CB9}"/>
-          </ac:cxnSpMkLst>
-        </pc:cxnChg>
-        <pc:cxnChg chg="add mod">
-          <ac:chgData name="Joab Kloppers" userId="bcab5db0-8267-4c54-83c3-7ddba1e5c6be" providerId="ADAL" clId="{90E0EE0E-984C-4547-AADC-7DD4534EA015}" dt="2026-02-10T20:21:00.828" v="9438" actId="13822"/>
-          <ac:cxnSpMkLst>
-            <pc:docMk/>
-            <pc:sldMk cId="3134398988" sldId="341"/>
-            <ac:cxnSpMk id="15" creationId="{A62BABF9-266B-6777-6C16-EDBBF8066092}"/>
-          </ac:cxnSpMkLst>
-        </pc:cxnChg>
-        <pc:cxnChg chg="add mod">
-          <ac:chgData name="Joab Kloppers" userId="bcab5db0-8267-4c54-83c3-7ddba1e5c6be" providerId="ADAL" clId="{90E0EE0E-984C-4547-AADC-7DD4534EA015}" dt="2026-02-10T20:22:23.027" v="9490" actId="13822"/>
-          <ac:cxnSpMkLst>
-            <pc:docMk/>
-            <pc:sldMk cId="3134398988" sldId="341"/>
-            <ac:cxnSpMk id="20" creationId="{92F2A379-D195-021E-7225-7EB9A36A7B5B}"/>
-          </ac:cxnSpMkLst>
-        </pc:cxnChg>
-        <pc:cxnChg chg="add mod">
-          <ac:chgData name="Joab Kloppers" userId="bcab5db0-8267-4c54-83c3-7ddba1e5c6be" providerId="ADAL" clId="{90E0EE0E-984C-4547-AADC-7DD4534EA015}" dt="2026-02-10T20:26:09.058" v="9591" actId="14100"/>
-          <ac:cxnSpMkLst>
-            <pc:docMk/>
-            <pc:sldMk cId="3134398988" sldId="341"/>
-            <ac:cxnSpMk id="26" creationId="{17DA7481-E0B5-8D0B-8B62-8F1CA411F6C8}"/>
-          </ac:cxnSpMkLst>
-        </pc:cxnChg>
-        <pc:cxnChg chg="add mod">
-          <ac:chgData name="Joab Kloppers" userId="bcab5db0-8267-4c54-83c3-7ddba1e5c6be" providerId="ADAL" clId="{90E0EE0E-984C-4547-AADC-7DD4534EA015}" dt="2026-02-10T20:25:48.333" v="9587" actId="14100"/>
-          <ac:cxnSpMkLst>
-            <pc:docMk/>
-            <pc:sldMk cId="3134398988" sldId="341"/>
-            <ac:cxnSpMk id="36" creationId="{CC973BE6-3859-F65A-40C9-8C52D8671503}"/>
-          </ac:cxnSpMkLst>
-        </pc:cxnChg>
-        <pc:cxnChg chg="mod ord">
-          <ac:chgData name="Joab Kloppers" userId="bcab5db0-8267-4c54-83c3-7ddba1e5c6be" providerId="ADAL" clId="{90E0EE0E-984C-4547-AADC-7DD4534EA015}" dt="2026-02-10T20:29:36.959" v="9633" actId="14100"/>
-          <ac:cxnSpMkLst>
-            <pc:docMk/>
-            <pc:sldMk cId="3134398988" sldId="341"/>
-            <ac:cxnSpMk id="37" creationId="{BF184665-63BF-AFC8-777F-A85949981183}"/>
-          </ac:cxnSpMkLst>
-        </pc:cxnChg>
-        <pc:cxnChg chg="add mod">
-          <ac:chgData name="Joab Kloppers" userId="bcab5db0-8267-4c54-83c3-7ddba1e5c6be" providerId="ADAL" clId="{90E0EE0E-984C-4547-AADC-7DD4534EA015}" dt="2026-02-10T20:26:49.406" v="9594" actId="13822"/>
-          <ac:cxnSpMkLst>
-            <pc:docMk/>
-            <pc:sldMk cId="3134398988" sldId="341"/>
-            <ac:cxnSpMk id="44" creationId="{68984215-6ACC-7C6C-449D-3AFFBDE196C8}"/>
-          </ac:cxnSpMkLst>
-        </pc:cxnChg>
       </pc:sldChg>
     </pc:docChg>
   </pc:docChgLst>
@@ -2214,6 +1851,7 @@
   <dgm:desc val=""/>
   <dgm:catLst>
     <dgm:cat type="process" pri="8000"/>
+    <dgm:cat type="timeline" pri="103"/>
     <dgm:cat type="convert" pri="14000"/>
   </dgm:catLst>
   <dgm:sampData useDef="1">
@@ -3608,7 +3246,7 @@
           <a:p>
             <a:fld id="{7FF95820-84BB-3447-8286-60A51307E7F2}" type="datetimeFigureOut">
               <a:rPr lang="en-US" smtClean="0"/>
-              <a:t>2/21/2026</a:t>
+              <a:t>6/1/2026</a:t>
             </a:fld>
             <a:endParaRPr lang="en-US" dirty="0"/>
           </a:p>
@@ -3786,7 +3424,7 @@
           <a:p>
             <a:fld id="{FC08FC54-6AE4-6A4A-9756-823A0F1BE5A6}" type="datetimeFigureOut">
               <a:rPr lang="en-US" smtClean="0"/>
-              <a:t>2/21/2026</a:t>
+              <a:t>6/1/2026</a:t>
             </a:fld>
             <a:endParaRPr lang="en-US" dirty="0"/>
           </a:p>
@@ -12273,7 +11911,7 @@
           <a:p>
             <a:r>
               <a:rPr lang="en-US" dirty="0"/>
-              <a:t>Summary</a:t>
+              <a:t>Summary &amp; Future Improvements</a:t>
             </a:r>
           </a:p>
         </p:txBody>
@@ -12296,7 +11934,7 @@
         </p:nvSpPr>
         <p:spPr>
           <a:xfrm>
-            <a:off x="3512997" y="2419970"/>
+            <a:off x="1280160" y="2419970"/>
             <a:ext cx="4663440" cy="3566160"/>
           </a:xfrm>
           <a:solidFill>
@@ -12311,7 +11949,13 @@
           <a:p>
             <a:r>
               <a:rPr lang="en-US" dirty="0"/>
-              <a:t>O-ring provides sufficient seals</a:t>
+              <a:t>Silicone O-Ring Used to Seal Lid</a:t>
+            </a:r>
+          </a:p>
+          <a:p>
+            <a:r>
+              <a:rPr lang="en-US" dirty="0"/>
+              <a:t>Silicone Gasket Used to Seal Base</a:t>
             </a:r>
           </a:p>
           <a:p>
@@ -12329,7 +11973,252 @@
           <a:p>
             <a:r>
               <a:rPr lang="en-US" dirty="0"/>
-              <a:t>Unobstructed viewing from bottom</a:t>
+              <a:t>Unobstructed viewing from Top and Bottom</a:t>
+            </a:r>
+          </a:p>
+        </p:txBody>
+      </p:sp>
+      <p:sp>
+        <p:nvSpPr>
+          <p:cNvPr id="4" name="Content Placeholder 2">
+            <a:extLst>
+              <a:ext uri="{FF2B5EF4-FFF2-40B4-BE49-F238E27FC236}">
+                <a16:creationId xmlns:a16="http://schemas.microsoft.com/office/drawing/2014/main" id="{3A50BD22-B986-7C11-B7AD-9D8DCCA3BF79}"/>
+              </a:ext>
+            </a:extLst>
+          </p:cNvPr>
+          <p:cNvSpPr txBox="1">
+            <a:spLocks/>
+          </p:cNvSpPr>
+          <p:nvPr/>
+        </p:nvSpPr>
+        <p:spPr>
+          <a:xfrm>
+            <a:off x="6597948" y="2419970"/>
+            <a:ext cx="4663440" cy="3566160"/>
+          </a:xfrm>
+          <a:prstGeom prst="rect">
+            <a:avLst/>
+          </a:prstGeom>
+          <a:solidFill>
+            <a:schemeClr val="accent4"/>
+          </a:solidFill>
+        </p:spPr>
+        <p:txBody>
+          <a:bodyPr vert="horz" lIns="365760" tIns="365760" rIns="365760" bIns="365760" rtlCol="0" anchor="t">
+            <a:normAutofit/>
+          </a:bodyPr>
+          <a:lstStyle>
+            <a:lvl1pPr marL="457200" indent="-457200" algn="l" defTabSz="914400" rtl="0" eaLnBrk="1" latinLnBrk="0" hangingPunct="1">
+              <a:lnSpc>
+                <a:spcPct val="100000"/>
+              </a:lnSpc>
+              <a:spcBef>
+                <a:spcPts val="1400"/>
+              </a:spcBef>
+              <a:buClr>
+                <a:schemeClr val="tx1"/>
+              </a:buClr>
+              <a:buSzPct val="80000"/>
+              <a:buFont typeface="Courier New" panose="02070309020205020404" pitchFamily="49" charset="0"/>
+              <a:buChar char="o"/>
+              <a:defRPr sz="1800" b="0" i="0" kern="1200" cap="none" baseline="0">
+                <a:solidFill>
+                  <a:schemeClr val="tx1"/>
+                </a:solidFill>
+                <a:latin typeface="+mn-lt"/>
+                <a:ea typeface="+mn-ea"/>
+                <a:cs typeface="+mn-cs"/>
+              </a:defRPr>
+            </a:lvl1pPr>
+            <a:lvl2pPr marL="914400" indent="-457200" algn="l" defTabSz="914400" rtl="0" eaLnBrk="1" latinLnBrk="0" hangingPunct="1">
+              <a:lnSpc>
+                <a:spcPct val="100000"/>
+              </a:lnSpc>
+              <a:spcBef>
+                <a:spcPts val="500"/>
+              </a:spcBef>
+              <a:buClr>
+                <a:schemeClr val="tx1"/>
+              </a:buClr>
+              <a:buSzPct val="80000"/>
+              <a:buFont typeface="Courier New" panose="02070309020205020404" pitchFamily="49" charset="0"/>
+              <a:buChar char="o"/>
+              <a:defRPr sz="1600" b="0" i="0" kern="1200" baseline="0">
+                <a:solidFill>
+                  <a:schemeClr val="tx1"/>
+                </a:solidFill>
+                <a:latin typeface="+mn-lt"/>
+                <a:ea typeface="+mn-ea"/>
+                <a:cs typeface="+mn-cs"/>
+              </a:defRPr>
+            </a:lvl2pPr>
+            <a:lvl3pPr marL="1371600" indent="-457200" algn="l" defTabSz="914400" rtl="0" eaLnBrk="1" latinLnBrk="0" hangingPunct="1">
+              <a:lnSpc>
+                <a:spcPct val="100000"/>
+              </a:lnSpc>
+              <a:spcBef>
+                <a:spcPts val="500"/>
+              </a:spcBef>
+              <a:buClr>
+                <a:schemeClr val="tx1"/>
+              </a:buClr>
+              <a:buSzPct val="80000"/>
+              <a:buFont typeface="Courier New" panose="02070309020205020404" pitchFamily="49" charset="0"/>
+              <a:buChar char="o"/>
+              <a:defRPr sz="1400" b="0" i="0" kern="1200" baseline="0">
+                <a:solidFill>
+                  <a:schemeClr val="tx1"/>
+                </a:solidFill>
+                <a:latin typeface="+mn-lt"/>
+                <a:ea typeface="+mn-ea"/>
+                <a:cs typeface="+mn-cs"/>
+              </a:defRPr>
+            </a:lvl3pPr>
+            <a:lvl4pPr marL="1828800" indent="-457200" algn="l" defTabSz="914400" rtl="0" eaLnBrk="1" latinLnBrk="0" hangingPunct="1">
+              <a:lnSpc>
+                <a:spcPct val="100000"/>
+              </a:lnSpc>
+              <a:spcBef>
+                <a:spcPts val="500"/>
+              </a:spcBef>
+              <a:buClr>
+                <a:schemeClr val="tx1"/>
+              </a:buClr>
+              <a:buSzPct val="80000"/>
+              <a:buFont typeface="Courier New" panose="02070309020205020404" pitchFamily="49" charset="0"/>
+              <a:buChar char="o"/>
+              <a:defRPr sz="1200" b="0" i="0" kern="1200" baseline="0">
+                <a:solidFill>
+                  <a:schemeClr val="tx1"/>
+                </a:solidFill>
+                <a:latin typeface="+mn-lt"/>
+                <a:ea typeface="+mn-ea"/>
+                <a:cs typeface="+mn-cs"/>
+              </a:defRPr>
+            </a:lvl4pPr>
+            <a:lvl5pPr marL="2286000" indent="-457200" algn="l" defTabSz="914400" rtl="0" eaLnBrk="1" latinLnBrk="0" hangingPunct="1">
+              <a:lnSpc>
+                <a:spcPct val="100000"/>
+              </a:lnSpc>
+              <a:spcBef>
+                <a:spcPts val="500"/>
+              </a:spcBef>
+              <a:buClr>
+                <a:schemeClr val="tx1"/>
+              </a:buClr>
+              <a:buSzPct val="80000"/>
+              <a:buFont typeface="Courier New" panose="02070309020205020404" pitchFamily="49" charset="0"/>
+              <a:buChar char="o"/>
+              <a:defRPr sz="1100" b="0" i="0" kern="1200" baseline="0">
+                <a:solidFill>
+                  <a:schemeClr val="tx1"/>
+                </a:solidFill>
+                <a:latin typeface="+mn-lt"/>
+                <a:ea typeface="+mn-ea"/>
+                <a:cs typeface="+mn-cs"/>
+              </a:defRPr>
+            </a:lvl5pPr>
+            <a:lvl6pPr marL="2514600" indent="-228600" algn="l" defTabSz="914400" rtl="0" eaLnBrk="1" latinLnBrk="0" hangingPunct="1">
+              <a:lnSpc>
+                <a:spcPct val="90000"/>
+              </a:lnSpc>
+              <a:spcBef>
+                <a:spcPts val="500"/>
+              </a:spcBef>
+              <a:buFont typeface="Arial" panose="020B0604020202020204" pitchFamily="34" charset="0"/>
+              <a:buChar char="•"/>
+              <a:defRPr sz="1800" kern="1200">
+                <a:solidFill>
+                  <a:schemeClr val="tx1"/>
+                </a:solidFill>
+                <a:latin typeface="+mn-lt"/>
+                <a:ea typeface="+mn-ea"/>
+                <a:cs typeface="+mn-cs"/>
+              </a:defRPr>
+            </a:lvl6pPr>
+            <a:lvl7pPr marL="2971800" indent="-228600" algn="l" defTabSz="914400" rtl="0" eaLnBrk="1" latinLnBrk="0" hangingPunct="1">
+              <a:lnSpc>
+                <a:spcPct val="90000"/>
+              </a:lnSpc>
+              <a:spcBef>
+                <a:spcPts val="500"/>
+              </a:spcBef>
+              <a:buFont typeface="Arial" panose="020B0604020202020204" pitchFamily="34" charset="0"/>
+              <a:buChar char="•"/>
+              <a:defRPr sz="1800" kern="1200">
+                <a:solidFill>
+                  <a:schemeClr val="tx1"/>
+                </a:solidFill>
+                <a:latin typeface="+mn-lt"/>
+                <a:ea typeface="+mn-ea"/>
+                <a:cs typeface="+mn-cs"/>
+              </a:defRPr>
+            </a:lvl7pPr>
+            <a:lvl8pPr marL="3429000" indent="-228600" algn="l" defTabSz="914400" rtl="0" eaLnBrk="1" latinLnBrk="0" hangingPunct="1">
+              <a:lnSpc>
+                <a:spcPct val="90000"/>
+              </a:lnSpc>
+              <a:spcBef>
+                <a:spcPts val="500"/>
+              </a:spcBef>
+              <a:buFont typeface="Arial" panose="020B0604020202020204" pitchFamily="34" charset="0"/>
+              <a:buChar char="•"/>
+              <a:defRPr sz="1800" kern="1200">
+                <a:solidFill>
+                  <a:schemeClr val="tx1"/>
+                </a:solidFill>
+                <a:latin typeface="+mn-lt"/>
+                <a:ea typeface="+mn-ea"/>
+                <a:cs typeface="+mn-cs"/>
+              </a:defRPr>
+            </a:lvl8pPr>
+            <a:lvl9pPr marL="3886200" indent="-228600" algn="l" defTabSz="914400" rtl="0" eaLnBrk="1" latinLnBrk="0" hangingPunct="1">
+              <a:lnSpc>
+                <a:spcPct val="90000"/>
+              </a:lnSpc>
+              <a:spcBef>
+                <a:spcPts val="500"/>
+              </a:spcBef>
+              <a:buFont typeface="Arial" panose="020B0604020202020204" pitchFamily="34" charset="0"/>
+              <a:buChar char="•"/>
+              <a:defRPr sz="1800" kern="1200">
+                <a:solidFill>
+                  <a:schemeClr val="tx1"/>
+                </a:solidFill>
+                <a:latin typeface="+mn-lt"/>
+                <a:ea typeface="+mn-ea"/>
+                <a:cs typeface="+mn-cs"/>
+              </a:defRPr>
+            </a:lvl9pPr>
+          </a:lstStyle>
+          <a:p>
+            <a:r>
+              <a:rPr lang="en-US" dirty="0"/>
+              <a:t>Screw Mounting Tedious, and Supply Insufficient Mounting Pressure</a:t>
+            </a:r>
+          </a:p>
+          <a:p>
+            <a:r>
+              <a:rPr lang="en-US" dirty="0"/>
+              <a:t>New Mechanism to Apply pressure to Multi-Well Plate</a:t>
+            </a:r>
+          </a:p>
+          <a:p>
+            <a:r>
+              <a:rPr lang="en-US" dirty="0"/>
+              <a:t>Two Sealant </a:t>
+            </a:r>
+            <a:r>
+              <a:rPr lang="en-US"/>
+              <a:t>Mechanisms Sub-Optimal</a:t>
+            </a:r>
+            <a:endParaRPr lang="en-US" dirty="0"/>
+          </a:p>
+          <a:p>
+            <a:r>
+              <a:rPr lang="en-US" dirty="0"/>
+              <a:t>Provisions for Gas and Temperature Control</a:t>
             </a:r>
           </a:p>
         </p:txBody>
@@ -13801,15 +13690,6 @@
 </file>
 
 <file path=customXml/item2.xml><?xml version="1.0" encoding="utf-8"?>
-<?mso-contentType ?>
-<FormTemplates xmlns="http://schemas.microsoft.com/sharepoint/v3/contenttype/forms">
-  <Display>DocumentLibraryForm</Display>
-  <Edit>DocumentLibraryForm</Edit>
-  <New>DocumentLibraryForm</New>
-</FormTemplates>
-</file>
-
-<file path=customXml/item3.xml><?xml version="1.0" encoding="utf-8"?>
 <p:properties xmlns:p="http://schemas.microsoft.com/office/2006/metadata/properties" xmlns:xsi="http://www.w3.org/2001/XMLSchema-instance" xmlns:pc="http://schemas.microsoft.com/office/infopath/2007/PartnerControls">
   <documentManagement>
     <_ip_UnifiedCompliancePolicyUIAction xmlns="http://schemas.microsoft.com/sharepoint/v3" xsi:nil="true"/>
@@ -13827,6 +13707,15 @@
     <MediaServiceKeyPoints xmlns="71af3243-3dd4-4a8d-8c0d-dd76da1f02a5" xsi:nil="true"/>
   </documentManagement>
 </p:properties>
+</file>
+
+<file path=customXml/item3.xml><?xml version="1.0" encoding="utf-8"?>
+<?mso-contentType ?>
+<FormTemplates xmlns="http://schemas.microsoft.com/sharepoint/v3/contenttype/forms">
+  <Display>DocumentLibraryForm</Display>
+  <Edit>DocumentLibraryForm</Edit>
+  <New>DocumentLibraryForm</New>
+</FormTemplates>
 </file>
 
 <file path=customXml/itemProps1.xml><?xml version="1.0" encoding="utf-8"?>
@@ -13851,14 +13740,6 @@
 </file>
 
 <file path=customXml/itemProps2.xml><?xml version="1.0" encoding="utf-8"?>
-<ds:datastoreItem xmlns:ds="http://schemas.openxmlformats.org/officeDocument/2006/customXml" ds:itemID="{DF8397A0-8C35-4EEE-8E61-47C914415B57}">
-  <ds:schemaRefs>
-    <ds:schemaRef ds:uri="http://schemas.microsoft.com/sharepoint/v3/contenttype/forms"/>
-  </ds:schemaRefs>
-</ds:datastoreItem>
-</file>
-
-<file path=customXml/itemProps3.xml><?xml version="1.0" encoding="utf-8"?>
 <ds:datastoreItem xmlns:ds="http://schemas.openxmlformats.org/officeDocument/2006/customXml" ds:itemID="{B881D8D6-8849-400B-8BC9-21D401C7DD06}">
   <ds:schemaRefs>
     <ds:schemaRef ds:uri="http://schemas.microsoft.com/office/2006/metadata/properties"/>
@@ -13870,6 +13751,14 @@
 </ds:datastoreItem>
 </file>
 
+<file path=customXml/itemProps3.xml><?xml version="1.0" encoding="utf-8"?>
+<ds:datastoreItem xmlns:ds="http://schemas.openxmlformats.org/officeDocument/2006/customXml" ds:itemID="{DF8397A0-8C35-4EEE-8E61-47C914415B57}">
+  <ds:schemaRefs>
+    <ds:schemaRef ds:uri="http://schemas.microsoft.com/sharepoint/v3/contenttype/forms"/>
+  </ds:schemaRefs>
+</ds:datastoreItem>
+</file>
+
 <file path=docMetadata/LabelInfo.xml><?xml version="1.0" encoding="utf-8"?>
 <clbl:labelList xmlns:clbl="http://schemas.microsoft.com/office/2020/mipLabelMetadata"/>
 </file>
</xml_diff>